<commit_message>
[doc] update BJData marker diagram
</commit_message>
<xml_diff>
--- a/images/BJData_Diagram.pptx
+++ b/images/BJData_Diagram.pptx
@@ -1,11 +1,11 @@
 
 <file path=ppt/presentation.xml><?xml version="1.0" encoding="utf-8"?>
-<p:presentation xmlns:a="http://schemas.openxmlformats.org/drawingml/2006/main" xmlns:r="http://schemas.openxmlformats.org/officeDocument/2006/relationships" xmlns:p="http://schemas.openxmlformats.org/presentationml/2006/main" saveSubsetFonts="1">
+<p:presentation xmlns:a="http://schemas.openxmlformats.org/drawingml/2006/main" xmlns:r="http://schemas.openxmlformats.org/officeDocument/2006/relationships" xmlns:p="http://schemas.openxmlformats.org/presentationml/2006/main">
   <p:sldMasterIdLst>
     <p:sldMasterId id="2147483648" r:id="rId1"/>
   </p:sldMasterIdLst>
   <p:sldIdLst>
-    <p:sldId id="256" r:id="rId2"/>
+    <p:sldId id="256" r:id="rId3"/>
   </p:sldIdLst>
   <p:sldSz cx="9144000" cy="6858000" type="screen4x3"/>
   <p:notesSz cx="6858000" cy="9144000"/>
@@ -104,22 +104,6 @@
       </a:defRPr>
     </a:lvl9pPr>
   </p:defaultTextStyle>
-  <p:extLst>
-    <p:ext uri="{EFAFB233-063F-42B5-8137-9DF3F51BA10A}">
-      <p15:sldGuideLst xmlns:p15="http://schemas.microsoft.com/office/powerpoint/2012/main">
-        <p15:guide id="1" orient="horz" pos="2160">
-          <p15:clr>
-            <a:srgbClr val="A4A3A4"/>
-          </p15:clr>
-        </p15:guide>
-        <p15:guide id="2" pos="2880">
-          <p15:clr>
-            <a:srgbClr val="A4A3A4"/>
-          </p15:clr>
-        </p15:guide>
-      </p15:sldGuideLst>
-    </p:ext>
-  </p:extLst>
 </p:presentation>
 </file>
 
@@ -164,6 +148,7 @@
               <a:rPr lang="en-US"/>
               <a:t>Click to edit Master title style</a:t>
             </a:r>
+            <a:endParaRPr lang="en-US"/>
           </a:p>
         </p:txBody>
       </p:sp>
@@ -282,6 +267,7 @@
               <a:rPr lang="en-US"/>
               <a:t>Click to edit Master subtitle style</a:t>
             </a:r>
+            <a:endParaRPr lang="en-US"/>
           </a:p>
         </p:txBody>
       </p:sp>
@@ -302,7 +288,6 @@
           <a:p>
             <a:fld id="{CDC85A0B-4DEE-4BD6-AE5A-B582637D85F0}" type="datetimeFigureOut">
               <a:rPr lang="en-US" smtClean="0"/>
-              <a:t>2/22/2025</a:t>
             </a:fld>
             <a:endParaRPr lang="en-US"/>
           </a:p>
@@ -344,18 +329,12 @@
           <a:p>
             <a:fld id="{92575AC0-47D5-4858-B9F2-8194FF11ECF9}" type="slidenum">
               <a:rPr lang="en-US" smtClean="0"/>
-              <a:t>‹#›</a:t>
             </a:fld>
             <a:endParaRPr lang="en-US"/>
           </a:p>
         </p:txBody>
       </p:sp>
     </p:spTree>
-    <p:extLst>
-      <p:ext uri="{BB962C8B-B14F-4D97-AF65-F5344CB8AC3E}">
-        <p14:creationId xmlns:p14="http://schemas.microsoft.com/office/powerpoint/2010/main" val="2499175786"/>
-      </p:ext>
-    </p:extLst>
   </p:cSld>
   <p:clrMapOvr>
     <a:masterClrMapping/>
@@ -399,6 +378,7 @@
               <a:rPr lang="en-US"/>
               <a:t>Click to edit Master title style</a:t>
             </a:r>
+            <a:endParaRPr lang="en-US"/>
           </a:p>
         </p:txBody>
       </p:sp>
@@ -422,6 +402,7 @@
               <a:rPr lang="en-US"/>
               <a:t>Click to edit Master text styles</a:t>
             </a:r>
+            <a:endParaRPr lang="en-US"/>
           </a:p>
           <a:p>
             <a:pPr lvl="1"/>
@@ -429,6 +410,7 @@
               <a:rPr lang="en-US"/>
               <a:t>Second level</a:t>
             </a:r>
+            <a:endParaRPr lang="en-US"/>
           </a:p>
           <a:p>
             <a:pPr lvl="2"/>
@@ -436,6 +418,7 @@
               <a:rPr lang="en-US"/>
               <a:t>Third level</a:t>
             </a:r>
+            <a:endParaRPr lang="en-US"/>
           </a:p>
           <a:p>
             <a:pPr lvl="3"/>
@@ -443,6 +426,7 @@
               <a:rPr lang="en-US"/>
               <a:t>Fourth level</a:t>
             </a:r>
+            <a:endParaRPr lang="en-US"/>
           </a:p>
           <a:p>
             <a:pPr lvl="4"/>
@@ -450,6 +434,7 @@
               <a:rPr lang="en-US"/>
               <a:t>Fifth level</a:t>
             </a:r>
+            <a:endParaRPr lang="en-US"/>
           </a:p>
         </p:txBody>
       </p:sp>
@@ -470,7 +455,6 @@
           <a:p>
             <a:fld id="{CDC85A0B-4DEE-4BD6-AE5A-B582637D85F0}" type="datetimeFigureOut">
               <a:rPr lang="en-US" smtClean="0"/>
-              <a:t>2/22/2025</a:t>
             </a:fld>
             <a:endParaRPr lang="en-US"/>
           </a:p>
@@ -512,18 +496,12 @@
           <a:p>
             <a:fld id="{92575AC0-47D5-4858-B9F2-8194FF11ECF9}" type="slidenum">
               <a:rPr lang="en-US" smtClean="0"/>
-              <a:t>‹#›</a:t>
             </a:fld>
             <a:endParaRPr lang="en-US"/>
           </a:p>
         </p:txBody>
       </p:sp>
     </p:spTree>
-    <p:extLst>
-      <p:ext uri="{BB962C8B-B14F-4D97-AF65-F5344CB8AC3E}">
-        <p14:creationId xmlns:p14="http://schemas.microsoft.com/office/powerpoint/2010/main" val="3301818250"/>
-      </p:ext>
-    </p:extLst>
   </p:cSld>
   <p:clrMapOvr>
     <a:masterClrMapping/>
@@ -572,6 +550,7 @@
               <a:rPr lang="en-US"/>
               <a:t>Click to edit Master title style</a:t>
             </a:r>
+            <a:endParaRPr lang="en-US"/>
           </a:p>
         </p:txBody>
       </p:sp>
@@ -600,6 +579,7 @@
               <a:rPr lang="en-US"/>
               <a:t>Click to edit Master text styles</a:t>
             </a:r>
+            <a:endParaRPr lang="en-US"/>
           </a:p>
           <a:p>
             <a:pPr lvl="1"/>
@@ -607,6 +587,7 @@
               <a:rPr lang="en-US"/>
               <a:t>Second level</a:t>
             </a:r>
+            <a:endParaRPr lang="en-US"/>
           </a:p>
           <a:p>
             <a:pPr lvl="2"/>
@@ -614,6 +595,7 @@
               <a:rPr lang="en-US"/>
               <a:t>Third level</a:t>
             </a:r>
+            <a:endParaRPr lang="en-US"/>
           </a:p>
           <a:p>
             <a:pPr lvl="3"/>
@@ -621,6 +603,7 @@
               <a:rPr lang="en-US"/>
               <a:t>Fourth level</a:t>
             </a:r>
+            <a:endParaRPr lang="en-US"/>
           </a:p>
           <a:p>
             <a:pPr lvl="4"/>
@@ -628,6 +611,7 @@
               <a:rPr lang="en-US"/>
               <a:t>Fifth level</a:t>
             </a:r>
+            <a:endParaRPr lang="en-US"/>
           </a:p>
         </p:txBody>
       </p:sp>
@@ -648,7 +632,6 @@
           <a:p>
             <a:fld id="{CDC85A0B-4DEE-4BD6-AE5A-B582637D85F0}" type="datetimeFigureOut">
               <a:rPr lang="en-US" smtClean="0"/>
-              <a:t>2/22/2025</a:t>
             </a:fld>
             <a:endParaRPr lang="en-US"/>
           </a:p>
@@ -690,18 +673,12 @@
           <a:p>
             <a:fld id="{92575AC0-47D5-4858-B9F2-8194FF11ECF9}" type="slidenum">
               <a:rPr lang="en-US" smtClean="0"/>
-              <a:t>‹#›</a:t>
             </a:fld>
             <a:endParaRPr lang="en-US"/>
           </a:p>
         </p:txBody>
       </p:sp>
     </p:spTree>
-    <p:extLst>
-      <p:ext uri="{BB962C8B-B14F-4D97-AF65-F5344CB8AC3E}">
-        <p14:creationId xmlns:p14="http://schemas.microsoft.com/office/powerpoint/2010/main" val="1796940686"/>
-      </p:ext>
-    </p:extLst>
   </p:cSld>
   <p:clrMapOvr>
     <a:masterClrMapping/>
@@ -745,6 +722,7 @@
               <a:rPr lang="en-US"/>
               <a:t>Click to edit Master title style</a:t>
             </a:r>
+            <a:endParaRPr lang="en-US"/>
           </a:p>
         </p:txBody>
       </p:sp>
@@ -768,6 +746,7 @@
               <a:rPr lang="en-US"/>
               <a:t>Click to edit Master text styles</a:t>
             </a:r>
+            <a:endParaRPr lang="en-US"/>
           </a:p>
           <a:p>
             <a:pPr lvl="1"/>
@@ -775,6 +754,7 @@
               <a:rPr lang="en-US"/>
               <a:t>Second level</a:t>
             </a:r>
+            <a:endParaRPr lang="en-US"/>
           </a:p>
           <a:p>
             <a:pPr lvl="2"/>
@@ -782,6 +762,7 @@
               <a:rPr lang="en-US"/>
               <a:t>Third level</a:t>
             </a:r>
+            <a:endParaRPr lang="en-US"/>
           </a:p>
           <a:p>
             <a:pPr lvl="3"/>
@@ -789,6 +770,7 @@
               <a:rPr lang="en-US"/>
               <a:t>Fourth level</a:t>
             </a:r>
+            <a:endParaRPr lang="en-US"/>
           </a:p>
           <a:p>
             <a:pPr lvl="4"/>
@@ -796,6 +778,7 @@
               <a:rPr lang="en-US"/>
               <a:t>Fifth level</a:t>
             </a:r>
+            <a:endParaRPr lang="en-US"/>
           </a:p>
         </p:txBody>
       </p:sp>
@@ -816,7 +799,6 @@
           <a:p>
             <a:fld id="{CDC85A0B-4DEE-4BD6-AE5A-B582637D85F0}" type="datetimeFigureOut">
               <a:rPr lang="en-US" smtClean="0"/>
-              <a:t>2/22/2025</a:t>
             </a:fld>
             <a:endParaRPr lang="en-US"/>
           </a:p>
@@ -858,18 +840,12 @@
           <a:p>
             <a:fld id="{92575AC0-47D5-4858-B9F2-8194FF11ECF9}" type="slidenum">
               <a:rPr lang="en-US" smtClean="0"/>
-              <a:t>‹#›</a:t>
             </a:fld>
             <a:endParaRPr lang="en-US"/>
           </a:p>
         </p:txBody>
       </p:sp>
     </p:spTree>
-    <p:extLst>
-      <p:ext uri="{BB962C8B-B14F-4D97-AF65-F5344CB8AC3E}">
-        <p14:creationId xmlns:p14="http://schemas.microsoft.com/office/powerpoint/2010/main" val="731053956"/>
-      </p:ext>
-    </p:extLst>
   </p:cSld>
   <p:clrMapOvr>
     <a:masterClrMapping/>
@@ -922,6 +898,7 @@
               <a:rPr lang="en-US"/>
               <a:t>Click to edit Master title style</a:t>
             </a:r>
+            <a:endParaRPr lang="en-US"/>
           </a:p>
         </p:txBody>
       </p:sp>
@@ -1041,6 +1018,7 @@
               <a:rPr lang="en-US"/>
               <a:t>Click to edit Master text styles</a:t>
             </a:r>
+            <a:endParaRPr lang="en-US"/>
           </a:p>
         </p:txBody>
       </p:sp>
@@ -1061,7 +1039,6 @@
           <a:p>
             <a:fld id="{CDC85A0B-4DEE-4BD6-AE5A-B582637D85F0}" type="datetimeFigureOut">
               <a:rPr lang="en-US" smtClean="0"/>
-              <a:t>2/22/2025</a:t>
             </a:fld>
             <a:endParaRPr lang="en-US"/>
           </a:p>
@@ -1103,18 +1080,12 @@
           <a:p>
             <a:fld id="{92575AC0-47D5-4858-B9F2-8194FF11ECF9}" type="slidenum">
               <a:rPr lang="en-US" smtClean="0"/>
-              <a:t>‹#›</a:t>
             </a:fld>
             <a:endParaRPr lang="en-US"/>
           </a:p>
         </p:txBody>
       </p:sp>
     </p:spTree>
-    <p:extLst>
-      <p:ext uri="{BB962C8B-B14F-4D97-AF65-F5344CB8AC3E}">
-        <p14:creationId xmlns:p14="http://schemas.microsoft.com/office/powerpoint/2010/main" val="4167011658"/>
-      </p:ext>
-    </p:extLst>
   </p:cSld>
   <p:clrMapOvr>
     <a:masterClrMapping/>
@@ -1158,6 +1129,7 @@
               <a:rPr lang="en-US"/>
               <a:t>Click to edit Master title style</a:t>
             </a:r>
+            <a:endParaRPr lang="en-US"/>
           </a:p>
         </p:txBody>
       </p:sp>
@@ -1214,6 +1186,7 @@
               <a:rPr lang="en-US"/>
               <a:t>Click to edit Master text styles</a:t>
             </a:r>
+            <a:endParaRPr lang="en-US"/>
           </a:p>
           <a:p>
             <a:pPr lvl="1"/>
@@ -1221,6 +1194,7 @@
               <a:rPr lang="en-US"/>
               <a:t>Second level</a:t>
             </a:r>
+            <a:endParaRPr lang="en-US"/>
           </a:p>
           <a:p>
             <a:pPr lvl="2"/>
@@ -1228,6 +1202,7 @@
               <a:rPr lang="en-US"/>
               <a:t>Third level</a:t>
             </a:r>
+            <a:endParaRPr lang="en-US"/>
           </a:p>
           <a:p>
             <a:pPr lvl="3"/>
@@ -1235,6 +1210,7 @@
               <a:rPr lang="en-US"/>
               <a:t>Fourth level</a:t>
             </a:r>
+            <a:endParaRPr lang="en-US"/>
           </a:p>
           <a:p>
             <a:pPr lvl="4"/>
@@ -1242,6 +1218,7 @@
               <a:rPr lang="en-US"/>
               <a:t>Fifth level</a:t>
             </a:r>
+            <a:endParaRPr lang="en-US"/>
           </a:p>
         </p:txBody>
       </p:sp>
@@ -1298,6 +1275,7 @@
               <a:rPr lang="en-US"/>
               <a:t>Click to edit Master text styles</a:t>
             </a:r>
+            <a:endParaRPr lang="en-US"/>
           </a:p>
           <a:p>
             <a:pPr lvl="1"/>
@@ -1305,6 +1283,7 @@
               <a:rPr lang="en-US"/>
               <a:t>Second level</a:t>
             </a:r>
+            <a:endParaRPr lang="en-US"/>
           </a:p>
           <a:p>
             <a:pPr lvl="2"/>
@@ -1312,6 +1291,7 @@
               <a:rPr lang="en-US"/>
               <a:t>Third level</a:t>
             </a:r>
+            <a:endParaRPr lang="en-US"/>
           </a:p>
           <a:p>
             <a:pPr lvl="3"/>
@@ -1319,6 +1299,7 @@
               <a:rPr lang="en-US"/>
               <a:t>Fourth level</a:t>
             </a:r>
+            <a:endParaRPr lang="en-US"/>
           </a:p>
           <a:p>
             <a:pPr lvl="4"/>
@@ -1326,6 +1307,7 @@
               <a:rPr lang="en-US"/>
               <a:t>Fifth level</a:t>
             </a:r>
+            <a:endParaRPr lang="en-US"/>
           </a:p>
         </p:txBody>
       </p:sp>
@@ -1346,7 +1328,6 @@
           <a:p>
             <a:fld id="{CDC85A0B-4DEE-4BD6-AE5A-B582637D85F0}" type="datetimeFigureOut">
               <a:rPr lang="en-US" smtClean="0"/>
-              <a:t>2/22/2025</a:t>
             </a:fld>
             <a:endParaRPr lang="en-US"/>
           </a:p>
@@ -1388,18 +1369,12 @@
           <a:p>
             <a:fld id="{92575AC0-47D5-4858-B9F2-8194FF11ECF9}" type="slidenum">
               <a:rPr lang="en-US" smtClean="0"/>
-              <a:t>‹#›</a:t>
             </a:fld>
             <a:endParaRPr lang="en-US"/>
           </a:p>
         </p:txBody>
       </p:sp>
     </p:spTree>
-    <p:extLst>
-      <p:ext uri="{BB962C8B-B14F-4D97-AF65-F5344CB8AC3E}">
-        <p14:creationId xmlns:p14="http://schemas.microsoft.com/office/powerpoint/2010/main" val="4118419533"/>
-      </p:ext>
-    </p:extLst>
   </p:cSld>
   <p:clrMapOvr>
     <a:masterClrMapping/>
@@ -1447,6 +1422,7 @@
               <a:rPr lang="en-US"/>
               <a:t>Click to edit Master title style</a:t>
             </a:r>
+            <a:endParaRPr lang="en-US"/>
           </a:p>
         </p:txBody>
       </p:sp>
@@ -1512,6 +1488,7 @@
               <a:rPr lang="en-US"/>
               <a:t>Click to edit Master text styles</a:t>
             </a:r>
+            <a:endParaRPr lang="en-US"/>
           </a:p>
         </p:txBody>
       </p:sp>
@@ -1568,6 +1545,7 @@
               <a:rPr lang="en-US"/>
               <a:t>Click to edit Master text styles</a:t>
             </a:r>
+            <a:endParaRPr lang="en-US"/>
           </a:p>
           <a:p>
             <a:pPr lvl="1"/>
@@ -1575,6 +1553,7 @@
               <a:rPr lang="en-US"/>
               <a:t>Second level</a:t>
             </a:r>
+            <a:endParaRPr lang="en-US"/>
           </a:p>
           <a:p>
             <a:pPr lvl="2"/>
@@ -1582,6 +1561,7 @@
               <a:rPr lang="en-US"/>
               <a:t>Third level</a:t>
             </a:r>
+            <a:endParaRPr lang="en-US"/>
           </a:p>
           <a:p>
             <a:pPr lvl="3"/>
@@ -1589,6 +1569,7 @@
               <a:rPr lang="en-US"/>
               <a:t>Fourth level</a:t>
             </a:r>
+            <a:endParaRPr lang="en-US"/>
           </a:p>
           <a:p>
             <a:pPr lvl="4"/>
@@ -1596,6 +1577,7 @@
               <a:rPr lang="en-US"/>
               <a:t>Fifth level</a:t>
             </a:r>
+            <a:endParaRPr lang="en-US"/>
           </a:p>
         </p:txBody>
       </p:sp>
@@ -1661,6 +1643,7 @@
               <a:rPr lang="en-US"/>
               <a:t>Click to edit Master text styles</a:t>
             </a:r>
+            <a:endParaRPr lang="en-US"/>
           </a:p>
         </p:txBody>
       </p:sp>
@@ -1717,6 +1700,7 @@
               <a:rPr lang="en-US"/>
               <a:t>Click to edit Master text styles</a:t>
             </a:r>
+            <a:endParaRPr lang="en-US"/>
           </a:p>
           <a:p>
             <a:pPr lvl="1"/>
@@ -1724,6 +1708,7 @@
               <a:rPr lang="en-US"/>
               <a:t>Second level</a:t>
             </a:r>
+            <a:endParaRPr lang="en-US"/>
           </a:p>
           <a:p>
             <a:pPr lvl="2"/>
@@ -1731,6 +1716,7 @@
               <a:rPr lang="en-US"/>
               <a:t>Third level</a:t>
             </a:r>
+            <a:endParaRPr lang="en-US"/>
           </a:p>
           <a:p>
             <a:pPr lvl="3"/>
@@ -1738,6 +1724,7 @@
               <a:rPr lang="en-US"/>
               <a:t>Fourth level</a:t>
             </a:r>
+            <a:endParaRPr lang="en-US"/>
           </a:p>
           <a:p>
             <a:pPr lvl="4"/>
@@ -1745,6 +1732,7 @@
               <a:rPr lang="en-US"/>
               <a:t>Fifth level</a:t>
             </a:r>
+            <a:endParaRPr lang="en-US"/>
           </a:p>
         </p:txBody>
       </p:sp>
@@ -1765,7 +1753,6 @@
           <a:p>
             <a:fld id="{CDC85A0B-4DEE-4BD6-AE5A-B582637D85F0}" type="datetimeFigureOut">
               <a:rPr lang="en-US" smtClean="0"/>
-              <a:t>2/22/2025</a:t>
             </a:fld>
             <a:endParaRPr lang="en-US"/>
           </a:p>
@@ -1807,18 +1794,12 @@
           <a:p>
             <a:fld id="{92575AC0-47D5-4858-B9F2-8194FF11ECF9}" type="slidenum">
               <a:rPr lang="en-US" smtClean="0"/>
-              <a:t>‹#›</a:t>
             </a:fld>
             <a:endParaRPr lang="en-US"/>
           </a:p>
         </p:txBody>
       </p:sp>
     </p:spTree>
-    <p:extLst>
-      <p:ext uri="{BB962C8B-B14F-4D97-AF65-F5344CB8AC3E}">
-        <p14:creationId xmlns:p14="http://schemas.microsoft.com/office/powerpoint/2010/main" val="3290010426"/>
-      </p:ext>
-    </p:extLst>
   </p:cSld>
   <p:clrMapOvr>
     <a:masterClrMapping/>
@@ -1862,6 +1843,7 @@
               <a:rPr lang="en-US"/>
               <a:t>Click to edit Master title style</a:t>
             </a:r>
+            <a:endParaRPr lang="en-US"/>
           </a:p>
         </p:txBody>
       </p:sp>
@@ -1882,7 +1864,6 @@
           <a:p>
             <a:fld id="{CDC85A0B-4DEE-4BD6-AE5A-B582637D85F0}" type="datetimeFigureOut">
               <a:rPr lang="en-US" smtClean="0"/>
-              <a:t>2/22/2025</a:t>
             </a:fld>
             <a:endParaRPr lang="en-US"/>
           </a:p>
@@ -1924,18 +1905,12 @@
           <a:p>
             <a:fld id="{92575AC0-47D5-4858-B9F2-8194FF11ECF9}" type="slidenum">
               <a:rPr lang="en-US" smtClean="0"/>
-              <a:t>‹#›</a:t>
             </a:fld>
             <a:endParaRPr lang="en-US"/>
           </a:p>
         </p:txBody>
       </p:sp>
     </p:spTree>
-    <p:extLst>
-      <p:ext uri="{BB962C8B-B14F-4D97-AF65-F5344CB8AC3E}">
-        <p14:creationId xmlns:p14="http://schemas.microsoft.com/office/powerpoint/2010/main" val="3642305360"/>
-      </p:ext>
-    </p:extLst>
   </p:cSld>
   <p:clrMapOvr>
     <a:masterClrMapping/>
@@ -1977,7 +1952,6 @@
           <a:p>
             <a:fld id="{CDC85A0B-4DEE-4BD6-AE5A-B582637D85F0}" type="datetimeFigureOut">
               <a:rPr lang="en-US" smtClean="0"/>
-              <a:t>2/22/2025</a:t>
             </a:fld>
             <a:endParaRPr lang="en-US"/>
           </a:p>
@@ -2019,18 +1993,12 @@
           <a:p>
             <a:fld id="{92575AC0-47D5-4858-B9F2-8194FF11ECF9}" type="slidenum">
               <a:rPr lang="en-US" smtClean="0"/>
-              <a:t>‹#›</a:t>
             </a:fld>
             <a:endParaRPr lang="en-US"/>
           </a:p>
         </p:txBody>
       </p:sp>
     </p:spTree>
-    <p:extLst>
-      <p:ext uri="{BB962C8B-B14F-4D97-AF65-F5344CB8AC3E}">
-        <p14:creationId xmlns:p14="http://schemas.microsoft.com/office/powerpoint/2010/main" val="1622471109"/>
-      </p:ext>
-    </p:extLst>
   </p:cSld>
   <p:clrMapOvr>
     <a:masterClrMapping/>
@@ -2083,6 +2051,7 @@
               <a:rPr lang="en-US"/>
               <a:t>Click to edit Master title style</a:t>
             </a:r>
+            <a:endParaRPr lang="en-US"/>
           </a:p>
         </p:txBody>
       </p:sp>
@@ -2139,6 +2108,7 @@
               <a:rPr lang="en-US"/>
               <a:t>Click to edit Master text styles</a:t>
             </a:r>
+            <a:endParaRPr lang="en-US"/>
           </a:p>
           <a:p>
             <a:pPr lvl="1"/>
@@ -2146,6 +2116,7 @@
               <a:rPr lang="en-US"/>
               <a:t>Second level</a:t>
             </a:r>
+            <a:endParaRPr lang="en-US"/>
           </a:p>
           <a:p>
             <a:pPr lvl="2"/>
@@ -2153,6 +2124,7 @@
               <a:rPr lang="en-US"/>
               <a:t>Third level</a:t>
             </a:r>
+            <a:endParaRPr lang="en-US"/>
           </a:p>
           <a:p>
             <a:pPr lvl="3"/>
@@ -2160,6 +2132,7 @@
               <a:rPr lang="en-US"/>
               <a:t>Fourth level</a:t>
             </a:r>
+            <a:endParaRPr lang="en-US"/>
           </a:p>
           <a:p>
             <a:pPr lvl="4"/>
@@ -2167,6 +2140,7 @@
               <a:rPr lang="en-US"/>
               <a:t>Fifth level</a:t>
             </a:r>
+            <a:endParaRPr lang="en-US"/>
           </a:p>
         </p:txBody>
       </p:sp>
@@ -2232,6 +2206,7 @@
               <a:rPr lang="en-US"/>
               <a:t>Click to edit Master text styles</a:t>
             </a:r>
+            <a:endParaRPr lang="en-US"/>
           </a:p>
         </p:txBody>
       </p:sp>
@@ -2252,7 +2227,6 @@
           <a:p>
             <a:fld id="{CDC85A0B-4DEE-4BD6-AE5A-B582637D85F0}" type="datetimeFigureOut">
               <a:rPr lang="en-US" smtClean="0"/>
-              <a:t>2/22/2025</a:t>
             </a:fld>
             <a:endParaRPr lang="en-US"/>
           </a:p>
@@ -2294,18 +2268,12 @@
           <a:p>
             <a:fld id="{92575AC0-47D5-4858-B9F2-8194FF11ECF9}" type="slidenum">
               <a:rPr lang="en-US" smtClean="0"/>
-              <a:t>‹#›</a:t>
             </a:fld>
             <a:endParaRPr lang="en-US"/>
           </a:p>
         </p:txBody>
       </p:sp>
     </p:spTree>
-    <p:extLst>
-      <p:ext uri="{BB962C8B-B14F-4D97-AF65-F5344CB8AC3E}">
-        <p14:creationId xmlns:p14="http://schemas.microsoft.com/office/powerpoint/2010/main" val="3228195830"/>
-      </p:ext>
-    </p:extLst>
   </p:cSld>
   <p:clrMapOvr>
     <a:masterClrMapping/>
@@ -2358,6 +2326,7 @@
               <a:rPr lang="en-US"/>
               <a:t>Click to edit Master title style</a:t>
             </a:r>
+            <a:endParaRPr lang="en-US"/>
           </a:p>
         </p:txBody>
       </p:sp>
@@ -2484,6 +2453,7 @@
               <a:rPr lang="en-US"/>
               <a:t>Click to edit Master text styles</a:t>
             </a:r>
+            <a:endParaRPr lang="en-US"/>
           </a:p>
         </p:txBody>
       </p:sp>
@@ -2504,7 +2474,6 @@
           <a:p>
             <a:fld id="{CDC85A0B-4DEE-4BD6-AE5A-B582637D85F0}" type="datetimeFigureOut">
               <a:rPr lang="en-US" smtClean="0"/>
-              <a:t>2/22/2025</a:t>
             </a:fld>
             <a:endParaRPr lang="en-US"/>
           </a:p>
@@ -2546,18 +2515,12 @@
           <a:p>
             <a:fld id="{92575AC0-47D5-4858-B9F2-8194FF11ECF9}" type="slidenum">
               <a:rPr lang="en-US" smtClean="0"/>
-              <a:t>‹#›</a:t>
             </a:fld>
             <a:endParaRPr lang="en-US"/>
           </a:p>
         </p:txBody>
       </p:sp>
     </p:spTree>
-    <p:extLst>
-      <p:ext uri="{BB962C8B-B14F-4D97-AF65-F5344CB8AC3E}">
-        <p14:creationId xmlns:p14="http://schemas.microsoft.com/office/powerpoint/2010/main" val="1862448731"/>
-      </p:ext>
-    </p:extLst>
   </p:cSld>
   <p:clrMapOvr>
     <a:masterClrMapping/>
@@ -2616,6 +2579,7 @@
               <a:rPr lang="en-US"/>
               <a:t>Click to edit Master title style</a:t>
             </a:r>
+            <a:endParaRPr lang="en-US"/>
           </a:p>
         </p:txBody>
       </p:sp>
@@ -2649,6 +2613,7 @@
               <a:rPr lang="en-US"/>
               <a:t>Click to edit Master text styles</a:t>
             </a:r>
+            <a:endParaRPr lang="en-US"/>
           </a:p>
           <a:p>
             <a:pPr lvl="1"/>
@@ -2656,6 +2621,7 @@
               <a:rPr lang="en-US"/>
               <a:t>Second level</a:t>
             </a:r>
+            <a:endParaRPr lang="en-US"/>
           </a:p>
           <a:p>
             <a:pPr lvl="2"/>
@@ -2663,6 +2629,7 @@
               <a:rPr lang="en-US"/>
               <a:t>Third level</a:t>
             </a:r>
+            <a:endParaRPr lang="en-US"/>
           </a:p>
           <a:p>
             <a:pPr lvl="3"/>
@@ -2670,6 +2637,7 @@
               <a:rPr lang="en-US"/>
               <a:t>Fourth level</a:t>
             </a:r>
+            <a:endParaRPr lang="en-US"/>
           </a:p>
           <a:p>
             <a:pPr lvl="4"/>
@@ -2677,6 +2645,7 @@
               <a:rPr lang="en-US"/>
               <a:t>Fifth level</a:t>
             </a:r>
+            <a:endParaRPr lang="en-US"/>
           </a:p>
         </p:txBody>
       </p:sp>
@@ -2715,7 +2684,6 @@
           <a:p>
             <a:fld id="{CDC85A0B-4DEE-4BD6-AE5A-B582637D85F0}" type="datetimeFigureOut">
               <a:rPr lang="en-US" smtClean="0"/>
-              <a:t>2/22/2025</a:t>
             </a:fld>
             <a:endParaRPr lang="en-US"/>
           </a:p>
@@ -2793,18 +2761,12 @@
           <a:p>
             <a:fld id="{92575AC0-47D5-4858-B9F2-8194FF11ECF9}" type="slidenum">
               <a:rPr lang="en-US" smtClean="0"/>
-              <a:t>‹#›</a:t>
             </a:fld>
             <a:endParaRPr lang="en-US"/>
           </a:p>
         </p:txBody>
       </p:sp>
     </p:spTree>
-    <p:extLst>
-      <p:ext uri="{BB962C8B-B14F-4D97-AF65-F5344CB8AC3E}">
-        <p14:creationId xmlns:p14="http://schemas.microsoft.com/office/powerpoint/2010/main" val="539740851"/>
-      </p:ext>
-    </p:extLst>
   </p:cSld>
   <p:clrMap bg1="lt1" tx1="dk1" bg2="lt2" tx2="dk2" accent1="accent1" accent2="accent2" accent3="accent3" accent4="accent4" accent5="accent5" accent6="accent6" hlink="hlink" folHlink="folHlink"/>
   <p:sldLayoutIdLst>
@@ -2842,7 +2804,7 @@
         <a:spcBef>
           <a:spcPct val="20000"/>
         </a:spcBef>
-        <a:buFont typeface="Arial" pitchFamily="34" charset="0"/>
+        <a:buFont typeface="Arial" panose="020B0604020202020204" pitchFamily="34" charset="0"/>
         <a:buChar char="•"/>
         <a:defRPr sz="3200" kern="1200">
           <a:solidFill>
@@ -2857,7 +2819,7 @@
         <a:spcBef>
           <a:spcPct val="20000"/>
         </a:spcBef>
-        <a:buFont typeface="Arial" pitchFamily="34" charset="0"/>
+        <a:buFont typeface="Arial" panose="020B0604020202020204" pitchFamily="34" charset="0"/>
         <a:buChar char="–"/>
         <a:defRPr sz="2800" kern="1200">
           <a:solidFill>
@@ -2872,7 +2834,7 @@
         <a:spcBef>
           <a:spcPct val="20000"/>
         </a:spcBef>
-        <a:buFont typeface="Arial" pitchFamily="34" charset="0"/>
+        <a:buFont typeface="Arial" panose="020B0604020202020204" pitchFamily="34" charset="0"/>
         <a:buChar char="•"/>
         <a:defRPr sz="2400" kern="1200">
           <a:solidFill>
@@ -2887,7 +2849,7 @@
         <a:spcBef>
           <a:spcPct val="20000"/>
         </a:spcBef>
-        <a:buFont typeface="Arial" pitchFamily="34" charset="0"/>
+        <a:buFont typeface="Arial" panose="020B0604020202020204" pitchFamily="34" charset="0"/>
         <a:buChar char="–"/>
         <a:defRPr sz="2000" kern="1200">
           <a:solidFill>
@@ -2902,7 +2864,7 @@
         <a:spcBef>
           <a:spcPct val="20000"/>
         </a:spcBef>
-        <a:buFont typeface="Arial" pitchFamily="34" charset="0"/>
+        <a:buFont typeface="Arial" panose="020B0604020202020204" pitchFamily="34" charset="0"/>
         <a:buChar char="»"/>
         <a:defRPr sz="2000" kern="1200">
           <a:solidFill>
@@ -2917,7 +2879,7 @@
         <a:spcBef>
           <a:spcPct val="20000"/>
         </a:spcBef>
-        <a:buFont typeface="Arial" pitchFamily="34" charset="0"/>
+        <a:buFont typeface="Arial" panose="020B0604020202020204" pitchFamily="34" charset="0"/>
         <a:buChar char="•"/>
         <a:defRPr sz="2000" kern="1200">
           <a:solidFill>
@@ -2932,7 +2894,7 @@
         <a:spcBef>
           <a:spcPct val="20000"/>
         </a:spcBef>
-        <a:buFont typeface="Arial" pitchFamily="34" charset="0"/>
+        <a:buFont typeface="Arial" panose="020B0604020202020204" pitchFamily="34" charset="0"/>
         <a:buChar char="•"/>
         <a:defRPr sz="2000" kern="1200">
           <a:solidFill>
@@ -2947,7 +2909,7 @@
         <a:spcBef>
           <a:spcPct val="20000"/>
         </a:spcBef>
-        <a:buFont typeface="Arial" pitchFamily="34" charset="0"/>
+        <a:buFont typeface="Arial" panose="020B0604020202020204" pitchFamily="34" charset="0"/>
         <a:buChar char="•"/>
         <a:defRPr sz="2000" kern="1200">
           <a:solidFill>
@@ -2962,7 +2924,7 @@
         <a:spcBef>
           <a:spcPct val="20000"/>
         </a:spcBef>
-        <a:buFont typeface="Arial" pitchFamily="34" charset="0"/>
+        <a:buFont typeface="Arial" panose="020B0604020202020204" pitchFamily="34" charset="0"/>
         <a:buChar char="•"/>
         <a:defRPr sz="2000" kern="1200">
           <a:solidFill>
@@ -3098,7 +3060,7 @@
         </p:nvSpPr>
         <p:spPr>
           <a:xfrm>
-            <a:off x="376445" y="356738"/>
+            <a:off x="376445" y="128138"/>
             <a:ext cx="2234907" cy="400110"/>
           </a:xfrm>
           <a:prstGeom prst="rect">
@@ -3133,6 +3095,14 @@
               </a:rPr>
               <a:t> Synopsis</a:t>
             </a:r>
+            <a:endParaRPr lang="en-US" sz="2000" dirty="0">
+              <a:solidFill>
+                <a:schemeClr val="bg1">
+                  <a:lumMod val="75000"/>
+                </a:schemeClr>
+              </a:solidFill>
+              <a:latin typeface="Raleway ExtraBold" pitchFamily="2" charset="0"/>
+            </a:endParaRPr>
           </a:p>
         </p:txBody>
       </p:sp>
@@ -3144,8 +3114,8 @@
         </p:nvSpPr>
         <p:spPr>
           <a:xfrm>
-            <a:off x="2614183" y="427786"/>
-            <a:ext cx="2541080" cy="253916"/>
+            <a:off x="2614183" y="199186"/>
+            <a:ext cx="2516505" cy="252730"/>
           </a:xfrm>
           <a:prstGeom prst="rect">
             <a:avLst/>
@@ -3164,13 +3134,13 @@
                     <a:lumMod val="75000"/>
                   </a:schemeClr>
                 </a:solidFill>
-                <a:latin typeface="Ubuntu Mono" pitchFamily="49" charset="0"/>
-                <a:hlinkClick r:id="rId2"/>
+                <a:latin typeface="Ubuntu Mono" panose="020B0509030602030204" pitchFamily="49" charset="0"/>
+                <a:hlinkClick r:id="rId1"/>
               </a:rPr>
-              <a:t>https://neurojson.org/bjdata/draft3</a:t>
+              <a:t>https://neurojson.org/bjdata/draft4</a:t>
             </a:r>
             <a:endParaRPr lang="en-US" sz="1050" dirty="0">
-              <a:latin typeface="Ubuntu Mono" pitchFamily="49" charset="0"/>
+              <a:latin typeface="Ubuntu Mono" panose="020B0509030602030204" pitchFamily="49" charset="0"/>
             </a:endParaRPr>
           </a:p>
         </p:txBody>
@@ -3183,7 +3153,7 @@
         </p:nvGrpSpPr>
         <p:grpSpPr>
           <a:xfrm>
-            <a:off x="514272" y="979197"/>
+            <a:off x="514272" y="750597"/>
             <a:ext cx="3383360" cy="552450"/>
             <a:chOff x="770714" y="914400"/>
             <a:chExt cx="3383360" cy="552450"/>
@@ -3267,6 +3237,9 @@
                 </a:rPr>
                 <a:t>Value</a:t>
               </a:r>
+              <a:endParaRPr lang="en-US" sz="1200" dirty="0">
+                <a:latin typeface="Raleway ExtraBold" pitchFamily="2" charset="0"/>
+              </a:endParaRPr>
             </a:p>
           </p:txBody>
         </p:sp>
@@ -3395,16 +3368,10 @@
         <p:nvGraphicFramePr>
           <p:cNvPr id="124" name="Google Shape;324;p39"/>
           <p:cNvGraphicFramePr/>
-          <p:nvPr>
-            <p:extLst>
-              <p:ext uri="{D42A27DB-BD31-4B8C-83A1-F6EECF244321}">
-                <p14:modId xmlns:p14="http://schemas.microsoft.com/office/powerpoint/2010/main" val="712077280"/>
-              </p:ext>
-            </p:extLst>
-          </p:nvPr>
+          <p:nvPr/>
         </p:nvGraphicFramePr>
         <p:xfrm>
-          <a:off x="495077" y="3566020"/>
+          <a:off x="495077" y="3337420"/>
           <a:ext cx="3848323" cy="3249116"/>
         </p:xfrm>
         <a:graphic>
@@ -3414,34 +3381,10 @@
                 <a:noFill/>
               </a:tblPr>
               <a:tblGrid>
-                <a:gridCol w="792100">
-                  <a:extLst>
-                    <a:ext uri="{9D8B030D-6E8A-4147-A177-3AD203B41FA5}">
-                      <a16:colId xmlns:a16="http://schemas.microsoft.com/office/drawing/2014/main" val="20000"/>
-                    </a:ext>
-                  </a:extLst>
-                </a:gridCol>
-                <a:gridCol w="576075">
-                  <a:extLst>
-                    <a:ext uri="{9D8B030D-6E8A-4147-A177-3AD203B41FA5}">
-                      <a16:colId xmlns:a16="http://schemas.microsoft.com/office/drawing/2014/main" val="20001"/>
-                    </a:ext>
-                  </a:extLst>
-                </a:gridCol>
-                <a:gridCol w="900100">
-                  <a:extLst>
-                    <a:ext uri="{9D8B030D-6E8A-4147-A177-3AD203B41FA5}">
-                      <a16:colId xmlns:a16="http://schemas.microsoft.com/office/drawing/2014/main" val="20002"/>
-                    </a:ext>
-                  </a:extLst>
-                </a:gridCol>
-                <a:gridCol w="1580048">
-                  <a:extLst>
-                    <a:ext uri="{9D8B030D-6E8A-4147-A177-3AD203B41FA5}">
-                      <a16:colId xmlns:a16="http://schemas.microsoft.com/office/drawing/2014/main" val="20003"/>
-                    </a:ext>
-                  </a:extLst>
-                </a:gridCol>
+                <a:gridCol w="792100"/>
+                <a:gridCol w="576075"/>
+                <a:gridCol w="900100"/>
+                <a:gridCol w="1580048"/>
               </a:tblGrid>
               <a:tr h="214565">
                 <a:tc>
@@ -3462,11 +3405,11 @@
                         <a:buNone/>
                       </a:pPr>
                       <a:r>
-                        <a:rPr lang="en" sz="800" u="none" strike="noStrike" cap="none" dirty="0">
+                        <a:rPr lang="en-GB" sz="800" u="none" strike="noStrike" cap="none" dirty="0">
                           <a:solidFill>
                             <a:srgbClr val="FFFF00"/>
                           </a:solidFill>
-                          <a:latin typeface="Ubuntu" pitchFamily="34" charset="0"/>
+                          <a:latin typeface="Ubuntu" panose="020B0504030602030204" pitchFamily="34" charset="0"/>
                         </a:rPr>
                         <a:t>Type Marker</a:t>
                       </a:r>
@@ -3474,7 +3417,7 @@
                         <a:solidFill>
                           <a:srgbClr val="FFFF00"/>
                         </a:solidFill>
-                        <a:latin typeface="Ubuntu" pitchFamily="34" charset="0"/>
+                        <a:latin typeface="Ubuntu" panose="020B0504030602030204" pitchFamily="34" charset="0"/>
                       </a:endParaRPr>
                     </a:p>
                   </a:txBody>
@@ -3505,11 +3448,11 @@
                         <a:buNone/>
                       </a:pPr>
                       <a:r>
-                        <a:rPr lang="en" sz="800" u="none" strike="noStrike" cap="none" dirty="0">
+                        <a:rPr lang="en-GB" sz="800" u="none" strike="noStrike" cap="none" dirty="0">
                           <a:solidFill>
                             <a:srgbClr val="FFFF00"/>
                           </a:solidFill>
-                          <a:latin typeface="Ubuntu" pitchFamily="34" charset="0"/>
+                          <a:latin typeface="Ubuntu" panose="020B0504030602030204" pitchFamily="34" charset="0"/>
                         </a:rPr>
                         <a:t>Length</a:t>
                       </a:r>
@@ -3517,7 +3460,7 @@
                         <a:solidFill>
                           <a:srgbClr val="FFFF00"/>
                         </a:solidFill>
-                        <a:latin typeface="Ubuntu" pitchFamily="34" charset="0"/>
+                        <a:latin typeface="Ubuntu" panose="020B0504030602030204" pitchFamily="34" charset="0"/>
                       </a:endParaRPr>
                     </a:p>
                   </a:txBody>
@@ -3549,15 +3492,15 @@
                           <a:srgbClr val="000000"/>
                         </a:buClr>
                         <a:buSzPts val="800"/>
-                        <a:buFont typeface="Arial"/>
-                        <a:buNone/>
-                      </a:pPr>
-                      <a:r>
-                        <a:rPr lang="en" sz="800" u="none" strike="noStrike" cap="none" dirty="0">
+                        <a:buFont typeface="Arial" panose="020B0604020202020204"/>
+                        <a:buNone/>
+                      </a:pPr>
+                      <a:r>
+                        <a:rPr lang="en-GB" sz="800" u="none" strike="noStrike" cap="none" dirty="0">
                           <a:solidFill>
                             <a:srgbClr val="FFFF00"/>
                           </a:solidFill>
-                          <a:latin typeface="Ubuntu" pitchFamily="34" charset="0"/>
+                          <a:latin typeface="Ubuntu" panose="020B0504030602030204" pitchFamily="34" charset="0"/>
                         </a:rPr>
                         <a:t>Data Payload</a:t>
                       </a:r>
@@ -3565,7 +3508,7 @@
                         <a:solidFill>
                           <a:srgbClr val="FFFF00"/>
                         </a:solidFill>
-                        <a:latin typeface="Ubuntu" pitchFamily="34" charset="0"/>
+                        <a:latin typeface="Ubuntu" panose="020B0504030602030204" pitchFamily="34" charset="0"/>
                       </a:endParaRPr>
                     </a:p>
                   </a:txBody>
@@ -3596,11 +3539,11 @@
                         <a:buNone/>
                       </a:pPr>
                       <a:r>
-                        <a:rPr lang="en" sz="800" u="none" strike="noStrike" cap="none" dirty="0">
+                        <a:rPr lang="en-GB" sz="800" u="none" strike="noStrike" cap="none" dirty="0">
                           <a:solidFill>
                             <a:srgbClr val="FFFF00"/>
                           </a:solidFill>
-                          <a:latin typeface="Ubuntu" pitchFamily="34" charset="0"/>
+                          <a:latin typeface="Ubuntu" panose="020B0504030602030204" pitchFamily="34" charset="0"/>
                         </a:rPr>
                         <a:t>Meaning</a:t>
                       </a:r>
@@ -3608,7 +3551,7 @@
                         <a:solidFill>
                           <a:srgbClr val="FFFF00"/>
                         </a:solidFill>
-                        <a:latin typeface="Ubuntu" pitchFamily="34" charset="0"/>
+                        <a:latin typeface="Ubuntu" panose="020B0504030602030204" pitchFamily="34" charset="0"/>
                       </a:endParaRPr>
                     </a:p>
                   </a:txBody>
@@ -3621,11 +3564,6 @@
                     </a:solidFill>
                   </a:tcPr>
                 </a:tc>
-                <a:extLst>
-                  <a:ext uri="{0D108BD9-81ED-4DB2-BD59-A6C34878D82A}">
-                    <a16:rowId xmlns:a16="http://schemas.microsoft.com/office/drawing/2014/main" val="10000"/>
-                  </a:ext>
-                </a:extLst>
               </a:tr>
               <a:tr h="214565">
                 <a:tc>
@@ -3646,8 +3584,8 @@
                         <a:buNone/>
                       </a:pPr>
                       <a:r>
-                        <a:rPr lang="en" sz="800" u="none" strike="noStrike" cap="none" dirty="0">
-                          <a:latin typeface="Ubuntu" pitchFamily="34" charset="0"/>
+                        <a:rPr lang="en-GB" sz="800" u="none" strike="noStrike" cap="none" dirty="0">
+                          <a:latin typeface="Ubuntu" panose="020B0504030602030204" pitchFamily="34" charset="0"/>
                           <a:ea typeface="Consolas"/>
                           <a:cs typeface="Consolas"/>
                           <a:sym typeface="Consolas"/>
@@ -3655,7 +3593,7 @@
                         <a:t>Z</a:t>
                       </a:r>
                       <a:endParaRPr sz="800" u="none" strike="noStrike" cap="none" dirty="0">
-                        <a:latin typeface="Ubuntu" pitchFamily="34" charset="0"/>
+                        <a:latin typeface="Ubuntu" panose="020B0504030602030204" pitchFamily="34" charset="0"/>
                         <a:ea typeface="Consolas"/>
                         <a:cs typeface="Consolas"/>
                         <a:sym typeface="Consolas"/>
@@ -3686,13 +3624,13 @@
                         <a:buNone/>
                       </a:pPr>
                       <a:r>
-                        <a:rPr lang="en" sz="800" u="none" strike="noStrike" cap="none">
-                          <a:latin typeface="Ubuntu" pitchFamily="34" charset="0"/>
+                        <a:rPr lang="en-GB" sz="800" u="none" strike="noStrike" cap="none">
+                          <a:latin typeface="Ubuntu" panose="020B0504030602030204" pitchFamily="34" charset="0"/>
                         </a:rPr>
                         <a:t>no</a:t>
                       </a:r>
                       <a:endParaRPr sz="800" u="none" strike="noStrike" cap="none">
-                        <a:latin typeface="Ubuntu" pitchFamily="34" charset="0"/>
+                        <a:latin typeface="Ubuntu" panose="020B0504030602030204" pitchFamily="34" charset="0"/>
                       </a:endParaRPr>
                     </a:p>
                   </a:txBody>
@@ -3720,13 +3658,13 @@
                         <a:buNone/>
                       </a:pPr>
                       <a:r>
-                        <a:rPr lang="en" sz="800" u="none" strike="noStrike" cap="none">
-                          <a:latin typeface="Ubuntu" pitchFamily="34" charset="0"/>
+                        <a:rPr lang="en-GB" sz="800" u="none" strike="noStrike" cap="none">
+                          <a:latin typeface="Ubuntu" panose="020B0504030602030204" pitchFamily="34" charset="0"/>
                         </a:rPr>
                         <a:t>no</a:t>
                       </a:r>
                       <a:endParaRPr sz="800" u="none" strike="noStrike" cap="none">
-                        <a:latin typeface="Ubuntu" pitchFamily="34" charset="0"/>
+                        <a:latin typeface="Ubuntu" panose="020B0504030602030204" pitchFamily="34" charset="0"/>
                       </a:endParaRPr>
                     </a:p>
                   </a:txBody>
@@ -3754,13 +3692,13 @@
                         <a:buNone/>
                       </a:pPr>
                       <a:r>
-                        <a:rPr lang="en" sz="800" u="none" strike="noStrike" cap="none" dirty="0">
-                          <a:latin typeface="Ubuntu" pitchFamily="34" charset="0"/>
+                        <a:rPr lang="en-GB" sz="800" u="none" strike="noStrike" cap="none" dirty="0">
+                          <a:latin typeface="Ubuntu" panose="020B0504030602030204" pitchFamily="34" charset="0"/>
                         </a:rPr>
                         <a:t>null</a:t>
                       </a:r>
                       <a:endParaRPr sz="800" u="none" strike="noStrike" cap="none" dirty="0">
-                        <a:latin typeface="Ubuntu" pitchFamily="34" charset="0"/>
+                        <a:latin typeface="Ubuntu" panose="020B0504030602030204" pitchFamily="34" charset="0"/>
                       </a:endParaRPr>
                     </a:p>
                   </a:txBody>
@@ -3770,11 +3708,6 @@
                     </a:solidFill>
                   </a:tcPr>
                 </a:tc>
-                <a:extLst>
-                  <a:ext uri="{0D108BD9-81ED-4DB2-BD59-A6C34878D82A}">
-                    <a16:rowId xmlns:a16="http://schemas.microsoft.com/office/drawing/2014/main" val="10001"/>
-                  </a:ext>
-                </a:extLst>
               </a:tr>
               <a:tr h="214565">
                 <a:tc>
@@ -3795,8 +3728,8 @@
                         <a:buNone/>
                       </a:pPr>
                       <a:r>
-                        <a:rPr lang="en" sz="800" u="none" strike="noStrike" cap="none">
-                          <a:latin typeface="Ubuntu" pitchFamily="34" charset="0"/>
+                        <a:rPr lang="en-GB" sz="800" u="none" strike="noStrike" cap="none">
+                          <a:latin typeface="Ubuntu" panose="020B0504030602030204" pitchFamily="34" charset="0"/>
                           <a:ea typeface="Consolas"/>
                           <a:cs typeface="Consolas"/>
                           <a:sym typeface="Consolas"/>
@@ -3804,7 +3737,7 @@
                         <a:t>T</a:t>
                       </a:r>
                       <a:endParaRPr sz="800" u="none" strike="noStrike" cap="none">
-                        <a:latin typeface="Ubuntu" pitchFamily="34" charset="0"/>
+                        <a:latin typeface="Ubuntu" panose="020B0504030602030204" pitchFamily="34" charset="0"/>
                         <a:ea typeface="Consolas"/>
                         <a:cs typeface="Consolas"/>
                         <a:sym typeface="Consolas"/>
@@ -3835,13 +3768,13 @@
                         <a:buNone/>
                       </a:pPr>
                       <a:r>
-                        <a:rPr lang="en" sz="800" u="none" strike="noStrike" cap="none" dirty="0">
-                          <a:latin typeface="Ubuntu" pitchFamily="34" charset="0"/>
+                        <a:rPr lang="en-GB" sz="800" u="none" strike="noStrike" cap="none" dirty="0">
+                          <a:latin typeface="Ubuntu" panose="020B0504030602030204" pitchFamily="34" charset="0"/>
                         </a:rPr>
                         <a:t>no</a:t>
                       </a:r>
                       <a:endParaRPr sz="800" u="none" strike="noStrike" cap="none" dirty="0">
-                        <a:latin typeface="Ubuntu" pitchFamily="34" charset="0"/>
+                        <a:latin typeface="Ubuntu" panose="020B0504030602030204" pitchFamily="34" charset="0"/>
                       </a:endParaRPr>
                     </a:p>
                   </a:txBody>
@@ -3869,13 +3802,13 @@
                         <a:buNone/>
                       </a:pPr>
                       <a:r>
-                        <a:rPr lang="en" sz="800" u="none" strike="noStrike" cap="none" dirty="0">
-                          <a:latin typeface="Ubuntu" pitchFamily="34" charset="0"/>
+                        <a:rPr lang="en-GB" sz="800" u="none" strike="noStrike" cap="none" dirty="0">
+                          <a:latin typeface="Ubuntu" panose="020B0504030602030204" pitchFamily="34" charset="0"/>
                         </a:rPr>
                         <a:t>no</a:t>
                       </a:r>
                       <a:endParaRPr sz="800" u="none" strike="noStrike" cap="none" dirty="0">
-                        <a:latin typeface="Ubuntu" pitchFamily="34" charset="0"/>
+                        <a:latin typeface="Ubuntu" panose="020B0504030602030204" pitchFamily="34" charset="0"/>
                       </a:endParaRPr>
                     </a:p>
                   </a:txBody>
@@ -3903,13 +3836,13 @@
                         <a:buNone/>
                       </a:pPr>
                       <a:r>
-                        <a:rPr lang="en" sz="800" u="none" strike="noStrike" cap="none">
-                          <a:latin typeface="Ubuntu" pitchFamily="34" charset="0"/>
+                        <a:rPr lang="en-GB" sz="800" u="none" strike="noStrike" cap="none">
+                          <a:latin typeface="Ubuntu" panose="020B0504030602030204" pitchFamily="34" charset="0"/>
                         </a:rPr>
                         <a:t>true</a:t>
                       </a:r>
                       <a:endParaRPr sz="800" u="none" strike="noStrike" cap="none">
-                        <a:latin typeface="Ubuntu" pitchFamily="34" charset="0"/>
+                        <a:latin typeface="Ubuntu" panose="020B0504030602030204" pitchFamily="34" charset="0"/>
                       </a:endParaRPr>
                     </a:p>
                   </a:txBody>
@@ -3919,11 +3852,6 @@
                     </a:solidFill>
                   </a:tcPr>
                 </a:tc>
-                <a:extLst>
-                  <a:ext uri="{0D108BD9-81ED-4DB2-BD59-A6C34878D82A}">
-                    <a16:rowId xmlns:a16="http://schemas.microsoft.com/office/drawing/2014/main" val="10002"/>
-                  </a:ext>
-                </a:extLst>
               </a:tr>
               <a:tr h="214565">
                 <a:tc>
@@ -3944,8 +3872,8 @@
                         <a:buNone/>
                       </a:pPr>
                       <a:r>
-                        <a:rPr lang="en" sz="800" u="none" strike="noStrike" cap="none">
-                          <a:latin typeface="Ubuntu" pitchFamily="34" charset="0"/>
+                        <a:rPr lang="en-GB" sz="800" u="none" strike="noStrike" cap="none">
+                          <a:latin typeface="Ubuntu" panose="020B0504030602030204" pitchFamily="34" charset="0"/>
                           <a:ea typeface="Consolas"/>
                           <a:cs typeface="Consolas"/>
                           <a:sym typeface="Consolas"/>
@@ -3953,7 +3881,7 @@
                         <a:t>F</a:t>
                       </a:r>
                       <a:endParaRPr sz="800" u="none" strike="noStrike" cap="none">
-                        <a:latin typeface="Ubuntu" pitchFamily="34" charset="0"/>
+                        <a:latin typeface="Ubuntu" panose="020B0504030602030204" pitchFamily="34" charset="0"/>
                         <a:ea typeface="Consolas"/>
                         <a:cs typeface="Consolas"/>
                         <a:sym typeface="Consolas"/>
@@ -3984,13 +3912,13 @@
                         <a:buNone/>
                       </a:pPr>
                       <a:r>
-                        <a:rPr lang="en" sz="800" u="none" strike="noStrike" cap="none">
-                          <a:latin typeface="Ubuntu" pitchFamily="34" charset="0"/>
+                        <a:rPr lang="en-GB" sz="800" u="none" strike="noStrike" cap="none">
+                          <a:latin typeface="Ubuntu" panose="020B0504030602030204" pitchFamily="34" charset="0"/>
                         </a:rPr>
                         <a:t>no</a:t>
                       </a:r>
                       <a:endParaRPr sz="800" u="none" strike="noStrike" cap="none">
-                        <a:latin typeface="Ubuntu" pitchFamily="34" charset="0"/>
+                        <a:latin typeface="Ubuntu" panose="020B0504030602030204" pitchFamily="34" charset="0"/>
                       </a:endParaRPr>
                     </a:p>
                   </a:txBody>
@@ -4018,13 +3946,13 @@
                         <a:buNone/>
                       </a:pPr>
                       <a:r>
-                        <a:rPr lang="en" sz="800" u="none" strike="noStrike" cap="none" dirty="0">
-                          <a:latin typeface="Ubuntu" pitchFamily="34" charset="0"/>
+                        <a:rPr lang="en-GB" sz="800" u="none" strike="noStrike" cap="none" dirty="0">
+                          <a:latin typeface="Ubuntu" panose="020B0504030602030204" pitchFamily="34" charset="0"/>
                         </a:rPr>
                         <a:t>no</a:t>
                       </a:r>
                       <a:endParaRPr sz="800" u="none" strike="noStrike" cap="none" dirty="0">
-                        <a:latin typeface="Ubuntu" pitchFamily="34" charset="0"/>
+                        <a:latin typeface="Ubuntu" panose="020B0504030602030204" pitchFamily="34" charset="0"/>
                       </a:endParaRPr>
                     </a:p>
                   </a:txBody>
@@ -4052,13 +3980,13 @@
                         <a:buNone/>
                       </a:pPr>
                       <a:r>
-                        <a:rPr lang="en" sz="800" u="none" strike="noStrike" cap="none" dirty="0">
-                          <a:latin typeface="Ubuntu" pitchFamily="34" charset="0"/>
+                        <a:rPr lang="en-GB" sz="800" u="none" strike="noStrike" cap="none" dirty="0">
+                          <a:latin typeface="Ubuntu" panose="020B0504030602030204" pitchFamily="34" charset="0"/>
                         </a:rPr>
                         <a:t>false</a:t>
                       </a:r>
                       <a:endParaRPr sz="800" u="none" strike="noStrike" cap="none" dirty="0">
-                        <a:latin typeface="Ubuntu" pitchFamily="34" charset="0"/>
+                        <a:latin typeface="Ubuntu" panose="020B0504030602030204" pitchFamily="34" charset="0"/>
                       </a:endParaRPr>
                     </a:p>
                   </a:txBody>
@@ -4068,11 +3996,6 @@
                     </a:solidFill>
                   </a:tcPr>
                 </a:tc>
-                <a:extLst>
-                  <a:ext uri="{0D108BD9-81ED-4DB2-BD59-A6C34878D82A}">
-                    <a16:rowId xmlns:a16="http://schemas.microsoft.com/office/drawing/2014/main" val="10003"/>
-                  </a:ext>
-                </a:extLst>
               </a:tr>
               <a:tr h="214565">
                 <a:tc>
@@ -4093,8 +4016,8 @@
                         <a:buNone/>
                       </a:pPr>
                       <a:r>
-                        <a:rPr lang="en" sz="800" u="none" strike="noStrike" cap="none">
-                          <a:latin typeface="Ubuntu" pitchFamily="34" charset="0"/>
+                        <a:rPr lang="en-GB" sz="800" u="none" strike="noStrike" cap="none">
+                          <a:latin typeface="Ubuntu" panose="020B0504030602030204" pitchFamily="34" charset="0"/>
                           <a:ea typeface="Consolas"/>
                           <a:cs typeface="Consolas"/>
                           <a:sym typeface="Consolas"/>
@@ -4102,7 +4025,7 @@
                         <a:t>N</a:t>
                       </a:r>
                       <a:endParaRPr sz="800" u="none" strike="noStrike" cap="none">
-                        <a:latin typeface="Ubuntu" pitchFamily="34" charset="0"/>
+                        <a:latin typeface="Ubuntu" panose="020B0504030602030204" pitchFamily="34" charset="0"/>
                         <a:ea typeface="Consolas"/>
                         <a:cs typeface="Consolas"/>
                         <a:sym typeface="Consolas"/>
@@ -4133,13 +4056,13 @@
                         <a:buNone/>
                       </a:pPr>
                       <a:r>
-                        <a:rPr lang="en" sz="800" u="none" strike="noStrike" cap="none">
-                          <a:latin typeface="Ubuntu" pitchFamily="34" charset="0"/>
+                        <a:rPr lang="en-GB" sz="800" u="none" strike="noStrike" cap="none">
+                          <a:latin typeface="Ubuntu" panose="020B0504030602030204" pitchFamily="34" charset="0"/>
                         </a:rPr>
                         <a:t>no</a:t>
                       </a:r>
                       <a:endParaRPr sz="800" u="none" strike="noStrike" cap="none">
-                        <a:latin typeface="Ubuntu" pitchFamily="34" charset="0"/>
+                        <a:latin typeface="Ubuntu" panose="020B0504030602030204" pitchFamily="34" charset="0"/>
                       </a:endParaRPr>
                     </a:p>
                   </a:txBody>
@@ -4167,13 +4090,13 @@
                         <a:buNone/>
                       </a:pPr>
                       <a:r>
-                        <a:rPr lang="en" sz="800" u="none" strike="noStrike" cap="none" dirty="0">
-                          <a:latin typeface="Ubuntu" pitchFamily="34" charset="0"/>
+                        <a:rPr lang="en-GB" sz="800" u="none" strike="noStrike" cap="none" dirty="0">
+                          <a:latin typeface="Ubuntu" panose="020B0504030602030204" pitchFamily="34" charset="0"/>
                         </a:rPr>
                         <a:t>no</a:t>
                       </a:r>
                       <a:endParaRPr sz="800" u="none" strike="noStrike" cap="none" dirty="0">
-                        <a:latin typeface="Ubuntu" pitchFamily="34" charset="0"/>
+                        <a:latin typeface="Ubuntu" panose="020B0504030602030204" pitchFamily="34" charset="0"/>
                       </a:endParaRPr>
                     </a:p>
                   </a:txBody>
@@ -4201,13 +4124,13 @@
                         <a:buNone/>
                       </a:pPr>
                       <a:r>
-                        <a:rPr lang="en" sz="800" u="none" strike="noStrike" cap="none" dirty="0">
-                          <a:latin typeface="Ubuntu" pitchFamily="34" charset="0"/>
+                        <a:rPr lang="en-GB" sz="800" u="none" strike="noStrike" cap="none" dirty="0">
+                          <a:latin typeface="Ubuntu" panose="020B0504030602030204" pitchFamily="34" charset="0"/>
                         </a:rPr>
                         <a:t>no-op (keep-alive)</a:t>
                       </a:r>
                       <a:endParaRPr sz="800" u="none" strike="noStrike" cap="none" dirty="0">
-                        <a:latin typeface="Ubuntu" pitchFamily="34" charset="0"/>
+                        <a:latin typeface="Ubuntu" panose="020B0504030602030204" pitchFamily="34" charset="0"/>
                       </a:endParaRPr>
                     </a:p>
                   </a:txBody>
@@ -4217,11 +4140,6 @@
                     </a:solidFill>
                   </a:tcPr>
                 </a:tc>
-                <a:extLst>
-                  <a:ext uri="{0D108BD9-81ED-4DB2-BD59-A6C34878D82A}">
-                    <a16:rowId xmlns:a16="http://schemas.microsoft.com/office/drawing/2014/main" val="10004"/>
-                  </a:ext>
-                </a:extLst>
               </a:tr>
               <a:tr h="214565">
                 <a:tc>
@@ -4242,8 +4160,8 @@
                         <a:buNone/>
                       </a:pPr>
                       <a:r>
-                        <a:rPr lang="en" sz="800" u="none" strike="noStrike" cap="none">
-                          <a:latin typeface="Ubuntu" pitchFamily="34" charset="0"/>
+                        <a:rPr lang="en-GB" sz="800" u="none" strike="noStrike" cap="none">
+                          <a:latin typeface="Ubuntu" panose="020B0504030602030204" pitchFamily="34" charset="0"/>
                           <a:ea typeface="Consolas"/>
                           <a:cs typeface="Consolas"/>
                           <a:sym typeface="Consolas"/>
@@ -4251,7 +4169,7 @@
                         <a:t>U</a:t>
                       </a:r>
                       <a:endParaRPr sz="800" u="none" strike="noStrike" cap="none">
-                        <a:latin typeface="Ubuntu" pitchFamily="34" charset="0"/>
+                        <a:latin typeface="Ubuntu" panose="020B0504030602030204" pitchFamily="34" charset="0"/>
                         <a:ea typeface="Consolas"/>
                         <a:cs typeface="Consolas"/>
                         <a:sym typeface="Consolas"/>
@@ -4282,13 +4200,13 @@
                         <a:buNone/>
                       </a:pPr>
                       <a:r>
-                        <a:rPr lang="en" sz="800" u="none" strike="noStrike" cap="none">
-                          <a:latin typeface="Ubuntu" pitchFamily="34" charset="0"/>
+                        <a:rPr lang="en-GB" sz="800" u="none" strike="noStrike" cap="none">
+                          <a:latin typeface="Ubuntu" panose="020B0504030602030204" pitchFamily="34" charset="0"/>
                         </a:rPr>
                         <a:t>no</a:t>
                       </a:r>
                       <a:endParaRPr sz="800" u="none" strike="noStrike" cap="none">
-                        <a:latin typeface="Ubuntu" pitchFamily="34" charset="0"/>
+                        <a:latin typeface="Ubuntu" panose="020B0504030602030204" pitchFamily="34" charset="0"/>
                       </a:endParaRPr>
                     </a:p>
                   </a:txBody>
@@ -4316,13 +4234,13 @@
                         <a:buNone/>
                       </a:pPr>
                       <a:r>
-                        <a:rPr lang="en" sz="800" u="none" strike="noStrike" cap="none">
-                          <a:latin typeface="Ubuntu" pitchFamily="34" charset="0"/>
+                        <a:rPr lang="en-GB" sz="800" u="none" strike="noStrike" cap="none">
+                          <a:latin typeface="Ubuntu" panose="020B0504030602030204" pitchFamily="34" charset="0"/>
                         </a:rPr>
                         <a:t>yes</a:t>
                       </a:r>
                       <a:endParaRPr sz="800" u="none" strike="noStrike" cap="none">
-                        <a:latin typeface="Ubuntu" pitchFamily="34" charset="0"/>
+                        <a:latin typeface="Ubuntu" panose="020B0504030602030204" pitchFamily="34" charset="0"/>
                       </a:endParaRPr>
                     </a:p>
                   </a:txBody>
@@ -4350,13 +4268,13 @@
                         <a:buNone/>
                       </a:pPr>
                       <a:r>
-                        <a:rPr lang="en" sz="800" u="none" strike="noStrike" cap="none" dirty="0">
-                          <a:latin typeface="Ubuntu" pitchFamily="34" charset="0"/>
+                        <a:rPr lang="en-GB" sz="800" u="none" strike="noStrike" cap="none" dirty="0">
+                          <a:latin typeface="Ubuntu" panose="020B0504030602030204" pitchFamily="34" charset="0"/>
                         </a:rPr>
                         <a:t>uint8</a:t>
                       </a:r>
                       <a:endParaRPr sz="800" u="none" strike="noStrike" cap="none" dirty="0">
-                        <a:latin typeface="Ubuntu" pitchFamily="34" charset="0"/>
+                        <a:latin typeface="Ubuntu" panose="020B0504030602030204" pitchFamily="34" charset="0"/>
                       </a:endParaRPr>
                     </a:p>
                   </a:txBody>
@@ -4366,11 +4284,6 @@
                     </a:solidFill>
                   </a:tcPr>
                 </a:tc>
-                <a:extLst>
-                  <a:ext uri="{0D108BD9-81ED-4DB2-BD59-A6C34878D82A}">
-                    <a16:rowId xmlns:a16="http://schemas.microsoft.com/office/drawing/2014/main" val="10005"/>
-                  </a:ext>
-                </a:extLst>
               </a:tr>
               <a:tr h="214565">
                 <a:tc>
@@ -4391,8 +4304,8 @@
                         <a:buNone/>
                       </a:pPr>
                       <a:r>
-                        <a:rPr lang="en" sz="800" u="none" strike="noStrike" cap="none">
-                          <a:latin typeface="Ubuntu" pitchFamily="34" charset="0"/>
+                        <a:rPr lang="en-GB" sz="800" u="none" strike="noStrike" cap="none">
+                          <a:latin typeface="Ubuntu" panose="020B0504030602030204" pitchFamily="34" charset="0"/>
                           <a:ea typeface="Consolas"/>
                           <a:cs typeface="Consolas"/>
                           <a:sym typeface="Consolas"/>
@@ -4400,7 +4313,7 @@
                         <a:t>i</a:t>
                       </a:r>
                       <a:endParaRPr sz="800" u="none" strike="noStrike" cap="none">
-                        <a:latin typeface="Ubuntu" pitchFamily="34" charset="0"/>
+                        <a:latin typeface="Ubuntu" panose="020B0504030602030204" pitchFamily="34" charset="0"/>
                         <a:ea typeface="Consolas"/>
                         <a:cs typeface="Consolas"/>
                         <a:sym typeface="Consolas"/>
@@ -4431,13 +4344,13 @@
                         <a:buNone/>
                       </a:pPr>
                       <a:r>
-                        <a:rPr lang="en" sz="800" u="none" strike="noStrike" cap="none">
-                          <a:latin typeface="Ubuntu" pitchFamily="34" charset="0"/>
+                        <a:rPr lang="en-GB" sz="800" u="none" strike="noStrike" cap="none">
+                          <a:latin typeface="Ubuntu" panose="020B0504030602030204" pitchFamily="34" charset="0"/>
                         </a:rPr>
                         <a:t>no</a:t>
                       </a:r>
                       <a:endParaRPr sz="800" u="none" strike="noStrike" cap="none">
-                        <a:latin typeface="Ubuntu" pitchFamily="34" charset="0"/>
+                        <a:latin typeface="Ubuntu" panose="020B0504030602030204" pitchFamily="34" charset="0"/>
                       </a:endParaRPr>
                     </a:p>
                   </a:txBody>
@@ -4465,13 +4378,13 @@
                         <a:buNone/>
                       </a:pPr>
                       <a:r>
-                        <a:rPr lang="en" sz="800" u="none" strike="noStrike" cap="none">
-                          <a:latin typeface="Ubuntu" pitchFamily="34" charset="0"/>
+                        <a:rPr lang="en-GB" sz="800" u="none" strike="noStrike" cap="none">
+                          <a:latin typeface="Ubuntu" panose="020B0504030602030204" pitchFamily="34" charset="0"/>
                         </a:rPr>
                         <a:t>yes</a:t>
                       </a:r>
                       <a:endParaRPr sz="800" u="none" strike="noStrike" cap="none">
-                        <a:latin typeface="Ubuntu" pitchFamily="34" charset="0"/>
+                        <a:latin typeface="Ubuntu" panose="020B0504030602030204" pitchFamily="34" charset="0"/>
                       </a:endParaRPr>
                     </a:p>
                   </a:txBody>
@@ -4499,13 +4412,13 @@
                         <a:buNone/>
                       </a:pPr>
                       <a:r>
-                        <a:rPr lang="en" sz="800" u="none" strike="noStrike" cap="none" dirty="0">
-                          <a:latin typeface="Ubuntu" pitchFamily="34" charset="0"/>
+                        <a:rPr lang="en-GB" sz="800" u="none" strike="noStrike" cap="none" dirty="0">
+                          <a:latin typeface="Ubuntu" panose="020B0504030602030204" pitchFamily="34" charset="0"/>
                         </a:rPr>
                         <a:t>int8</a:t>
                       </a:r>
                       <a:endParaRPr sz="800" u="none" strike="noStrike" cap="none" dirty="0">
-                        <a:latin typeface="Ubuntu" pitchFamily="34" charset="0"/>
+                        <a:latin typeface="Ubuntu" panose="020B0504030602030204" pitchFamily="34" charset="0"/>
                       </a:endParaRPr>
                     </a:p>
                   </a:txBody>
@@ -4515,11 +4428,6 @@
                     </a:solidFill>
                   </a:tcPr>
                 </a:tc>
-                <a:extLst>
-                  <a:ext uri="{0D108BD9-81ED-4DB2-BD59-A6C34878D82A}">
-                    <a16:rowId xmlns:a16="http://schemas.microsoft.com/office/drawing/2014/main" val="10006"/>
-                  </a:ext>
-                </a:extLst>
               </a:tr>
               <a:tr h="214565">
                 <a:tc>
@@ -4540,11 +4448,11 @@
                         <a:buNone/>
                       </a:pPr>
                       <a:r>
-                        <a:rPr lang="en" sz="800" u="none" strike="noStrike" cap="none">
+                        <a:rPr lang="en-GB" sz="800" u="none" strike="noStrike" cap="none">
                           <a:solidFill>
                             <a:srgbClr val="FF0000"/>
                           </a:solidFill>
-                          <a:latin typeface="Ubuntu" pitchFamily="34" charset="0"/>
+                          <a:latin typeface="Ubuntu" panose="020B0504030602030204" pitchFamily="34" charset="0"/>
                           <a:ea typeface="Consolas"/>
                           <a:cs typeface="Consolas"/>
                           <a:sym typeface="Consolas"/>
@@ -4555,7 +4463,7 @@
                         <a:solidFill>
                           <a:srgbClr val="FF0000"/>
                         </a:solidFill>
-                        <a:latin typeface="Ubuntu" pitchFamily="34" charset="0"/>
+                        <a:latin typeface="Ubuntu" panose="020B0504030602030204" pitchFamily="34" charset="0"/>
                         <a:ea typeface="Consolas"/>
                         <a:cs typeface="Consolas"/>
                         <a:sym typeface="Consolas"/>
@@ -4586,13 +4494,13 @@
                         <a:buNone/>
                       </a:pPr>
                       <a:r>
-                        <a:rPr lang="en" sz="800" u="none" strike="noStrike" cap="none">
-                          <a:latin typeface="Ubuntu" pitchFamily="34" charset="0"/>
+                        <a:rPr lang="en-GB" sz="800" u="none" strike="noStrike" cap="none">
+                          <a:latin typeface="Ubuntu" panose="020B0504030602030204" pitchFamily="34" charset="0"/>
                         </a:rPr>
                         <a:t>no</a:t>
                       </a:r>
                       <a:endParaRPr sz="800" u="none" strike="noStrike" cap="none">
-                        <a:latin typeface="Ubuntu" pitchFamily="34" charset="0"/>
+                        <a:latin typeface="Ubuntu" panose="020B0504030602030204" pitchFamily="34" charset="0"/>
                       </a:endParaRPr>
                     </a:p>
                   </a:txBody>
@@ -4620,13 +4528,13 @@
                         <a:buNone/>
                       </a:pPr>
                       <a:r>
-                        <a:rPr lang="en" sz="800" u="none" strike="noStrike" cap="none">
-                          <a:latin typeface="Ubuntu" pitchFamily="34" charset="0"/>
+                        <a:rPr lang="en-GB" sz="800" u="none" strike="noStrike" cap="none">
+                          <a:latin typeface="Ubuntu" panose="020B0504030602030204" pitchFamily="34" charset="0"/>
                         </a:rPr>
                         <a:t>yes</a:t>
                       </a:r>
                       <a:endParaRPr sz="800" u="none" strike="noStrike" cap="none">
-                        <a:latin typeface="Ubuntu" pitchFamily="34" charset="0"/>
+                        <a:latin typeface="Ubuntu" panose="020B0504030602030204" pitchFamily="34" charset="0"/>
                       </a:endParaRPr>
                     </a:p>
                   </a:txBody>
@@ -4654,13 +4562,13 @@
                         <a:buNone/>
                       </a:pPr>
                       <a:r>
-                        <a:rPr lang="en" sz="800" u="none" strike="noStrike" cap="none" dirty="0">
-                          <a:latin typeface="Ubuntu" pitchFamily="34" charset="0"/>
+                        <a:rPr lang="en-GB" sz="800" u="none" strike="noStrike" cap="none" dirty="0">
+                          <a:latin typeface="Ubuntu" panose="020B0504030602030204" pitchFamily="34" charset="0"/>
                         </a:rPr>
                         <a:t>uint16</a:t>
                       </a:r>
                       <a:endParaRPr dirty="0">
-                        <a:latin typeface="Ubuntu" pitchFamily="34" charset="0"/>
+                        <a:latin typeface="Ubuntu" panose="020B0504030602030204" pitchFamily="34" charset="0"/>
                       </a:endParaRPr>
                     </a:p>
                   </a:txBody>
@@ -4670,11 +4578,6 @@
                     </a:solidFill>
                   </a:tcPr>
                 </a:tc>
-                <a:extLst>
-                  <a:ext uri="{0D108BD9-81ED-4DB2-BD59-A6C34878D82A}">
-                    <a16:rowId xmlns:a16="http://schemas.microsoft.com/office/drawing/2014/main" val="10007"/>
-                  </a:ext>
-                </a:extLst>
               </a:tr>
               <a:tr h="214565">
                 <a:tc>
@@ -4695,8 +4598,8 @@
                         <a:buNone/>
                       </a:pPr>
                       <a:r>
-                        <a:rPr lang="en" sz="800" u="none" strike="noStrike" cap="none">
-                          <a:latin typeface="Ubuntu" pitchFamily="34" charset="0"/>
+                        <a:rPr lang="en-GB" sz="800" u="none" strike="noStrike" cap="none">
+                          <a:latin typeface="Ubuntu" panose="020B0504030602030204" pitchFamily="34" charset="0"/>
                           <a:ea typeface="Consolas"/>
                           <a:cs typeface="Consolas"/>
                           <a:sym typeface="Consolas"/>
@@ -4704,7 +4607,7 @@
                         <a:t>I</a:t>
                       </a:r>
                       <a:endParaRPr sz="800" u="none" strike="noStrike" cap="none">
-                        <a:latin typeface="Ubuntu" pitchFamily="34" charset="0"/>
+                        <a:latin typeface="Ubuntu" panose="020B0504030602030204" pitchFamily="34" charset="0"/>
                         <a:ea typeface="Consolas"/>
                         <a:cs typeface="Consolas"/>
                         <a:sym typeface="Consolas"/>
@@ -4735,13 +4638,13 @@
                         <a:buNone/>
                       </a:pPr>
                       <a:r>
-                        <a:rPr lang="en" sz="800" u="none" strike="noStrike" cap="none">
-                          <a:latin typeface="Ubuntu" pitchFamily="34" charset="0"/>
+                        <a:rPr lang="en-GB" sz="800" u="none" strike="noStrike" cap="none">
+                          <a:latin typeface="Ubuntu" panose="020B0504030602030204" pitchFamily="34" charset="0"/>
                         </a:rPr>
                         <a:t>no</a:t>
                       </a:r>
                       <a:endParaRPr sz="800" u="none" strike="noStrike" cap="none">
-                        <a:latin typeface="Ubuntu" pitchFamily="34" charset="0"/>
+                        <a:latin typeface="Ubuntu" panose="020B0504030602030204" pitchFamily="34" charset="0"/>
                       </a:endParaRPr>
                     </a:p>
                   </a:txBody>
@@ -4769,13 +4672,13 @@
                         <a:buNone/>
                       </a:pPr>
                       <a:r>
-                        <a:rPr lang="en" sz="800" u="none" strike="noStrike" cap="none" dirty="0">
-                          <a:latin typeface="Ubuntu" pitchFamily="34" charset="0"/>
+                        <a:rPr lang="en-GB" sz="800" u="none" strike="noStrike" cap="none" dirty="0">
+                          <a:latin typeface="Ubuntu" panose="020B0504030602030204" pitchFamily="34" charset="0"/>
                         </a:rPr>
                         <a:t>yes</a:t>
                       </a:r>
                       <a:endParaRPr sz="800" u="none" strike="noStrike" cap="none" dirty="0">
-                        <a:latin typeface="Ubuntu" pitchFamily="34" charset="0"/>
+                        <a:latin typeface="Ubuntu" panose="020B0504030602030204" pitchFamily="34" charset="0"/>
                       </a:endParaRPr>
                     </a:p>
                   </a:txBody>
@@ -4803,13 +4706,13 @@
                         <a:buNone/>
                       </a:pPr>
                       <a:r>
-                        <a:rPr lang="en" sz="800" u="none" strike="noStrike" cap="none" dirty="0">
-                          <a:latin typeface="Ubuntu" pitchFamily="34" charset="0"/>
+                        <a:rPr lang="en-GB" sz="800" u="none" strike="noStrike" cap="none" dirty="0">
+                          <a:latin typeface="Ubuntu" panose="020B0504030602030204" pitchFamily="34" charset="0"/>
                         </a:rPr>
                         <a:t>int16</a:t>
                       </a:r>
                       <a:endParaRPr dirty="0">
-                        <a:latin typeface="Ubuntu" pitchFamily="34" charset="0"/>
+                        <a:latin typeface="Ubuntu" panose="020B0504030602030204" pitchFamily="34" charset="0"/>
                       </a:endParaRPr>
                     </a:p>
                   </a:txBody>
@@ -4819,11 +4722,6 @@
                     </a:solidFill>
                   </a:tcPr>
                 </a:tc>
-                <a:extLst>
-                  <a:ext uri="{0D108BD9-81ED-4DB2-BD59-A6C34878D82A}">
-                    <a16:rowId xmlns:a16="http://schemas.microsoft.com/office/drawing/2014/main" val="10008"/>
-                  </a:ext>
-                </a:extLst>
               </a:tr>
               <a:tr h="214565">
                 <a:tc>
@@ -4844,11 +4742,11 @@
                         <a:buNone/>
                       </a:pPr>
                       <a:r>
-                        <a:rPr lang="en" sz="800" u="none" strike="noStrike" cap="none">
+                        <a:rPr lang="en-GB" sz="800" u="none" strike="noStrike" cap="none">
                           <a:solidFill>
                             <a:srgbClr val="FF0000"/>
                           </a:solidFill>
-                          <a:latin typeface="Ubuntu" pitchFamily="34" charset="0"/>
+                          <a:latin typeface="Ubuntu" panose="020B0504030602030204" pitchFamily="34" charset="0"/>
                           <a:ea typeface="Consolas"/>
                           <a:cs typeface="Consolas"/>
                           <a:sym typeface="Consolas"/>
@@ -4859,7 +4757,7 @@
                         <a:solidFill>
                           <a:srgbClr val="FF0000"/>
                         </a:solidFill>
-                        <a:latin typeface="Ubuntu" pitchFamily="34" charset="0"/>
+                        <a:latin typeface="Ubuntu" panose="020B0504030602030204" pitchFamily="34" charset="0"/>
                         <a:ea typeface="Consolas"/>
                         <a:cs typeface="Consolas"/>
                         <a:sym typeface="Consolas"/>
@@ -4890,13 +4788,13 @@
                         <a:buNone/>
                       </a:pPr>
                       <a:r>
-                        <a:rPr lang="en" sz="800" u="none" strike="noStrike" cap="none">
-                          <a:latin typeface="Ubuntu" pitchFamily="34" charset="0"/>
+                        <a:rPr lang="en-GB" sz="800" u="none" strike="noStrike" cap="none">
+                          <a:latin typeface="Ubuntu" panose="020B0504030602030204" pitchFamily="34" charset="0"/>
                         </a:rPr>
                         <a:t>no</a:t>
                       </a:r>
                       <a:endParaRPr sz="800" u="none" strike="noStrike" cap="none">
-                        <a:latin typeface="Ubuntu" pitchFamily="34" charset="0"/>
+                        <a:latin typeface="Ubuntu" panose="020B0504030602030204" pitchFamily="34" charset="0"/>
                       </a:endParaRPr>
                     </a:p>
                   </a:txBody>
@@ -4924,13 +4822,13 @@
                         <a:buNone/>
                       </a:pPr>
                       <a:r>
-                        <a:rPr lang="en" sz="800" u="none" strike="noStrike" cap="none">
-                          <a:latin typeface="Ubuntu" pitchFamily="34" charset="0"/>
+                        <a:rPr lang="en-GB" sz="800" u="none" strike="noStrike" cap="none">
+                          <a:latin typeface="Ubuntu" panose="020B0504030602030204" pitchFamily="34" charset="0"/>
                         </a:rPr>
                         <a:t>yes</a:t>
                       </a:r>
                       <a:endParaRPr sz="800" u="none" strike="noStrike" cap="none">
-                        <a:latin typeface="Ubuntu" pitchFamily="34" charset="0"/>
+                        <a:latin typeface="Ubuntu" panose="020B0504030602030204" pitchFamily="34" charset="0"/>
                       </a:endParaRPr>
                     </a:p>
                   </a:txBody>
@@ -4958,13 +4856,13 @@
                         <a:buNone/>
                       </a:pPr>
                       <a:r>
-                        <a:rPr lang="en" sz="800" u="none" strike="noStrike" cap="none" dirty="0">
-                          <a:latin typeface="Ubuntu" pitchFamily="34" charset="0"/>
+                        <a:rPr lang="en-GB" sz="800" u="none" strike="noStrike" cap="none" dirty="0">
+                          <a:latin typeface="Ubuntu" panose="020B0504030602030204" pitchFamily="34" charset="0"/>
                         </a:rPr>
                         <a:t>uint32</a:t>
                       </a:r>
                       <a:endParaRPr dirty="0">
-                        <a:latin typeface="Ubuntu" pitchFamily="34" charset="0"/>
+                        <a:latin typeface="Ubuntu" panose="020B0504030602030204" pitchFamily="34" charset="0"/>
                       </a:endParaRPr>
                     </a:p>
                   </a:txBody>
@@ -4974,11 +4872,6 @@
                     </a:solidFill>
                   </a:tcPr>
                 </a:tc>
-                <a:extLst>
-                  <a:ext uri="{0D108BD9-81ED-4DB2-BD59-A6C34878D82A}">
-                    <a16:rowId xmlns:a16="http://schemas.microsoft.com/office/drawing/2014/main" val="10009"/>
-                  </a:ext>
-                </a:extLst>
               </a:tr>
               <a:tr h="214565">
                 <a:tc>
@@ -4999,8 +4892,8 @@
                         <a:buNone/>
                       </a:pPr>
                       <a:r>
-                        <a:rPr lang="en" sz="800" u="none" strike="noStrike" cap="none">
-                          <a:latin typeface="Ubuntu" pitchFamily="34" charset="0"/>
+                        <a:rPr lang="en-GB" sz="800" u="none" strike="noStrike" cap="none">
+                          <a:latin typeface="Ubuntu" panose="020B0504030602030204" pitchFamily="34" charset="0"/>
                           <a:ea typeface="Consolas"/>
                           <a:cs typeface="Consolas"/>
                           <a:sym typeface="Consolas"/>
@@ -5008,7 +4901,7 @@
                         <a:t>l</a:t>
                       </a:r>
                       <a:endParaRPr sz="800" u="none" strike="noStrike" cap="none">
-                        <a:latin typeface="Ubuntu" pitchFamily="34" charset="0"/>
+                        <a:latin typeface="Ubuntu" panose="020B0504030602030204" pitchFamily="34" charset="0"/>
                         <a:ea typeface="Consolas"/>
                         <a:cs typeface="Consolas"/>
                         <a:sym typeface="Consolas"/>
@@ -5039,13 +4932,13 @@
                         <a:buNone/>
                       </a:pPr>
                       <a:r>
-                        <a:rPr lang="en" sz="800" u="none" strike="noStrike" cap="none">
-                          <a:latin typeface="Ubuntu" pitchFamily="34" charset="0"/>
+                        <a:rPr lang="en-GB" sz="800" u="none" strike="noStrike" cap="none">
+                          <a:latin typeface="Ubuntu" panose="020B0504030602030204" pitchFamily="34" charset="0"/>
                         </a:rPr>
                         <a:t>no</a:t>
                       </a:r>
                       <a:endParaRPr sz="800" u="none" strike="noStrike" cap="none">
-                        <a:latin typeface="Ubuntu" pitchFamily="34" charset="0"/>
+                        <a:latin typeface="Ubuntu" panose="020B0504030602030204" pitchFamily="34" charset="0"/>
                       </a:endParaRPr>
                     </a:p>
                   </a:txBody>
@@ -5073,13 +4966,13 @@
                         <a:buNone/>
                       </a:pPr>
                       <a:r>
-                        <a:rPr lang="en" sz="800" u="none" strike="noStrike" cap="none">
-                          <a:latin typeface="Ubuntu" pitchFamily="34" charset="0"/>
+                        <a:rPr lang="en-GB" sz="800" u="none" strike="noStrike" cap="none">
+                          <a:latin typeface="Ubuntu" panose="020B0504030602030204" pitchFamily="34" charset="0"/>
                         </a:rPr>
                         <a:t>yes</a:t>
                       </a:r>
                       <a:endParaRPr sz="800" u="none" strike="noStrike" cap="none">
-                        <a:latin typeface="Ubuntu" pitchFamily="34" charset="0"/>
+                        <a:latin typeface="Ubuntu" panose="020B0504030602030204" pitchFamily="34" charset="0"/>
                       </a:endParaRPr>
                     </a:p>
                   </a:txBody>
@@ -5107,13 +5000,13 @@
                         <a:buNone/>
                       </a:pPr>
                       <a:r>
-                        <a:rPr lang="en" sz="800" u="none" strike="noStrike" cap="none" dirty="0">
-                          <a:latin typeface="Ubuntu" pitchFamily="34" charset="0"/>
+                        <a:rPr lang="en-GB" sz="800" u="none" strike="noStrike" cap="none" dirty="0">
+                          <a:latin typeface="Ubuntu" panose="020B0504030602030204" pitchFamily="34" charset="0"/>
                         </a:rPr>
                         <a:t>int32</a:t>
                       </a:r>
                       <a:endParaRPr dirty="0">
-                        <a:latin typeface="Ubuntu" pitchFamily="34" charset="0"/>
+                        <a:latin typeface="Ubuntu" panose="020B0504030602030204" pitchFamily="34" charset="0"/>
                       </a:endParaRPr>
                     </a:p>
                   </a:txBody>
@@ -5123,11 +5016,6 @@
                     </a:solidFill>
                   </a:tcPr>
                 </a:tc>
-                <a:extLst>
-                  <a:ext uri="{0D108BD9-81ED-4DB2-BD59-A6C34878D82A}">
-                    <a16:rowId xmlns:a16="http://schemas.microsoft.com/office/drawing/2014/main" val="10010"/>
-                  </a:ext>
-                </a:extLst>
               </a:tr>
               <a:tr h="214565">
                 <a:tc>
@@ -5148,11 +5036,11 @@
                         <a:buNone/>
                       </a:pPr>
                       <a:r>
-                        <a:rPr lang="en" sz="800" u="none" strike="noStrike" cap="none">
+                        <a:rPr lang="en-GB" sz="800" u="none" strike="noStrike" cap="none">
                           <a:solidFill>
                             <a:srgbClr val="FF0000"/>
                           </a:solidFill>
-                          <a:latin typeface="Ubuntu" pitchFamily="34" charset="0"/>
+                          <a:latin typeface="Ubuntu" panose="020B0504030602030204" pitchFamily="34" charset="0"/>
                           <a:ea typeface="Consolas"/>
                           <a:cs typeface="Consolas"/>
                           <a:sym typeface="Consolas"/>
@@ -5163,7 +5051,7 @@
                         <a:solidFill>
                           <a:srgbClr val="FF0000"/>
                         </a:solidFill>
-                        <a:latin typeface="Ubuntu" pitchFamily="34" charset="0"/>
+                        <a:latin typeface="Ubuntu" panose="020B0504030602030204" pitchFamily="34" charset="0"/>
                         <a:ea typeface="Consolas"/>
                         <a:cs typeface="Consolas"/>
                         <a:sym typeface="Consolas"/>
@@ -5194,13 +5082,13 @@
                         <a:buNone/>
                       </a:pPr>
                       <a:r>
-                        <a:rPr lang="en" sz="800" u="none" strike="noStrike" cap="none">
-                          <a:latin typeface="Ubuntu" pitchFamily="34" charset="0"/>
+                        <a:rPr lang="en-GB" sz="800" u="none" strike="noStrike" cap="none">
+                          <a:latin typeface="Ubuntu" panose="020B0504030602030204" pitchFamily="34" charset="0"/>
                         </a:rPr>
                         <a:t>no</a:t>
                       </a:r>
                       <a:endParaRPr sz="800" u="none" strike="noStrike" cap="none">
-                        <a:latin typeface="Ubuntu" pitchFamily="34" charset="0"/>
+                        <a:latin typeface="Ubuntu" panose="020B0504030602030204" pitchFamily="34" charset="0"/>
                       </a:endParaRPr>
                     </a:p>
                   </a:txBody>
@@ -5228,13 +5116,13 @@
                         <a:buNone/>
                       </a:pPr>
                       <a:r>
-                        <a:rPr lang="en" sz="800" u="none" strike="noStrike" cap="none">
-                          <a:latin typeface="Ubuntu" pitchFamily="34" charset="0"/>
+                        <a:rPr lang="en-GB" sz="800" u="none" strike="noStrike" cap="none">
+                          <a:latin typeface="Ubuntu" panose="020B0504030602030204" pitchFamily="34" charset="0"/>
                         </a:rPr>
                         <a:t>yes</a:t>
                       </a:r>
                       <a:endParaRPr sz="800" u="none" strike="noStrike" cap="none">
-                        <a:latin typeface="Ubuntu" pitchFamily="34" charset="0"/>
+                        <a:latin typeface="Ubuntu" panose="020B0504030602030204" pitchFamily="34" charset="0"/>
                       </a:endParaRPr>
                     </a:p>
                   </a:txBody>
@@ -5262,13 +5150,13 @@
                         <a:buNone/>
                       </a:pPr>
                       <a:r>
-                        <a:rPr lang="en" sz="800" u="none" strike="noStrike" cap="none" dirty="0">
-                          <a:latin typeface="Ubuntu" pitchFamily="34" charset="0"/>
+                        <a:rPr lang="en-GB" sz="800" u="none" strike="noStrike" cap="none" dirty="0">
+                          <a:latin typeface="Ubuntu" panose="020B0504030602030204" pitchFamily="34" charset="0"/>
                         </a:rPr>
                         <a:t>uint64</a:t>
                       </a:r>
                       <a:endParaRPr dirty="0">
-                        <a:latin typeface="Ubuntu" pitchFamily="34" charset="0"/>
+                        <a:latin typeface="Ubuntu" panose="020B0504030602030204" pitchFamily="34" charset="0"/>
                       </a:endParaRPr>
                     </a:p>
                   </a:txBody>
@@ -5278,11 +5166,6 @@
                     </a:solidFill>
                   </a:tcPr>
                 </a:tc>
-                <a:extLst>
-                  <a:ext uri="{0D108BD9-81ED-4DB2-BD59-A6C34878D82A}">
-                    <a16:rowId xmlns:a16="http://schemas.microsoft.com/office/drawing/2014/main" val="10011"/>
-                  </a:ext>
-                </a:extLst>
               </a:tr>
               <a:tr h="214565">
                 <a:tc>
@@ -5303,8 +5186,8 @@
                         <a:buNone/>
                       </a:pPr>
                       <a:r>
-                        <a:rPr lang="en" sz="800" u="none" strike="noStrike" cap="none" dirty="0">
-                          <a:latin typeface="Ubuntu" pitchFamily="34" charset="0"/>
+                        <a:rPr lang="en-GB" sz="800" u="none" strike="noStrike" cap="none" dirty="0">
+                          <a:latin typeface="Ubuntu" panose="020B0504030602030204" pitchFamily="34" charset="0"/>
                           <a:ea typeface="Consolas"/>
                           <a:cs typeface="Consolas"/>
                           <a:sym typeface="Consolas"/>
@@ -5312,7 +5195,7 @@
                         <a:t>L</a:t>
                       </a:r>
                       <a:endParaRPr sz="800" u="none" strike="noStrike" cap="none" dirty="0">
-                        <a:latin typeface="Ubuntu" pitchFamily="34" charset="0"/>
+                        <a:latin typeface="Ubuntu" panose="020B0504030602030204" pitchFamily="34" charset="0"/>
                         <a:ea typeface="Consolas"/>
                         <a:cs typeface="Consolas"/>
                         <a:sym typeface="Consolas"/>
@@ -5343,13 +5226,13 @@
                         <a:buNone/>
                       </a:pPr>
                       <a:r>
-                        <a:rPr lang="en" sz="800" u="none" strike="noStrike" cap="none" dirty="0">
-                          <a:latin typeface="Ubuntu" pitchFamily="34" charset="0"/>
+                        <a:rPr lang="en-GB" sz="800" u="none" strike="noStrike" cap="none" dirty="0">
+                          <a:latin typeface="Ubuntu" panose="020B0504030602030204" pitchFamily="34" charset="0"/>
                         </a:rPr>
                         <a:t>no</a:t>
                       </a:r>
                       <a:endParaRPr sz="800" u="none" strike="noStrike" cap="none" dirty="0">
-                        <a:latin typeface="Ubuntu" pitchFamily="34" charset="0"/>
+                        <a:latin typeface="Ubuntu" panose="020B0504030602030204" pitchFamily="34" charset="0"/>
                       </a:endParaRPr>
                     </a:p>
                   </a:txBody>
@@ -5377,13 +5260,13 @@
                         <a:buNone/>
                       </a:pPr>
                       <a:r>
-                        <a:rPr lang="en" sz="800" u="none" strike="noStrike" cap="none" dirty="0">
-                          <a:latin typeface="Ubuntu" pitchFamily="34" charset="0"/>
+                        <a:rPr lang="en-GB" sz="800" u="none" strike="noStrike" cap="none" dirty="0">
+                          <a:latin typeface="Ubuntu" panose="020B0504030602030204" pitchFamily="34" charset="0"/>
                         </a:rPr>
                         <a:t>yes</a:t>
                       </a:r>
                       <a:endParaRPr sz="800" u="none" strike="noStrike" cap="none" dirty="0">
-                        <a:latin typeface="Ubuntu" pitchFamily="34" charset="0"/>
+                        <a:latin typeface="Ubuntu" panose="020B0504030602030204" pitchFamily="34" charset="0"/>
                       </a:endParaRPr>
                     </a:p>
                   </a:txBody>
@@ -5411,13 +5294,13 @@
                         <a:buNone/>
                       </a:pPr>
                       <a:r>
-                        <a:rPr lang="en" sz="800" u="none" strike="noStrike" cap="none" dirty="0">
-                          <a:latin typeface="Ubuntu" pitchFamily="34" charset="0"/>
+                        <a:rPr lang="en-GB" sz="800" u="none" strike="noStrike" cap="none" dirty="0">
+                          <a:latin typeface="Ubuntu" panose="020B0504030602030204" pitchFamily="34" charset="0"/>
                         </a:rPr>
                         <a:t>int64</a:t>
                       </a:r>
                       <a:endParaRPr dirty="0">
-                        <a:latin typeface="Ubuntu" pitchFamily="34" charset="0"/>
+                        <a:latin typeface="Ubuntu" panose="020B0504030602030204" pitchFamily="34" charset="0"/>
                       </a:endParaRPr>
                     </a:p>
                   </a:txBody>
@@ -5427,11 +5310,6 @@
                     </a:solidFill>
                   </a:tcPr>
                 </a:tc>
-                <a:extLst>
-                  <a:ext uri="{0D108BD9-81ED-4DB2-BD59-A6C34878D82A}">
-                    <a16:rowId xmlns:a16="http://schemas.microsoft.com/office/drawing/2014/main" val="10012"/>
-                  </a:ext>
-                </a:extLst>
               </a:tr>
               <a:tr h="214565">
                 <a:tc>
@@ -5452,11 +5330,11 @@
                         <a:buNone/>
                       </a:pPr>
                       <a:r>
-                        <a:rPr lang="en" sz="800" u="none" strike="noStrike" cap="none" dirty="0">
+                        <a:rPr lang="en-GB" sz="800" u="none" strike="noStrike" cap="none" dirty="0">
                           <a:solidFill>
                             <a:srgbClr val="FF0000"/>
                           </a:solidFill>
-                          <a:latin typeface="Ubuntu" pitchFamily="34" charset="0"/>
+                          <a:latin typeface="Ubuntu" panose="020B0504030602030204" pitchFamily="34" charset="0"/>
                           <a:ea typeface="Consolas"/>
                           <a:cs typeface="Consolas"/>
                           <a:sym typeface="Consolas"/>
@@ -5467,7 +5345,7 @@
                         <a:solidFill>
                           <a:srgbClr val="FF0000"/>
                         </a:solidFill>
-                        <a:latin typeface="Ubuntu" pitchFamily="34" charset="0"/>
+                        <a:latin typeface="Ubuntu" panose="020B0504030602030204" pitchFamily="34" charset="0"/>
                         <a:ea typeface="Consolas"/>
                         <a:cs typeface="Consolas"/>
                         <a:sym typeface="Consolas"/>
@@ -5498,13 +5376,13 @@
                         <a:buNone/>
                       </a:pPr>
                       <a:r>
-                        <a:rPr lang="en" sz="800" u="none" strike="noStrike" cap="none" dirty="0">
-                          <a:latin typeface="Ubuntu" pitchFamily="34" charset="0"/>
+                        <a:rPr lang="en-GB" sz="800" u="none" strike="noStrike" cap="none" dirty="0">
+                          <a:latin typeface="Ubuntu" panose="020B0504030602030204" pitchFamily="34" charset="0"/>
                         </a:rPr>
                         <a:t>no</a:t>
                       </a:r>
                       <a:endParaRPr sz="800" u="none" strike="noStrike" cap="none" dirty="0">
-                        <a:latin typeface="Ubuntu" pitchFamily="34" charset="0"/>
+                        <a:latin typeface="Ubuntu" panose="020B0504030602030204" pitchFamily="34" charset="0"/>
                       </a:endParaRPr>
                     </a:p>
                   </a:txBody>
@@ -5532,13 +5410,13 @@
                         <a:buNone/>
                       </a:pPr>
                       <a:r>
-                        <a:rPr lang="en" sz="800" u="none" strike="noStrike" cap="none" dirty="0">
-                          <a:latin typeface="Ubuntu" pitchFamily="34" charset="0"/>
+                        <a:rPr lang="en-GB" sz="800" u="none" strike="noStrike" cap="none" dirty="0">
+                          <a:latin typeface="Ubuntu" panose="020B0504030602030204" pitchFamily="34" charset="0"/>
                         </a:rPr>
                         <a:t>yes</a:t>
                       </a:r>
                       <a:endParaRPr sz="800" u="none" strike="noStrike" cap="none" dirty="0">
-                        <a:latin typeface="Ubuntu" pitchFamily="34" charset="0"/>
+                        <a:latin typeface="Ubuntu" panose="020B0504030602030204" pitchFamily="34" charset="0"/>
                       </a:endParaRPr>
                     </a:p>
                   </a:txBody>
@@ -5566,13 +5444,13 @@
                         <a:buNone/>
                       </a:pPr>
                       <a:r>
-                        <a:rPr lang="en" sz="800" u="none" strike="noStrike" cap="none" dirty="0">
-                          <a:latin typeface="Ubuntu" pitchFamily="34" charset="0"/>
+                        <a:rPr lang="en-GB" sz="800" u="none" strike="noStrike" cap="none" dirty="0">
+                          <a:latin typeface="Ubuntu" panose="020B0504030602030204" pitchFamily="34" charset="0"/>
                         </a:rPr>
                         <a:t>float16 (half)</a:t>
                       </a:r>
                       <a:endParaRPr sz="800" u="none" strike="noStrike" cap="none" dirty="0">
-                        <a:latin typeface="Ubuntu" pitchFamily="34" charset="0"/>
+                        <a:latin typeface="Ubuntu" panose="020B0504030602030204" pitchFamily="34" charset="0"/>
                       </a:endParaRPr>
                     </a:p>
                   </a:txBody>
@@ -5582,11 +5460,6 @@
                     </a:solidFill>
                   </a:tcPr>
                 </a:tc>
-                <a:extLst>
-                  <a:ext uri="{0D108BD9-81ED-4DB2-BD59-A6C34878D82A}">
-                    <a16:rowId xmlns:a16="http://schemas.microsoft.com/office/drawing/2014/main" val="2589933068"/>
-                  </a:ext>
-                </a:extLst>
               </a:tr>
               <a:tr h="245206">
                 <a:tc gridSpan="4">
@@ -5607,149 +5480,155 @@
                         <a:buNone/>
                       </a:pPr>
                       <a:r>
-                        <a:rPr lang="en" sz="800" u="none" strike="noStrike" cap="none" dirty="0">
+                        <a:rPr lang="en-GB" sz="800" u="none" strike="noStrike" cap="none" dirty="0">
                           <a:solidFill>
                             <a:schemeClr val="tx1"/>
                           </a:solidFill>
-                          <a:latin typeface="Ubuntu" pitchFamily="34" charset="0"/>
-                          <a:ea typeface="Arial"/>
-                          <a:cs typeface="Arial"/>
-                          <a:sym typeface="Arial"/>
+                          <a:latin typeface="Ubuntu" panose="020B0504030602030204" pitchFamily="34" charset="0"/>
+                          <a:ea typeface="Arial" panose="020B0604020202020204"/>
+                          <a:cs typeface="Arial" panose="020B0604020202020204"/>
+                          <a:sym typeface="Arial" panose="020B0604020202020204"/>
                         </a:rPr>
                         <a:t>-</a:t>
                       </a:r>
                       <a:r>
-                        <a:rPr lang="en" sz="800" u="none" strike="noStrike" cap="none" dirty="0">
+                        <a:rPr lang="en-GB" sz="800" u="none" strike="noStrike" cap="none" dirty="0">
                           <a:solidFill>
                             <a:srgbClr val="FF0000"/>
                           </a:solidFill>
-                          <a:latin typeface="Ubuntu" pitchFamily="34" charset="0"/>
-                          <a:ea typeface="Arial"/>
-                          <a:cs typeface="Arial"/>
-                          <a:sym typeface="Arial"/>
+                          <a:latin typeface="Ubuntu" panose="020B0504030602030204" pitchFamily="34" charset="0"/>
+                          <a:ea typeface="Arial" panose="020B0604020202020204"/>
+                          <a:cs typeface="Arial" panose="020B0604020202020204"/>
+                          <a:sym typeface="Arial" panose="020B0604020202020204"/>
                         </a:rPr>
                         <a:t> in red </a:t>
                       </a:r>
                       <a:r>
-                        <a:rPr lang="en" sz="800" u="none" strike="noStrike" cap="none" dirty="0">
-                          <a:latin typeface="Ubuntu" pitchFamily="34" charset="0"/>
-                          <a:ea typeface="Arial"/>
-                          <a:cs typeface="Arial"/>
-                          <a:sym typeface="Arial"/>
+                        <a:rPr lang="en-GB" sz="800" u="none" strike="noStrike" cap="none" dirty="0">
+                          <a:latin typeface="Ubuntu" panose="020B0504030602030204" pitchFamily="34" charset="0"/>
+                          <a:ea typeface="Arial" panose="020B0604020202020204"/>
+                          <a:cs typeface="Arial" panose="020B0604020202020204"/>
+                          <a:sym typeface="Arial" panose="020B0604020202020204"/>
                         </a:rPr>
                         <a:t>– extended type/syntax by BJData from UBJSON (</a:t>
                       </a:r>
                       <a:r>
-                        <a:rPr lang="en" sz="800" u="none" strike="noStrike" cap="none" dirty="0">
-                          <a:latin typeface="Ubuntu" pitchFamily="34" charset="0"/>
-                          <a:ea typeface="Arial"/>
-                          <a:cs typeface="Arial"/>
-                          <a:sym typeface="Arial"/>
-                          <a:hlinkClick r:id="rId3"/>
+                        <a:rPr lang="en-GB" sz="800" u="none" strike="noStrike" cap="none" dirty="0">
+                          <a:latin typeface="Ubuntu" panose="020B0504030602030204" pitchFamily="34" charset="0"/>
+                          <a:ea typeface="Arial" panose="020B0604020202020204"/>
+                          <a:cs typeface="Arial" panose="020B0604020202020204"/>
+                          <a:sym typeface="Arial" panose="020B0604020202020204"/>
+                          <a:hlinkClick r:id="rId2"/>
                         </a:rPr>
                         <a:t>https://ubjson.org</a:t>
                       </a:r>
                       <a:r>
-                        <a:rPr lang="en" sz="800" u="none" strike="noStrike" cap="none" dirty="0">
-                          <a:latin typeface="Ubuntu" pitchFamily="34" charset="0"/>
-                          <a:ea typeface="Arial"/>
-                          <a:cs typeface="Arial"/>
-                          <a:sym typeface="Arial"/>
+                        <a:rPr lang="en-GB" sz="800" u="none" strike="noStrike" cap="none" dirty="0">
+                          <a:latin typeface="Ubuntu" panose="020B0504030602030204" pitchFamily="34" charset="0"/>
+                          <a:ea typeface="Arial" panose="020B0604020202020204"/>
+                          <a:cs typeface="Arial" panose="020B0604020202020204"/>
+                          <a:sym typeface="Arial" panose="020B0604020202020204"/>
                         </a:rPr>
                         <a:t>)</a:t>
                       </a:r>
                       <a:r>
-                        <a:rPr lang="en" sz="800" dirty="0">
-                          <a:latin typeface="Ubuntu" pitchFamily="34" charset="0"/>
+                        <a:rPr lang="en-GB" sz="800" dirty="0">
+                          <a:latin typeface="Ubuntu" panose="020B0504030602030204" pitchFamily="34" charset="0"/>
                         </a:rPr>
                         <a:t>;</a:t>
                       </a:r>
                       <a:r>
-                        <a:rPr lang="en" sz="800" u="none" strike="noStrike" cap="none" dirty="0">
-                          <a:latin typeface="Ubuntu" pitchFamily="34" charset="0"/>
-                          <a:ea typeface="Arial"/>
-                          <a:cs typeface="Arial"/>
-                          <a:sym typeface="Arial"/>
+                        <a:rPr lang="en-GB" sz="800" u="none" strike="noStrike" cap="none" dirty="0">
+                          <a:latin typeface="Ubuntu" panose="020B0504030602030204" pitchFamily="34" charset="0"/>
+                          <a:ea typeface="Arial" panose="020B0604020202020204"/>
+                          <a:cs typeface="Arial" panose="020B0604020202020204"/>
+                          <a:sym typeface="Arial" panose="020B0604020202020204"/>
                         </a:rPr>
                         <a:t> </a:t>
                       </a:r>
-                    </a:p>
-                    <a:p>
-                      <a:pPr marL="0" marR="0" lvl="0" indent="0" algn="l" rtl="0">
-                        <a:lnSpc>
-                          <a:spcPct val="100000"/>
-                        </a:lnSpc>
-                        <a:spcBef>
-                          <a:spcPts val="0"/>
-                        </a:spcBef>
-                        <a:spcAft>
-                          <a:spcPts val="0"/>
-                        </a:spcAft>
-                        <a:buNone/>
-                      </a:pPr>
-                      <a:r>
-                        <a:rPr lang="en" sz="800" u="none" strike="noStrike" cap="none" dirty="0">
-                          <a:latin typeface="Ubuntu" pitchFamily="34" charset="0"/>
-                          <a:ea typeface="Arial"/>
-                          <a:cs typeface="Arial"/>
-                          <a:sym typeface="Arial"/>
+                      <a:endParaRPr lang="en-GB" sz="800" u="none" strike="noStrike" cap="none" dirty="0">
+                        <a:latin typeface="Ubuntu" panose="020B0504030602030204" pitchFamily="34" charset="0"/>
+                        <a:ea typeface="Arial" panose="020B0604020202020204"/>
+                        <a:cs typeface="Arial" panose="020B0604020202020204"/>
+                        <a:sym typeface="Arial" panose="020B0604020202020204"/>
+                      </a:endParaRPr>
+                    </a:p>
+                    <a:p>
+                      <a:pPr marL="0" marR="0" lvl="0" indent="0" algn="l" rtl="0">
+                        <a:lnSpc>
+                          <a:spcPct val="100000"/>
+                        </a:lnSpc>
+                        <a:spcBef>
+                          <a:spcPts val="0"/>
+                        </a:spcBef>
+                        <a:spcAft>
+                          <a:spcPts val="0"/>
+                        </a:spcAft>
+                        <a:buNone/>
+                      </a:pPr>
+                      <a:r>
+                        <a:rPr lang="en-GB" sz="800" u="none" strike="noStrike" cap="none" dirty="0">
+                          <a:latin typeface="Ubuntu" panose="020B0504030602030204" pitchFamily="34" charset="0"/>
+                          <a:ea typeface="Arial" panose="020B0604020202020204"/>
+                          <a:cs typeface="Arial" panose="020B0604020202020204"/>
+                          <a:sym typeface="Arial" panose="020B0604020202020204"/>
                         </a:rPr>
                         <a:t>- all</a:t>
                       </a:r>
                       <a:r>
-                        <a:rPr lang="en" sz="800" u="none" strike="noStrike" cap="none" baseline="0" dirty="0">
-                          <a:latin typeface="Ubuntu" pitchFamily="34" charset="0"/>
-                          <a:ea typeface="Arial"/>
-                          <a:cs typeface="Arial"/>
-                          <a:sym typeface="Arial"/>
+                        <a:rPr lang="en-GB" sz="800" u="none" strike="noStrike" cap="none" baseline="0" dirty="0">
+                          <a:latin typeface="Ubuntu" panose="020B0504030602030204" pitchFamily="34" charset="0"/>
+                          <a:ea typeface="Arial" panose="020B0604020202020204"/>
+                          <a:cs typeface="Arial" panose="020B0604020202020204"/>
+                          <a:sym typeface="Arial" panose="020B0604020202020204"/>
                         </a:rPr>
                         <a:t> numeric values are in </a:t>
                       </a:r>
                       <a:r>
-                        <a:rPr lang="en" sz="800" b="1" u="none" strike="noStrike" cap="none" dirty="0">
+                        <a:rPr lang="en-GB" sz="800" b="1" u="none" strike="noStrike" cap="none" dirty="0">
                           <a:solidFill>
                             <a:srgbClr val="FF0000"/>
                           </a:solidFill>
-                          <a:latin typeface="Ubuntu" pitchFamily="34" charset="0"/>
-                          <a:ea typeface="Arial"/>
-                          <a:cs typeface="Arial"/>
-                          <a:sym typeface="Arial"/>
+                          <a:latin typeface="Ubuntu" panose="020B0504030602030204" pitchFamily="34" charset="0"/>
+                          <a:ea typeface="Arial" panose="020B0604020202020204"/>
+                          <a:cs typeface="Arial" panose="020B0604020202020204"/>
+                          <a:sym typeface="Arial" panose="020B0604020202020204"/>
                         </a:rPr>
                         <a:t>Little-Endian</a:t>
                       </a:r>
                       <a:r>
-                        <a:rPr lang="en" sz="800" u="none" strike="noStrike" cap="none" dirty="0">
+                        <a:rPr lang="en-GB" sz="800" u="none" strike="noStrike" cap="none" dirty="0">
                           <a:solidFill>
                             <a:schemeClr val="tx1"/>
                           </a:solidFill>
-                          <a:latin typeface="Ubuntu" pitchFamily="34" charset="0"/>
-                          <a:ea typeface="Arial"/>
-                          <a:cs typeface="Arial"/>
-                          <a:sym typeface="Arial"/>
+                          <a:latin typeface="Ubuntu" panose="020B0504030602030204" pitchFamily="34" charset="0"/>
+                          <a:ea typeface="Arial" panose="020B0604020202020204"/>
+                          <a:cs typeface="Arial" panose="020B0604020202020204"/>
+                          <a:sym typeface="Arial" panose="020B0604020202020204"/>
                         </a:rPr>
                         <a:t> as opposed</a:t>
                       </a:r>
                       <a:r>
-                        <a:rPr lang="en" sz="800" u="none" strike="noStrike" cap="none" baseline="0" dirty="0">
+                        <a:rPr lang="en-GB" sz="800" u="none" strike="noStrike" cap="none" baseline="0" dirty="0">
                           <a:solidFill>
                             <a:schemeClr val="tx1"/>
                           </a:solidFill>
-                          <a:latin typeface="Ubuntu" pitchFamily="34" charset="0"/>
-                          <a:ea typeface="Arial"/>
-                          <a:cs typeface="Arial"/>
-                          <a:sym typeface="Arial"/>
+                          <a:latin typeface="Ubuntu" panose="020B0504030602030204" pitchFamily="34" charset="0"/>
+                          <a:ea typeface="Arial" panose="020B0604020202020204"/>
+                          <a:cs typeface="Arial" panose="020B0604020202020204"/>
+                          <a:sym typeface="Arial" panose="020B0604020202020204"/>
                         </a:rPr>
                         <a:t> to </a:t>
                       </a:r>
                       <a:r>
-                        <a:rPr lang="en" sz="800" u="none" strike="noStrike" cap="none" dirty="0">
+                        <a:rPr lang="en-GB" sz="800" u="none" strike="noStrike" cap="none" dirty="0">
                           <a:solidFill>
                             <a:schemeClr val="tx1"/>
                           </a:solidFill>
-                          <a:latin typeface="Ubuntu" pitchFamily="34" charset="0"/>
-                          <a:ea typeface="Arial"/>
-                          <a:cs typeface="Arial"/>
-                          <a:sym typeface="Arial"/>
+                          <a:latin typeface="Ubuntu" panose="020B0504030602030204" pitchFamily="34" charset="0"/>
+                          <a:ea typeface="Arial" panose="020B0604020202020204"/>
+                          <a:cs typeface="Arial" panose="020B0604020202020204"/>
+                          <a:sym typeface="Arial" panose="020B0604020202020204"/>
                         </a:rPr>
                         <a:t>Big-Endian in UBJSON.</a:t>
                       </a:r>
@@ -5757,10 +5636,10 @@
                         <a:solidFill>
                           <a:schemeClr val="tx1"/>
                         </a:solidFill>
-                        <a:latin typeface="Ubuntu" pitchFamily="34" charset="0"/>
-                        <a:ea typeface="Arial"/>
-                        <a:cs typeface="Arial"/>
-                        <a:sym typeface="Arial"/>
+                        <a:latin typeface="Ubuntu" panose="020B0504030602030204" pitchFamily="34" charset="0"/>
+                        <a:ea typeface="Arial" panose="020B0604020202020204"/>
+                        <a:cs typeface="Arial" panose="020B0604020202020204"/>
+                        <a:sym typeface="Arial" panose="020B0604020202020204"/>
                       </a:endParaRPr>
                     </a:p>
                   </a:txBody>
@@ -5771,40 +5650,14 @@
                   </a:tcPr>
                 </a:tc>
                 <a:tc hMerge="1">
-                  <a:txBody>
-                    <a:bodyPr/>
-                    <a:lstStyle/>
-                    <a:p>
-                      <a:endParaRPr lang="en-US"/>
-                    </a:p>
-                  </a:txBody>
                   <a:tcPr/>
                 </a:tc>
                 <a:tc hMerge="1">
-                  <a:txBody>
-                    <a:bodyPr/>
-                    <a:lstStyle/>
-                    <a:p>
-                      <a:endParaRPr lang="en-US"/>
-                    </a:p>
-                  </a:txBody>
                   <a:tcPr/>
                 </a:tc>
                 <a:tc hMerge="1">
-                  <a:txBody>
-                    <a:bodyPr/>
-                    <a:lstStyle/>
-                    <a:p>
-                      <a:endParaRPr lang="en-US"/>
-                    </a:p>
-                  </a:txBody>
                   <a:tcPr/>
                 </a:tc>
-                <a:extLst>
-                  <a:ext uri="{0D108BD9-81ED-4DB2-BD59-A6C34878D82A}">
-                    <a16:rowId xmlns:a16="http://schemas.microsoft.com/office/drawing/2014/main" val="10013"/>
-                  </a:ext>
-                </a:extLst>
               </a:tr>
             </a:tbl>
           </a:graphicData>
@@ -5814,17 +5667,11 @@
         <p:nvGraphicFramePr>
           <p:cNvPr id="125" name="Google Shape;325;p39"/>
           <p:cNvGraphicFramePr/>
-          <p:nvPr>
-            <p:extLst>
-              <p:ext uri="{D42A27DB-BD31-4B8C-83A1-F6EECF244321}">
-                <p14:modId xmlns:p14="http://schemas.microsoft.com/office/powerpoint/2010/main" val="3680330544"/>
-              </p:ext>
-            </p:extLst>
-          </p:nvPr>
+          <p:nvPr/>
         </p:nvGraphicFramePr>
         <p:xfrm>
-          <a:off x="4578150" y="3566020"/>
-          <a:ext cx="4261050" cy="3231020"/>
+          <a:off x="4578150" y="3337420"/>
+          <a:ext cx="4260850" cy="3444240"/>
         </p:xfrm>
         <a:graphic>
           <a:graphicData uri="http://schemas.openxmlformats.org/drawingml/2006/table">
@@ -5833,34 +5680,10 @@
                 <a:noFill/>
               </a:tblPr>
               <a:tblGrid>
-                <a:gridCol w="908250">
-                  <a:extLst>
-                    <a:ext uri="{9D8B030D-6E8A-4147-A177-3AD203B41FA5}">
-                      <a16:colId xmlns:a16="http://schemas.microsoft.com/office/drawing/2014/main" val="20000"/>
-                    </a:ext>
-                  </a:extLst>
-                </a:gridCol>
-                <a:gridCol w="621147">
-                  <a:extLst>
-                    <a:ext uri="{9D8B030D-6E8A-4147-A177-3AD203B41FA5}">
-                      <a16:colId xmlns:a16="http://schemas.microsoft.com/office/drawing/2014/main" val="20001"/>
-                    </a:ext>
-                  </a:extLst>
-                </a:gridCol>
-                <a:gridCol w="964107">
-                  <a:extLst>
-                    <a:ext uri="{9D8B030D-6E8A-4147-A177-3AD203B41FA5}">
-                      <a16:colId xmlns:a16="http://schemas.microsoft.com/office/drawing/2014/main" val="20002"/>
-                    </a:ext>
-                  </a:extLst>
-                </a:gridCol>
-                <a:gridCol w="1767546">
-                  <a:extLst>
-                    <a:ext uri="{9D8B030D-6E8A-4147-A177-3AD203B41FA5}">
-                      <a16:colId xmlns:a16="http://schemas.microsoft.com/office/drawing/2014/main" val="20003"/>
-                    </a:ext>
-                  </a:extLst>
-                </a:gridCol>
+                <a:gridCol w="927100"/>
+                <a:gridCol w="602297"/>
+                <a:gridCol w="964107"/>
+                <a:gridCol w="1767546"/>
               </a:tblGrid>
               <a:tr h="120875">
                 <a:tc>
@@ -5881,11 +5704,11 @@
                         <a:buNone/>
                       </a:pPr>
                       <a:r>
-                        <a:rPr lang="en" sz="800" u="none" strike="noStrike" cap="none" dirty="0">
+                        <a:rPr lang="en-GB" sz="800" u="none" strike="noStrike" cap="none" dirty="0">
                           <a:solidFill>
                             <a:srgbClr val="FFFF00"/>
                           </a:solidFill>
-                          <a:latin typeface="Ubuntu" pitchFamily="34" charset="0"/>
+                          <a:latin typeface="Ubuntu" panose="020B0504030602030204" pitchFamily="34" charset="0"/>
                         </a:rPr>
                         <a:t>Type Marker</a:t>
                       </a:r>
@@ -5893,7 +5716,7 @@
                         <a:solidFill>
                           <a:srgbClr val="FFFF00"/>
                         </a:solidFill>
-                        <a:latin typeface="Ubuntu" pitchFamily="34" charset="0"/>
+                        <a:latin typeface="Ubuntu" panose="020B0504030602030204" pitchFamily="34" charset="0"/>
                       </a:endParaRPr>
                     </a:p>
                   </a:txBody>
@@ -5924,11 +5747,11 @@
                         <a:buNone/>
                       </a:pPr>
                       <a:r>
-                        <a:rPr lang="en" sz="800" u="none" strike="noStrike" cap="none" dirty="0">
+                        <a:rPr lang="en-GB" sz="800" u="none" strike="noStrike" cap="none" dirty="0">
                           <a:solidFill>
                             <a:srgbClr val="FFFF00"/>
                           </a:solidFill>
-                          <a:latin typeface="Ubuntu" pitchFamily="34" charset="0"/>
+                          <a:latin typeface="Ubuntu" panose="020B0504030602030204" pitchFamily="34" charset="0"/>
                         </a:rPr>
                         <a:t>Length</a:t>
                       </a:r>
@@ -5936,7 +5759,7 @@
                         <a:solidFill>
                           <a:srgbClr val="FFFF00"/>
                         </a:solidFill>
-                        <a:latin typeface="Ubuntu" pitchFamily="34" charset="0"/>
+                        <a:latin typeface="Ubuntu" panose="020B0504030602030204" pitchFamily="34" charset="0"/>
                       </a:endParaRPr>
                     </a:p>
                   </a:txBody>
@@ -5968,15 +5791,15 @@
                           <a:srgbClr val="000000"/>
                         </a:buClr>
                         <a:buSzPts val="800"/>
-                        <a:buFont typeface="Arial"/>
-                        <a:buNone/>
-                      </a:pPr>
-                      <a:r>
-                        <a:rPr lang="en" sz="800" u="none" strike="noStrike" cap="none" dirty="0">
+                        <a:buFont typeface="Arial" panose="020B0604020202020204"/>
+                        <a:buNone/>
+                      </a:pPr>
+                      <a:r>
+                        <a:rPr lang="en-GB" sz="800" u="none" strike="noStrike" cap="none" dirty="0">
                           <a:solidFill>
                             <a:srgbClr val="FFFF00"/>
                           </a:solidFill>
-                          <a:latin typeface="Ubuntu" pitchFamily="34" charset="0"/>
+                          <a:latin typeface="Ubuntu" panose="020B0504030602030204" pitchFamily="34" charset="0"/>
                         </a:rPr>
                         <a:t>Data Payload</a:t>
                       </a:r>
@@ -5984,7 +5807,7 @@
                         <a:solidFill>
                           <a:srgbClr val="FFFF00"/>
                         </a:solidFill>
-                        <a:latin typeface="Ubuntu" pitchFamily="34" charset="0"/>
+                        <a:latin typeface="Ubuntu" panose="020B0504030602030204" pitchFamily="34" charset="0"/>
                       </a:endParaRPr>
                     </a:p>
                   </a:txBody>
@@ -6015,11 +5838,11 @@
                         <a:buNone/>
                       </a:pPr>
                       <a:r>
-                        <a:rPr lang="en" sz="800" u="none" strike="noStrike" cap="none" dirty="0">
+                        <a:rPr lang="en-GB" sz="800" u="none" strike="noStrike" cap="none" dirty="0">
                           <a:solidFill>
                             <a:srgbClr val="FFFF00"/>
                           </a:solidFill>
-                          <a:latin typeface="Ubuntu" pitchFamily="34" charset="0"/>
+                          <a:latin typeface="Ubuntu" panose="020B0504030602030204" pitchFamily="34" charset="0"/>
                         </a:rPr>
                         <a:t>Meaning</a:t>
                       </a:r>
@@ -6027,7 +5850,7 @@
                         <a:solidFill>
                           <a:srgbClr val="FFFF00"/>
                         </a:solidFill>
-                        <a:latin typeface="Ubuntu" pitchFamily="34" charset="0"/>
+                        <a:latin typeface="Ubuntu" panose="020B0504030602030204" pitchFamily="34" charset="0"/>
                       </a:endParaRPr>
                     </a:p>
                   </a:txBody>
@@ -6040,11 +5863,6 @@
                     </a:solidFill>
                   </a:tcPr>
                 </a:tc>
-                <a:extLst>
-                  <a:ext uri="{0D108BD9-81ED-4DB2-BD59-A6C34878D82A}">
-                    <a16:rowId xmlns:a16="http://schemas.microsoft.com/office/drawing/2014/main" val="10000"/>
-                  </a:ext>
-                </a:extLst>
               </a:tr>
               <a:tr h="120875">
                 <a:tc>
@@ -6065,8 +5883,8 @@
                         <a:buNone/>
                       </a:pPr>
                       <a:r>
-                        <a:rPr lang="en" sz="800" u="none" strike="noStrike" cap="none" dirty="0">
-                          <a:latin typeface="Ubuntu" pitchFamily="34" charset="0"/>
+                        <a:rPr lang="en-GB" sz="800" u="none" strike="noStrike" cap="none" dirty="0">
+                          <a:latin typeface="Ubuntu" panose="020B0504030602030204" pitchFamily="34" charset="0"/>
                           <a:ea typeface="Consolas"/>
                           <a:cs typeface="Consolas"/>
                           <a:sym typeface="Consolas"/>
@@ -6074,7 +5892,7 @@
                         <a:t>d</a:t>
                       </a:r>
                       <a:endParaRPr sz="800" u="none" strike="noStrike" cap="none" dirty="0">
-                        <a:latin typeface="Ubuntu" pitchFamily="34" charset="0"/>
+                        <a:latin typeface="Ubuntu" panose="020B0504030602030204" pitchFamily="34" charset="0"/>
                         <a:ea typeface="Consolas"/>
                         <a:cs typeface="Consolas"/>
                         <a:sym typeface="Consolas"/>
@@ -6105,13 +5923,13 @@
                         <a:buNone/>
                       </a:pPr>
                       <a:r>
-                        <a:rPr lang="en" sz="800" u="none" strike="noStrike" cap="none" dirty="0">
-                          <a:latin typeface="Ubuntu" pitchFamily="34" charset="0"/>
+                        <a:rPr lang="en-GB" sz="800" u="none" strike="noStrike" cap="none" dirty="0">
+                          <a:latin typeface="Ubuntu" panose="020B0504030602030204" pitchFamily="34" charset="0"/>
                         </a:rPr>
                         <a:t>no</a:t>
                       </a:r>
                       <a:endParaRPr sz="800" u="none" strike="noStrike" cap="none" dirty="0">
-                        <a:latin typeface="Ubuntu" pitchFamily="34" charset="0"/>
+                        <a:latin typeface="Ubuntu" panose="020B0504030602030204" pitchFamily="34" charset="0"/>
                       </a:endParaRPr>
                     </a:p>
                   </a:txBody>
@@ -6139,13 +5957,13 @@
                         <a:buNone/>
                       </a:pPr>
                       <a:r>
-                        <a:rPr lang="en" sz="800" u="none" strike="noStrike" cap="none" dirty="0">
-                          <a:latin typeface="Ubuntu" pitchFamily="34" charset="0"/>
+                        <a:rPr lang="en-GB" sz="800" u="none" strike="noStrike" cap="none" dirty="0">
+                          <a:latin typeface="Ubuntu" panose="020B0504030602030204" pitchFamily="34" charset="0"/>
                         </a:rPr>
                         <a:t>yes</a:t>
                       </a:r>
                       <a:endParaRPr sz="800" u="none" strike="noStrike" cap="none" dirty="0">
-                        <a:latin typeface="Ubuntu" pitchFamily="34" charset="0"/>
+                        <a:latin typeface="Ubuntu" panose="020B0504030602030204" pitchFamily="34" charset="0"/>
                       </a:endParaRPr>
                     </a:p>
                   </a:txBody>
@@ -6173,13 +5991,13 @@
                         <a:buNone/>
                       </a:pPr>
                       <a:r>
-                        <a:rPr lang="en" sz="800" u="none" strike="noStrike" cap="none" dirty="0">
-                          <a:latin typeface="Ubuntu" pitchFamily="34" charset="0"/>
+                        <a:rPr lang="en-GB" sz="800" u="none" strike="noStrike" cap="none" dirty="0">
+                          <a:latin typeface="Ubuntu" panose="020B0504030602030204" pitchFamily="34" charset="0"/>
                         </a:rPr>
                         <a:t>float32 (single)</a:t>
                       </a:r>
                       <a:endParaRPr sz="800" u="none" strike="noStrike" cap="none" dirty="0">
-                        <a:latin typeface="Ubuntu" pitchFamily="34" charset="0"/>
+                        <a:latin typeface="Ubuntu" panose="020B0504030602030204" pitchFamily="34" charset="0"/>
                       </a:endParaRPr>
                     </a:p>
                   </a:txBody>
@@ -6189,11 +6007,6 @@
                     </a:solidFill>
                   </a:tcPr>
                 </a:tc>
-                <a:extLst>
-                  <a:ext uri="{0D108BD9-81ED-4DB2-BD59-A6C34878D82A}">
-                    <a16:rowId xmlns:a16="http://schemas.microsoft.com/office/drawing/2014/main" val="10001"/>
-                  </a:ext>
-                </a:extLst>
               </a:tr>
               <a:tr h="120875">
                 <a:tc>
@@ -6214,8 +6027,8 @@
                         <a:buNone/>
                       </a:pPr>
                       <a:r>
-                        <a:rPr lang="en" sz="800" u="none" strike="noStrike" cap="none">
-                          <a:latin typeface="Ubuntu" pitchFamily="34" charset="0"/>
+                        <a:rPr lang="en-GB" sz="800" u="none" strike="noStrike" cap="none">
+                          <a:latin typeface="Ubuntu" panose="020B0504030602030204" pitchFamily="34" charset="0"/>
                           <a:ea typeface="Consolas"/>
                           <a:cs typeface="Consolas"/>
                           <a:sym typeface="Consolas"/>
@@ -6223,7 +6036,7 @@
                         <a:t>D</a:t>
                       </a:r>
                       <a:endParaRPr sz="800" u="none" strike="noStrike" cap="none">
-                        <a:latin typeface="Ubuntu" pitchFamily="34" charset="0"/>
+                        <a:latin typeface="Ubuntu" panose="020B0504030602030204" pitchFamily="34" charset="0"/>
                         <a:ea typeface="Consolas"/>
                         <a:cs typeface="Consolas"/>
                         <a:sym typeface="Consolas"/>
@@ -6254,13 +6067,13 @@
                         <a:buNone/>
                       </a:pPr>
                       <a:r>
-                        <a:rPr lang="en" sz="800" u="none" strike="noStrike" cap="none" dirty="0">
-                          <a:latin typeface="Ubuntu" pitchFamily="34" charset="0"/>
+                        <a:rPr lang="en-GB" sz="800" u="none" strike="noStrike" cap="none" dirty="0">
+                          <a:latin typeface="Ubuntu" panose="020B0504030602030204" pitchFamily="34" charset="0"/>
                         </a:rPr>
                         <a:t>no</a:t>
                       </a:r>
                       <a:endParaRPr sz="800" u="none" strike="noStrike" cap="none" dirty="0">
-                        <a:latin typeface="Ubuntu" pitchFamily="34" charset="0"/>
+                        <a:latin typeface="Ubuntu" panose="020B0504030602030204" pitchFamily="34" charset="0"/>
                       </a:endParaRPr>
                     </a:p>
                   </a:txBody>
@@ -6288,13 +6101,13 @@
                         <a:buNone/>
                       </a:pPr>
                       <a:r>
-                        <a:rPr lang="en" sz="800" u="none" strike="noStrike" cap="none">
-                          <a:latin typeface="Ubuntu" pitchFamily="34" charset="0"/>
+                        <a:rPr lang="en-GB" sz="800" u="none" strike="noStrike" cap="none">
+                          <a:latin typeface="Ubuntu" panose="020B0504030602030204" pitchFamily="34" charset="0"/>
                         </a:rPr>
                         <a:t>yes</a:t>
                       </a:r>
                       <a:endParaRPr sz="800" u="none" strike="noStrike" cap="none">
-                        <a:latin typeface="Ubuntu" pitchFamily="34" charset="0"/>
+                        <a:latin typeface="Ubuntu" panose="020B0504030602030204" pitchFamily="34" charset="0"/>
                       </a:endParaRPr>
                     </a:p>
                   </a:txBody>
@@ -6322,13 +6135,13 @@
                         <a:buNone/>
                       </a:pPr>
                       <a:r>
-                        <a:rPr lang="en" sz="800" u="none" strike="noStrike" cap="none">
-                          <a:latin typeface="Ubuntu" pitchFamily="34" charset="0"/>
+                        <a:rPr lang="en-GB" sz="800" u="none" strike="noStrike" cap="none">
+                          <a:latin typeface="Ubuntu" panose="020B0504030602030204" pitchFamily="34" charset="0"/>
                         </a:rPr>
                         <a:t>float64 (double)</a:t>
                       </a:r>
                       <a:endParaRPr sz="800" u="none" strike="noStrike" cap="none">
-                        <a:latin typeface="Ubuntu" pitchFamily="34" charset="0"/>
+                        <a:latin typeface="Ubuntu" panose="020B0504030602030204" pitchFamily="34" charset="0"/>
                       </a:endParaRPr>
                     </a:p>
                   </a:txBody>
@@ -6338,11 +6151,6 @@
                     </a:solidFill>
                   </a:tcPr>
                 </a:tc>
-                <a:extLst>
-                  <a:ext uri="{0D108BD9-81ED-4DB2-BD59-A6C34878D82A}">
-                    <a16:rowId xmlns:a16="http://schemas.microsoft.com/office/drawing/2014/main" val="10002"/>
-                  </a:ext>
-                </a:extLst>
               </a:tr>
               <a:tr h="120875">
                 <a:tc>
@@ -6363,8 +6171,8 @@
                         <a:buNone/>
                       </a:pPr>
                       <a:r>
-                        <a:rPr lang="en" sz="800" u="none" strike="noStrike" cap="none" dirty="0">
-                          <a:latin typeface="Ubuntu" pitchFamily="34" charset="0"/>
+                        <a:rPr lang="en-GB" sz="800" u="none" strike="noStrike" cap="none" dirty="0">
+                          <a:latin typeface="Ubuntu" panose="020B0504030602030204" pitchFamily="34" charset="0"/>
                           <a:ea typeface="Consolas"/>
                           <a:cs typeface="Consolas"/>
                           <a:sym typeface="Consolas"/>
@@ -6372,7 +6180,7 @@
                         <a:t>C</a:t>
                       </a:r>
                       <a:endParaRPr sz="800" u="none" strike="noStrike" cap="none" dirty="0">
-                        <a:latin typeface="Ubuntu" pitchFamily="34" charset="0"/>
+                        <a:latin typeface="Ubuntu" panose="020B0504030602030204" pitchFamily="34" charset="0"/>
                         <a:ea typeface="Consolas"/>
                         <a:cs typeface="Consolas"/>
                         <a:sym typeface="Consolas"/>
@@ -6403,13 +6211,13 @@
                         <a:buNone/>
                       </a:pPr>
                       <a:r>
-                        <a:rPr lang="en" sz="800" u="none" strike="noStrike" cap="none" dirty="0">
-                          <a:latin typeface="Ubuntu" pitchFamily="34" charset="0"/>
+                        <a:rPr lang="en-GB" sz="800" u="none" strike="noStrike" cap="none" dirty="0">
+                          <a:latin typeface="Ubuntu" panose="020B0504030602030204" pitchFamily="34" charset="0"/>
                         </a:rPr>
                         <a:t>no</a:t>
                       </a:r>
                       <a:endParaRPr sz="800" u="none" strike="noStrike" cap="none" dirty="0">
-                        <a:latin typeface="Ubuntu" pitchFamily="34" charset="0"/>
+                        <a:latin typeface="Ubuntu" panose="020B0504030602030204" pitchFamily="34" charset="0"/>
                       </a:endParaRPr>
                     </a:p>
                   </a:txBody>
@@ -6437,13 +6245,13 @@
                         <a:buNone/>
                       </a:pPr>
                       <a:r>
-                        <a:rPr lang="en" sz="800" dirty="0">
-                          <a:latin typeface="Ubuntu" pitchFamily="34" charset="0"/>
+                        <a:rPr lang="en-GB" sz="800" dirty="0">
+                          <a:latin typeface="Ubuntu" panose="020B0504030602030204" pitchFamily="34" charset="0"/>
                         </a:rPr>
                         <a:t>yes</a:t>
                       </a:r>
                       <a:endParaRPr sz="800" u="none" strike="noStrike" cap="none" dirty="0">
-                        <a:latin typeface="Ubuntu" pitchFamily="34" charset="0"/>
+                        <a:latin typeface="Ubuntu" panose="020B0504030602030204" pitchFamily="34" charset="0"/>
                       </a:endParaRPr>
                     </a:p>
                   </a:txBody>
@@ -6471,13 +6279,13 @@
                         <a:buNone/>
                       </a:pPr>
                       <a:r>
-                        <a:rPr lang="en" sz="800" u="none" strike="noStrike" cap="none" dirty="0">
-                          <a:latin typeface="Ubuntu" pitchFamily="34" charset="0"/>
+                        <a:rPr lang="en-GB" sz="800" u="none" strike="noStrike" cap="none" dirty="0">
+                          <a:latin typeface="Ubuntu" panose="020B0504030602030204" pitchFamily="34" charset="0"/>
                         </a:rPr>
                         <a:t>char</a:t>
                       </a:r>
                       <a:endParaRPr sz="800" u="none" strike="noStrike" cap="none" dirty="0">
-                        <a:latin typeface="Ubuntu" pitchFamily="34" charset="0"/>
+                        <a:latin typeface="Ubuntu" panose="020B0504030602030204" pitchFamily="34" charset="0"/>
                       </a:endParaRPr>
                     </a:p>
                   </a:txBody>
@@ -6487,11 +6295,6 @@
                     </a:solidFill>
                   </a:tcPr>
                 </a:tc>
-                <a:extLst>
-                  <a:ext uri="{0D108BD9-81ED-4DB2-BD59-A6C34878D82A}">
-                    <a16:rowId xmlns:a16="http://schemas.microsoft.com/office/drawing/2014/main" val="10003"/>
-                  </a:ext>
-                </a:extLst>
               </a:tr>
               <a:tr h="0">
                 <a:tc>
@@ -6512,11 +6315,11 @@
                         <a:buNone/>
                       </a:pPr>
                       <a:r>
-                        <a:rPr lang="en" sz="800" u="none" strike="noStrike" cap="none" dirty="0">
+                        <a:rPr lang="en-GB" sz="800" u="none" strike="noStrike" cap="none" dirty="0">
                           <a:solidFill>
                             <a:srgbClr val="FF0000"/>
                           </a:solidFill>
-                          <a:latin typeface="Ubuntu" pitchFamily="34" charset="0"/>
+                          <a:latin typeface="Ubuntu" panose="020B0504030602030204" pitchFamily="34" charset="0"/>
                           <a:ea typeface="Consolas"/>
                           <a:cs typeface="Consolas"/>
                           <a:sym typeface="Consolas"/>
@@ -6527,7 +6330,7 @@
                         <a:solidFill>
                           <a:srgbClr val="FF0000"/>
                         </a:solidFill>
-                        <a:latin typeface="Ubuntu" pitchFamily="34" charset="0"/>
+                        <a:latin typeface="Ubuntu" panose="020B0504030602030204" pitchFamily="34" charset="0"/>
                         <a:ea typeface="Consolas"/>
                         <a:cs typeface="Consolas"/>
                         <a:sym typeface="Consolas"/>
@@ -6558,13 +6361,13 @@
                         <a:buNone/>
                       </a:pPr>
                       <a:r>
-                        <a:rPr lang="en" sz="800" u="none" strike="noStrike" cap="none">
-                          <a:latin typeface="Ubuntu" pitchFamily="34" charset="0"/>
+                        <a:rPr lang="en-GB" sz="800" u="none" strike="noStrike" cap="none">
+                          <a:latin typeface="Ubuntu" panose="020B0504030602030204" pitchFamily="34" charset="0"/>
                         </a:rPr>
                         <a:t>no</a:t>
                       </a:r>
                       <a:endParaRPr sz="800" u="none" strike="noStrike" cap="none">
-                        <a:latin typeface="Ubuntu" pitchFamily="34" charset="0"/>
+                        <a:latin typeface="Ubuntu" panose="020B0504030602030204" pitchFamily="34" charset="0"/>
                       </a:endParaRPr>
                     </a:p>
                   </a:txBody>
@@ -6592,13 +6395,13 @@
                         <a:buNone/>
                       </a:pPr>
                       <a:r>
-                        <a:rPr lang="en" sz="800" dirty="0">
-                          <a:latin typeface="Ubuntu" pitchFamily="34" charset="0"/>
+                        <a:rPr lang="en-GB" sz="800" dirty="0">
+                          <a:latin typeface="Ubuntu" panose="020B0504030602030204" pitchFamily="34" charset="0"/>
                         </a:rPr>
                         <a:t>yes</a:t>
                       </a:r>
                       <a:endParaRPr sz="800" u="none" strike="noStrike" cap="none" dirty="0">
-                        <a:latin typeface="Ubuntu" pitchFamily="34" charset="0"/>
+                        <a:latin typeface="Ubuntu" panose="020B0504030602030204" pitchFamily="34" charset="0"/>
                       </a:endParaRPr>
                     </a:p>
                   </a:txBody>
@@ -6626,13 +6429,13 @@
                         <a:buNone/>
                       </a:pPr>
                       <a:r>
-                        <a:rPr lang="en" sz="800" u="none" strike="noStrike" cap="none" dirty="0">
-                          <a:latin typeface="Ubuntu" pitchFamily="34" charset="0"/>
+                        <a:rPr lang="en-GB" sz="800" u="none" strike="noStrike" cap="none" dirty="0">
+                          <a:latin typeface="Ubuntu" panose="020B0504030602030204" pitchFamily="34" charset="0"/>
                         </a:rPr>
                         <a:t>byte</a:t>
                       </a:r>
                       <a:endParaRPr sz="800" u="none" strike="noStrike" cap="none" dirty="0">
-                        <a:latin typeface="Ubuntu" pitchFamily="34" charset="0"/>
+                        <a:latin typeface="Ubuntu" panose="020B0504030602030204" pitchFamily="34" charset="0"/>
                       </a:endParaRPr>
                     </a:p>
                   </a:txBody>
@@ -6642,11 +6445,6 @@
                     </a:solidFill>
                   </a:tcPr>
                 </a:tc>
-                <a:extLst>
-                  <a:ext uri="{0D108BD9-81ED-4DB2-BD59-A6C34878D82A}">
-                    <a16:rowId xmlns:a16="http://schemas.microsoft.com/office/drawing/2014/main" val="10004"/>
-                  </a:ext>
-                </a:extLst>
               </a:tr>
               <a:tr h="120875">
                 <a:tc>
@@ -6667,8 +6465,8 @@
                         <a:buNone/>
                       </a:pPr>
                       <a:r>
-                        <a:rPr lang="en" sz="800" u="none" strike="noStrike" cap="none">
-                          <a:latin typeface="Ubuntu" pitchFamily="34" charset="0"/>
+                        <a:rPr lang="en-GB" sz="800" u="none" strike="noStrike" cap="none">
+                          <a:latin typeface="Ubuntu" panose="020B0504030602030204" pitchFamily="34" charset="0"/>
                           <a:ea typeface="Consolas"/>
                           <a:cs typeface="Consolas"/>
                           <a:sym typeface="Consolas"/>
@@ -6676,7 +6474,7 @@
                         <a:t>S</a:t>
                       </a:r>
                       <a:endParaRPr sz="800" u="none" strike="noStrike" cap="none">
-                        <a:latin typeface="Ubuntu" pitchFamily="34" charset="0"/>
+                        <a:latin typeface="Ubuntu" panose="020B0504030602030204" pitchFamily="34" charset="0"/>
                         <a:ea typeface="Consolas"/>
                         <a:cs typeface="Consolas"/>
                         <a:sym typeface="Consolas"/>
@@ -6707,13 +6505,13 @@
                         <a:buNone/>
                       </a:pPr>
                       <a:r>
-                        <a:rPr lang="en" sz="800" u="none" strike="noStrike" cap="none">
-                          <a:latin typeface="Ubuntu" pitchFamily="34" charset="0"/>
+                        <a:rPr lang="en-GB" sz="800" u="none" strike="noStrike" cap="none">
+                          <a:latin typeface="Ubuntu" panose="020B0504030602030204" pitchFamily="34" charset="0"/>
                         </a:rPr>
                         <a:t>yes</a:t>
                       </a:r>
                       <a:endParaRPr sz="800" u="none" strike="noStrike" cap="none">
-                        <a:latin typeface="Ubuntu" pitchFamily="34" charset="0"/>
+                        <a:latin typeface="Ubuntu" panose="020B0504030602030204" pitchFamily="34" charset="0"/>
                       </a:endParaRPr>
                     </a:p>
                   </a:txBody>
@@ -6741,13 +6539,13 @@
                         <a:buNone/>
                       </a:pPr>
                       <a:r>
-                        <a:rPr lang="en" sz="800" u="none" strike="noStrike" cap="none" dirty="0">
-                          <a:latin typeface="Ubuntu" pitchFamily="34" charset="0"/>
+                        <a:rPr lang="en-GB" sz="800" u="none" strike="noStrike" cap="none" dirty="0">
+                          <a:latin typeface="Ubuntu" panose="020B0504030602030204" pitchFamily="34" charset="0"/>
                         </a:rPr>
                         <a:t>yes</a:t>
                       </a:r>
                       <a:endParaRPr sz="800" u="none" strike="noStrike" cap="none" dirty="0">
-                        <a:latin typeface="Ubuntu" pitchFamily="34" charset="0"/>
+                        <a:latin typeface="Ubuntu" panose="020B0504030602030204" pitchFamily="34" charset="0"/>
                       </a:endParaRPr>
                     </a:p>
                   </a:txBody>
@@ -6775,13 +6573,13 @@
                         <a:buNone/>
                       </a:pPr>
                       <a:r>
-                        <a:rPr lang="en" sz="800" u="none" strike="noStrike" cap="none" dirty="0">
-                          <a:latin typeface="Ubuntu" pitchFamily="34" charset="0"/>
+                        <a:rPr lang="en-GB" sz="800" u="none" strike="noStrike" cap="none" dirty="0">
+                          <a:latin typeface="Ubuntu" panose="020B0504030602030204" pitchFamily="34" charset="0"/>
                         </a:rPr>
                         <a:t>string</a:t>
                       </a:r>
                       <a:endParaRPr sz="800" u="none" strike="noStrike" cap="none" dirty="0">
-                        <a:latin typeface="Ubuntu" pitchFamily="34" charset="0"/>
+                        <a:latin typeface="Ubuntu" panose="020B0504030602030204" pitchFamily="34" charset="0"/>
                       </a:endParaRPr>
                     </a:p>
                   </a:txBody>
@@ -6791,11 +6589,6 @@
                     </a:solidFill>
                   </a:tcPr>
                 </a:tc>
-                <a:extLst>
-                  <a:ext uri="{0D108BD9-81ED-4DB2-BD59-A6C34878D82A}">
-                    <a16:rowId xmlns:a16="http://schemas.microsoft.com/office/drawing/2014/main" val="10005"/>
-                  </a:ext>
-                </a:extLst>
               </a:tr>
               <a:tr h="120875">
                 <a:tc>
@@ -6816,8 +6609,8 @@
                         <a:buNone/>
                       </a:pPr>
                       <a:r>
-                        <a:rPr lang="en" sz="800" u="none" strike="noStrike" cap="none">
-                          <a:latin typeface="Ubuntu" pitchFamily="34" charset="0"/>
+                        <a:rPr lang="en-GB" sz="800" u="none" strike="noStrike" cap="none">
+                          <a:latin typeface="Ubuntu" panose="020B0504030602030204" pitchFamily="34" charset="0"/>
                           <a:ea typeface="Consolas"/>
                           <a:cs typeface="Consolas"/>
                           <a:sym typeface="Consolas"/>
@@ -6825,7 +6618,7 @@
                         <a:t>H</a:t>
                       </a:r>
                       <a:endParaRPr sz="800" u="none" strike="noStrike" cap="none">
-                        <a:latin typeface="Ubuntu" pitchFamily="34" charset="0"/>
+                        <a:latin typeface="Ubuntu" panose="020B0504030602030204" pitchFamily="34" charset="0"/>
                         <a:ea typeface="Consolas"/>
                         <a:cs typeface="Consolas"/>
                         <a:sym typeface="Consolas"/>
@@ -6856,13 +6649,13 @@
                         <a:buNone/>
                       </a:pPr>
                       <a:r>
-                        <a:rPr lang="en" sz="800" u="none" strike="noStrike" cap="none">
-                          <a:latin typeface="Ubuntu" pitchFamily="34" charset="0"/>
+                        <a:rPr lang="en-GB" sz="800" u="none" strike="noStrike" cap="none">
+                          <a:latin typeface="Ubuntu" panose="020B0504030602030204" pitchFamily="34" charset="0"/>
                         </a:rPr>
                         <a:t>yes</a:t>
                       </a:r>
                       <a:endParaRPr sz="800" u="none" strike="noStrike" cap="none">
-                        <a:latin typeface="Ubuntu" pitchFamily="34" charset="0"/>
+                        <a:latin typeface="Ubuntu" panose="020B0504030602030204" pitchFamily="34" charset="0"/>
                       </a:endParaRPr>
                     </a:p>
                   </a:txBody>
@@ -6890,13 +6683,13 @@
                         <a:buNone/>
                       </a:pPr>
                       <a:r>
-                        <a:rPr lang="en" sz="800" u="none" strike="noStrike" cap="none">
-                          <a:latin typeface="Ubuntu" pitchFamily="34" charset="0"/>
+                        <a:rPr lang="en-GB" sz="800" u="none" strike="noStrike" cap="none">
+                          <a:latin typeface="Ubuntu" panose="020B0504030602030204" pitchFamily="34" charset="0"/>
                         </a:rPr>
                         <a:t>yes</a:t>
                       </a:r>
                       <a:endParaRPr sz="800" u="none" strike="noStrike" cap="none">
-                        <a:latin typeface="Ubuntu" pitchFamily="34" charset="0"/>
+                        <a:latin typeface="Ubuntu" panose="020B0504030602030204" pitchFamily="34" charset="0"/>
                       </a:endParaRPr>
                     </a:p>
                   </a:txBody>
@@ -6924,13 +6717,13 @@
                         <a:buNone/>
                       </a:pPr>
                       <a:r>
-                        <a:rPr lang="en" sz="800" u="none" strike="noStrike" cap="none" dirty="0">
-                          <a:latin typeface="Ubuntu" pitchFamily="34" charset="0"/>
+                        <a:rPr lang="en-GB" sz="800" u="none" strike="noStrike" cap="none" dirty="0">
+                          <a:latin typeface="Ubuntu" panose="020B0504030602030204" pitchFamily="34" charset="0"/>
                         </a:rPr>
                         <a:t>huge-number (in string)</a:t>
                       </a:r>
                       <a:endParaRPr sz="800" u="none" strike="noStrike" cap="none" dirty="0">
-                        <a:latin typeface="Ubuntu" pitchFamily="34" charset="0"/>
+                        <a:latin typeface="Ubuntu" panose="020B0504030602030204" pitchFamily="34" charset="0"/>
                       </a:endParaRPr>
                     </a:p>
                   </a:txBody>
@@ -6940,41 +6733,41 @@
                     </a:solidFill>
                   </a:tcPr>
                 </a:tc>
-                <a:extLst>
-                  <a:ext uri="{0D108BD9-81ED-4DB2-BD59-A6C34878D82A}">
-                    <a16:rowId xmlns:a16="http://schemas.microsoft.com/office/drawing/2014/main" val="10006"/>
-                  </a:ext>
-                </a:extLst>
               </a:tr>
               <a:tr h="120875">
                 <a:tc>
                   <a:txBody>
                     <a:bodyPr/>
-                    <a:lstStyle/>
-                    <a:p>
-                      <a:pPr marL="0" marR="0" lvl="0" indent="0" algn="l" rtl="0">
-                        <a:lnSpc>
-                          <a:spcPct val="100000"/>
-                        </a:lnSpc>
-                        <a:spcBef>
-                          <a:spcPts val="0"/>
-                        </a:spcBef>
-                        <a:spcAft>
-                          <a:spcPts val="0"/>
-                        </a:spcAft>
-                        <a:buNone/>
-                      </a:pPr>
-                      <a:r>
-                        <a:rPr lang="en" sz="800" u="none" strike="noStrike" cap="none">
-                          <a:latin typeface="Ubuntu" pitchFamily="34" charset="0"/>
+                    <a:p>
+                      <a:pPr marL="0" marR="0" lvl="0" indent="0" algn="l" rtl="0">
+                        <a:lnSpc>
+                          <a:spcPct val="100000"/>
+                        </a:lnSpc>
+                        <a:spcBef>
+                          <a:spcPts val="0"/>
+                        </a:spcBef>
+                        <a:spcAft>
+                          <a:spcPts val="0"/>
+                        </a:spcAft>
+                        <a:buNone/>
+                      </a:pPr>
+                      <a:r>
+                        <a:rPr lang="en-US" sz="800" u="none" strike="noStrike" cap="none">
+                          <a:solidFill>
+                            <a:srgbClr val="FF0000"/>
+                          </a:solidFill>
+                          <a:latin typeface="Ubuntu" panose="020B0504030602030204" pitchFamily="34" charset="0"/>
                           <a:ea typeface="Consolas"/>
                           <a:cs typeface="Consolas"/>
                           <a:sym typeface="Consolas"/>
                         </a:rPr>
-                        <a:t>[</a:t>
-                      </a:r>
-                      <a:endParaRPr sz="800" u="none" strike="noStrike" cap="none">
-                        <a:latin typeface="Ubuntu" pitchFamily="34" charset="0"/>
+                        <a:t>E</a:t>
+                      </a:r>
+                      <a:endParaRPr lang="en-US" sz="800" u="none" strike="noStrike" cap="none">
+                        <a:solidFill>
+                          <a:srgbClr val="FF0000"/>
+                        </a:solidFill>
+                        <a:latin typeface="Ubuntu" panose="020B0504030602030204" pitchFamily="34" charset="0"/>
                         <a:ea typeface="Consolas"/>
                         <a:cs typeface="Consolas"/>
                         <a:sym typeface="Consolas"/>
@@ -6983,117 +6776,109 @@
                   </a:txBody>
                   <a:tcPr marL="91450" marR="91450" marT="45725" marB="45725">
                     <a:solidFill>
-                      <a:srgbClr val="92D050"/>
-                    </a:solidFill>
-                  </a:tcPr>
-                </a:tc>
-                <a:tc>
-                  <a:txBody>
-                    <a:bodyPr/>
-                    <a:lstStyle/>
-                    <a:p>
-                      <a:pPr marL="0" marR="0" lvl="0" indent="0" algn="l" rtl="0">
-                        <a:lnSpc>
-                          <a:spcPct val="100000"/>
-                        </a:lnSpc>
-                        <a:spcBef>
-                          <a:spcPts val="0"/>
-                        </a:spcBef>
-                        <a:spcAft>
-                          <a:spcPts val="0"/>
-                        </a:spcAft>
-                        <a:buNone/>
-                      </a:pPr>
-                      <a:r>
-                        <a:rPr lang="en" sz="800" u="none" strike="noStrike" cap="none">
-                          <a:latin typeface="Ubuntu" pitchFamily="34" charset="0"/>
-                        </a:rPr>
-                        <a:t>optional</a:t>
-                      </a:r>
-                      <a:endParaRPr sz="800" u="none" strike="noStrike" cap="none">
-                        <a:latin typeface="Ubuntu" pitchFamily="34" charset="0"/>
-                      </a:endParaRPr>
-                    </a:p>
-                  </a:txBody>
-                  <a:tcPr marL="91450" marR="91450" marT="45725" marB="45725">
-                    <a:solidFill>
-                      <a:srgbClr val="92D050"/>
-                    </a:solidFill>
-                  </a:tcPr>
-                </a:tc>
-                <a:tc>
-                  <a:txBody>
-                    <a:bodyPr/>
-                    <a:lstStyle/>
-                    <a:p>
-                      <a:pPr marL="0" marR="0" lvl="0" indent="0" algn="l" rtl="0">
-                        <a:lnSpc>
-                          <a:spcPct val="100000"/>
-                        </a:lnSpc>
-                        <a:spcBef>
-                          <a:spcPts val="0"/>
-                        </a:spcBef>
-                        <a:spcAft>
-                          <a:spcPts val="0"/>
-                        </a:spcAft>
-                        <a:buNone/>
-                      </a:pPr>
-                      <a:r>
-                        <a:rPr lang="en" sz="800" u="none" strike="noStrike" cap="none" dirty="0">
-                          <a:latin typeface="Ubuntu" pitchFamily="34" charset="0"/>
-                        </a:rPr>
-                        <a:t>optional</a:t>
-                      </a:r>
-                      <a:endParaRPr sz="800" u="none" strike="noStrike" cap="none" dirty="0">
-                        <a:latin typeface="Ubuntu" pitchFamily="34" charset="0"/>
-                      </a:endParaRPr>
-                    </a:p>
-                  </a:txBody>
-                  <a:tcPr marL="91450" marR="91450" marT="45725" marB="45725">
-                    <a:solidFill>
-                      <a:srgbClr val="92D050"/>
-                    </a:solidFill>
-                  </a:tcPr>
-                </a:tc>
-                <a:tc>
-                  <a:txBody>
-                    <a:bodyPr/>
-                    <a:lstStyle/>
-                    <a:p>
-                      <a:pPr marL="0" marR="0" lvl="0" indent="0" algn="l" rtl="0">
-                        <a:lnSpc>
-                          <a:spcPct val="100000"/>
-                        </a:lnSpc>
-                        <a:spcBef>
-                          <a:spcPts val="0"/>
-                        </a:spcBef>
-                        <a:spcAft>
-                          <a:spcPts val="0"/>
-                        </a:spcAft>
-                        <a:buNone/>
-                      </a:pPr>
-                      <a:r>
-                        <a:rPr lang="en" sz="800" u="none" strike="noStrike" cap="none">
-                          <a:latin typeface="Ubuntu" pitchFamily="34" charset="0"/>
-                        </a:rPr>
-                        <a:t>arrays</a:t>
-                      </a:r>
-                      <a:endParaRPr>
-                        <a:latin typeface="Ubuntu" pitchFamily="34" charset="0"/>
-                      </a:endParaRPr>
-                    </a:p>
-                  </a:txBody>
-                  <a:tcPr marL="91450" marR="91450" marT="45725" marB="45725">
-                    <a:solidFill>
-                      <a:srgbClr val="92D050"/>
-                    </a:solidFill>
-                  </a:tcPr>
-                </a:tc>
-                <a:extLst>
-                  <a:ext uri="{0D108BD9-81ED-4DB2-BD59-A6C34878D82A}">
-                    <a16:rowId xmlns:a16="http://schemas.microsoft.com/office/drawing/2014/main" val="10007"/>
-                  </a:ext>
-                </a:extLst>
+                      <a:srgbClr val="D8D8D8"/>
+                    </a:solidFill>
+                  </a:tcPr>
+                </a:tc>
+                <a:tc>
+                  <a:txBody>
+                    <a:bodyPr/>
+                    <a:p>
+                      <a:pPr marL="0" marR="0" lvl="0" indent="0" algn="l" rtl="0">
+                        <a:lnSpc>
+                          <a:spcPct val="100000"/>
+                        </a:lnSpc>
+                        <a:spcBef>
+                          <a:spcPts val="0"/>
+                        </a:spcBef>
+                        <a:spcAft>
+                          <a:spcPts val="0"/>
+                        </a:spcAft>
+                        <a:buNone/>
+                      </a:pPr>
+                      <a:r>
+                        <a:rPr lang="en-US" sz="800" u="none" strike="noStrike" cap="none">
+                          <a:latin typeface="Ubuntu" panose="020B0504030602030204" pitchFamily="34" charset="0"/>
+                        </a:rPr>
+                        <a:t>yes</a:t>
+                      </a:r>
+                      <a:endParaRPr lang="en-US" sz="800" u="none" strike="noStrike" cap="none">
+                        <a:latin typeface="Ubuntu" panose="020B0504030602030204" pitchFamily="34" charset="0"/>
+                      </a:endParaRPr>
+                    </a:p>
+                  </a:txBody>
+                  <a:tcPr marL="91450" marR="91450" marT="45725" marB="45725">
+                    <a:solidFill>
+                      <a:srgbClr val="D8D8D8"/>
+                    </a:solidFill>
+                  </a:tcPr>
+                </a:tc>
+                <a:tc>
+                  <a:txBody>
+                    <a:bodyPr/>
+                    <a:p>
+                      <a:pPr marL="0" marR="0" lvl="0" indent="0" algn="l" rtl="0">
+                        <a:lnSpc>
+                          <a:spcPct val="100000"/>
+                        </a:lnSpc>
+                        <a:spcBef>
+                          <a:spcPts val="0"/>
+                        </a:spcBef>
+                        <a:spcAft>
+                          <a:spcPts val="0"/>
+                        </a:spcAft>
+                        <a:buNone/>
+                      </a:pPr>
+                      <a:r>
+                        <a:rPr lang="en-US" sz="800" u="none" strike="noStrike" cap="none">
+                          <a:latin typeface="Ubuntu" panose="020B0504030602030204" pitchFamily="34" charset="0"/>
+                        </a:rPr>
+                        <a:t>yes</a:t>
+                      </a:r>
+                      <a:endParaRPr lang="en-US" sz="800" u="none" strike="noStrike" cap="none">
+                        <a:latin typeface="Ubuntu" panose="020B0504030602030204" pitchFamily="34" charset="0"/>
+                      </a:endParaRPr>
+                    </a:p>
+                  </a:txBody>
+                  <a:tcPr marL="91450" marR="91450" marT="45725" marB="45725">
+                    <a:solidFill>
+                      <a:srgbClr val="D8D8D8"/>
+                    </a:solidFill>
+                  </a:tcPr>
+                </a:tc>
+                <a:tc>
+                  <a:txBody>
+                    <a:bodyPr/>
+                    <a:p>
+                      <a:pPr marL="0" marR="0" lvl="0" indent="0" algn="l" rtl="0">
+                        <a:lnSpc>
+                          <a:spcPct val="100000"/>
+                        </a:lnSpc>
+                        <a:spcBef>
+                          <a:spcPts val="0"/>
+                        </a:spcBef>
+                        <a:spcAft>
+                          <a:spcPts val="0"/>
+                        </a:spcAft>
+                        <a:buNone/>
+                      </a:pPr>
+                      <a:r>
+                        <a:rPr lang="en-US" sz="800" u="none" strike="noStrike" cap="none" dirty="0">
+                          <a:latin typeface="Ubuntu" panose="020B0504030602030204" pitchFamily="34" charset="0"/>
+                        </a:rPr>
+                        <a:t>extension followed by type-id</a:t>
+                      </a:r>
+                      <a:endParaRPr lang="en-US" sz="800" u="none" strike="noStrike" cap="none" dirty="0">
+                        <a:latin typeface="Ubuntu" panose="020B0504030602030204" pitchFamily="34" charset="0"/>
+                      </a:endParaRPr>
+                    </a:p>
+                  </a:txBody>
+                  <a:tcPr marL="91450" marR="91450" marT="45725" marB="45725">
+                    <a:solidFill>
+                      <a:srgbClr val="D8D8D8"/>
+                    </a:solidFill>
+                  </a:tcPr>
+                </a:tc>
               </a:tr>
               <a:tr h="120875">
                 <a:tc>
@@ -7114,16 +6899,16 @@
                         <a:buNone/>
                       </a:pPr>
                       <a:r>
-                        <a:rPr lang="en" sz="800" u="none" strike="noStrike" cap="none">
-                          <a:latin typeface="Ubuntu" pitchFamily="34" charset="0"/>
+                        <a:rPr lang="en-GB" sz="800" u="none" strike="noStrike" cap="none">
+                          <a:latin typeface="Ubuntu" panose="020B0504030602030204" pitchFamily="34" charset="0"/>
                           <a:ea typeface="Consolas"/>
                           <a:cs typeface="Consolas"/>
                           <a:sym typeface="Consolas"/>
                         </a:rPr>
-                        <a:t>{</a:t>
+                        <a:t>[</a:t>
                       </a:r>
                       <a:endParaRPr sz="800" u="none" strike="noStrike" cap="none">
-                        <a:latin typeface="Ubuntu" pitchFamily="34" charset="0"/>
+                        <a:latin typeface="Ubuntu" panose="020B0504030602030204" pitchFamily="34" charset="0"/>
                         <a:ea typeface="Consolas"/>
                         <a:cs typeface="Consolas"/>
                         <a:sym typeface="Consolas"/>
@@ -7154,13 +6939,13 @@
                         <a:buNone/>
                       </a:pPr>
                       <a:r>
-                        <a:rPr lang="en" sz="800" u="none" strike="noStrike" cap="none">
-                          <a:latin typeface="Ubuntu" pitchFamily="34" charset="0"/>
+                        <a:rPr lang="en-GB" sz="800" u="none" strike="noStrike" cap="none">
+                          <a:latin typeface="Ubuntu" panose="020B0504030602030204" pitchFamily="34" charset="0"/>
                         </a:rPr>
                         <a:t>optional</a:t>
                       </a:r>
                       <a:endParaRPr sz="800" u="none" strike="noStrike" cap="none">
-                        <a:latin typeface="Ubuntu" pitchFamily="34" charset="0"/>
+                        <a:latin typeface="Ubuntu" panose="020B0504030602030204" pitchFamily="34" charset="0"/>
                       </a:endParaRPr>
                     </a:p>
                   </a:txBody>
@@ -7188,13 +6973,13 @@
                         <a:buNone/>
                       </a:pPr>
                       <a:r>
-                        <a:rPr lang="en" sz="800" u="none" strike="noStrike" cap="none" dirty="0">
-                          <a:latin typeface="Ubuntu" pitchFamily="34" charset="0"/>
+                        <a:rPr lang="en-GB" sz="800" u="none" strike="noStrike" cap="none" dirty="0">
+                          <a:latin typeface="Ubuntu" panose="020B0504030602030204" pitchFamily="34" charset="0"/>
                         </a:rPr>
                         <a:t>optional</a:t>
                       </a:r>
                       <a:endParaRPr sz="800" u="none" strike="noStrike" cap="none" dirty="0">
-                        <a:latin typeface="Ubuntu" pitchFamily="34" charset="0"/>
+                        <a:latin typeface="Ubuntu" panose="020B0504030602030204" pitchFamily="34" charset="0"/>
                       </a:endParaRPr>
                     </a:p>
                   </a:txBody>
@@ -7222,13 +7007,13 @@
                         <a:buNone/>
                       </a:pPr>
                       <a:r>
-                        <a:rPr lang="en" sz="800" u="none" strike="noStrike" cap="none" dirty="0">
-                          <a:latin typeface="Ubuntu" pitchFamily="34" charset="0"/>
-                        </a:rPr>
-                        <a:t>objects</a:t>
-                      </a:r>
-                      <a:endParaRPr dirty="0">
-                        <a:latin typeface="Ubuntu" pitchFamily="34" charset="0"/>
+                        <a:rPr lang="en-GB" sz="800" u="none" strike="noStrike" cap="none">
+                          <a:latin typeface="Ubuntu" panose="020B0504030602030204" pitchFamily="34" charset="0"/>
+                        </a:rPr>
+                        <a:t>arrays</a:t>
+                      </a:r>
+                      <a:endParaRPr>
+                        <a:latin typeface="Ubuntu" panose="020B0504030602030204" pitchFamily="34" charset="0"/>
                       </a:endParaRPr>
                     </a:p>
                   </a:txBody>
@@ -7238,11 +7023,6 @@
                     </a:solidFill>
                   </a:tcPr>
                 </a:tc>
-                <a:extLst>
-                  <a:ext uri="{0D108BD9-81ED-4DB2-BD59-A6C34878D82A}">
-                    <a16:rowId xmlns:a16="http://schemas.microsoft.com/office/drawing/2014/main" val="10008"/>
-                  </a:ext>
-                </a:extLst>
               </a:tr>
               <a:tr h="120875">
                 <a:tc>
@@ -7263,16 +7043,16 @@
                         <a:buNone/>
                       </a:pPr>
                       <a:r>
-                        <a:rPr lang="en" sz="800" u="none" strike="noStrike" cap="none">
-                          <a:latin typeface="Ubuntu" pitchFamily="34" charset="0"/>
+                        <a:rPr lang="en-GB" sz="800" u="none" strike="noStrike" cap="none">
+                          <a:latin typeface="Ubuntu" panose="020B0504030602030204" pitchFamily="34" charset="0"/>
                           <a:ea typeface="Consolas"/>
                           <a:cs typeface="Consolas"/>
                           <a:sym typeface="Consolas"/>
                         </a:rPr>
-                        <a:t>  […]</a:t>
+                        <a:t>{</a:t>
                       </a:r>
                       <a:endParaRPr sz="800" u="none" strike="noStrike" cap="none">
-                        <a:latin typeface="Ubuntu" pitchFamily="34" charset="0"/>
+                        <a:latin typeface="Ubuntu" panose="020B0504030602030204" pitchFamily="34" charset="0"/>
                         <a:ea typeface="Consolas"/>
                         <a:cs typeface="Consolas"/>
                         <a:sym typeface="Consolas"/>
@@ -7303,13 +7083,13 @@
                         <a:buNone/>
                       </a:pPr>
                       <a:r>
-                        <a:rPr lang="en" sz="800" u="none" strike="noStrike" cap="none">
-                          <a:latin typeface="Ubuntu" pitchFamily="34" charset="0"/>
-                        </a:rPr>
-                        <a:t>no</a:t>
+                        <a:rPr lang="en-GB" sz="800" u="none" strike="noStrike" cap="none">
+                          <a:latin typeface="Ubuntu" panose="020B0504030602030204" pitchFamily="34" charset="0"/>
+                        </a:rPr>
+                        <a:t>optional</a:t>
                       </a:r>
                       <a:endParaRPr sz="800" u="none" strike="noStrike" cap="none">
-                        <a:latin typeface="Ubuntu" pitchFamily="34" charset="0"/>
+                        <a:latin typeface="Ubuntu" panose="020B0504030602030204" pitchFamily="34" charset="0"/>
                       </a:endParaRPr>
                     </a:p>
                   </a:txBody>
@@ -7337,13 +7117,13 @@
                         <a:buNone/>
                       </a:pPr>
                       <a:r>
-                        <a:rPr lang="en" sz="800" u="none" strike="noStrike" cap="none">
-                          <a:latin typeface="Ubuntu" pitchFamily="34" charset="0"/>
+                        <a:rPr lang="en-GB" sz="800" u="none" strike="noStrike" cap="none" dirty="0">
+                          <a:latin typeface="Ubuntu" panose="020B0504030602030204" pitchFamily="34" charset="0"/>
                         </a:rPr>
                         <a:t>optional</a:t>
                       </a:r>
-                      <a:endParaRPr sz="800" u="none" strike="noStrike" cap="none">
-                        <a:latin typeface="Ubuntu" pitchFamily="34" charset="0"/>
+                      <a:endParaRPr sz="800" u="none" strike="noStrike" cap="none" dirty="0">
+                        <a:latin typeface="Ubuntu" panose="020B0504030602030204" pitchFamily="34" charset="0"/>
                       </a:endParaRPr>
                     </a:p>
                   </a:txBody>
@@ -7371,13 +7151,13 @@
                         <a:buNone/>
                       </a:pPr>
                       <a:r>
-                        <a:rPr lang="en" sz="800" u="none" strike="noStrike" cap="none">
-                          <a:latin typeface="Ubuntu" pitchFamily="34" charset="0"/>
-                        </a:rPr>
-                        <a:t>regular array: list of values</a:t>
-                      </a:r>
-                      <a:endParaRPr sz="800" u="none" strike="noStrike" cap="none">
-                        <a:latin typeface="Ubuntu" pitchFamily="34" charset="0"/>
+                        <a:rPr lang="en-GB" sz="800" u="none" strike="noStrike" cap="none" dirty="0">
+                          <a:latin typeface="Ubuntu" panose="020B0504030602030204" pitchFamily="34" charset="0"/>
+                        </a:rPr>
+                        <a:t>objects</a:t>
+                      </a:r>
+                      <a:endParaRPr dirty="0">
+                        <a:latin typeface="Ubuntu" panose="020B0504030602030204" pitchFamily="34" charset="0"/>
                       </a:endParaRPr>
                     </a:p>
                   </a:txBody>
@@ -7387,11 +7167,6 @@
                     </a:solidFill>
                   </a:tcPr>
                 </a:tc>
-                <a:extLst>
-                  <a:ext uri="{0D108BD9-81ED-4DB2-BD59-A6C34878D82A}">
-                    <a16:rowId xmlns:a16="http://schemas.microsoft.com/office/drawing/2014/main" val="10009"/>
-                  </a:ext>
-                </a:extLst>
               </a:tr>
               <a:tr h="120875">
                 <a:tc>
@@ -7412,16 +7187,16 @@
                         <a:buNone/>
                       </a:pPr>
                       <a:r>
-                        <a:rPr lang="en" sz="800" u="none" strike="noStrike" cap="none">
-                          <a:latin typeface="Ubuntu" pitchFamily="34" charset="0"/>
+                        <a:rPr lang="en-GB" sz="800" u="none" strike="noStrike" cap="none">
+                          <a:latin typeface="Ubuntu" panose="020B0504030602030204" pitchFamily="34" charset="0"/>
                           <a:ea typeface="Consolas"/>
                           <a:cs typeface="Consolas"/>
                           <a:sym typeface="Consolas"/>
                         </a:rPr>
-                        <a:t>  {…}</a:t>
+                        <a:t>  […]</a:t>
                       </a:r>
                       <a:endParaRPr sz="800" u="none" strike="noStrike" cap="none">
-                        <a:latin typeface="Ubuntu" pitchFamily="34" charset="0"/>
+                        <a:latin typeface="Ubuntu" panose="020B0504030602030204" pitchFamily="34" charset="0"/>
                         <a:ea typeface="Consolas"/>
                         <a:cs typeface="Consolas"/>
                         <a:sym typeface="Consolas"/>
@@ -7452,13 +7227,13 @@
                         <a:buNone/>
                       </a:pPr>
                       <a:r>
-                        <a:rPr lang="en" sz="800" u="none" strike="noStrike" cap="none">
-                          <a:latin typeface="Ubuntu" pitchFamily="34" charset="0"/>
+                        <a:rPr lang="en-GB" sz="800" u="none" strike="noStrike" cap="none">
+                          <a:latin typeface="Ubuntu" panose="020B0504030602030204" pitchFamily="34" charset="0"/>
                         </a:rPr>
                         <a:t>no</a:t>
                       </a:r>
                       <a:endParaRPr sz="800" u="none" strike="noStrike" cap="none">
-                        <a:latin typeface="Ubuntu" pitchFamily="34" charset="0"/>
+                        <a:latin typeface="Ubuntu" panose="020B0504030602030204" pitchFamily="34" charset="0"/>
                       </a:endParaRPr>
                     </a:p>
                   </a:txBody>
@@ -7486,13 +7261,13 @@
                         <a:buNone/>
                       </a:pPr>
                       <a:r>
-                        <a:rPr lang="en" sz="800" u="none" strike="noStrike" cap="none">
-                          <a:latin typeface="Ubuntu" pitchFamily="34" charset="0"/>
+                        <a:rPr lang="en-GB" sz="800" u="none" strike="noStrike" cap="none">
+                          <a:latin typeface="Ubuntu" panose="020B0504030602030204" pitchFamily="34" charset="0"/>
                         </a:rPr>
                         <a:t>optional</a:t>
                       </a:r>
                       <a:endParaRPr sz="800" u="none" strike="noStrike" cap="none">
-                        <a:latin typeface="Ubuntu" pitchFamily="34" charset="0"/>
+                        <a:latin typeface="Ubuntu" panose="020B0504030602030204" pitchFamily="34" charset="0"/>
                       </a:endParaRPr>
                     </a:p>
                   </a:txBody>
@@ -7520,13 +7295,13 @@
                         <a:buNone/>
                       </a:pPr>
                       <a:r>
-                        <a:rPr lang="en" sz="800" u="none" strike="noStrike" cap="none" dirty="0">
-                          <a:latin typeface="Ubuntu" pitchFamily="34" charset="0"/>
-                        </a:rPr>
-                        <a:t>regular object: name/value pairs</a:t>
-                      </a:r>
-                      <a:endParaRPr sz="800" u="none" strike="noStrike" cap="none" dirty="0">
-                        <a:latin typeface="Ubuntu" pitchFamily="34" charset="0"/>
+                        <a:rPr lang="en-GB" sz="800" u="none" strike="noStrike" cap="none">
+                          <a:latin typeface="Ubuntu" panose="020B0504030602030204" pitchFamily="34" charset="0"/>
+                        </a:rPr>
+                        <a:t>regular array: list of values</a:t>
+                      </a:r>
+                      <a:endParaRPr sz="800" u="none" strike="noStrike" cap="none">
+                        <a:latin typeface="Ubuntu" panose="020B0504030602030204" pitchFamily="34" charset="0"/>
                       </a:endParaRPr>
                     </a:p>
                   </a:txBody>
@@ -7536,11 +7311,6 @@
                     </a:solidFill>
                   </a:tcPr>
                 </a:tc>
-                <a:extLst>
-                  <a:ext uri="{0D108BD9-81ED-4DB2-BD59-A6C34878D82A}">
-                    <a16:rowId xmlns:a16="http://schemas.microsoft.com/office/drawing/2014/main" val="10010"/>
-                  </a:ext>
-                </a:extLst>
               </a:tr>
               <a:tr h="120875">
                 <a:tc>
@@ -7561,16 +7331,16 @@
                         <a:buNone/>
                       </a:pPr>
                       <a:r>
-                        <a:rPr lang="en" sz="800" u="none" strike="noStrike" cap="none">
-                          <a:latin typeface="Ubuntu" pitchFamily="34" charset="0"/>
+                        <a:rPr lang="en-GB" sz="800" u="none" strike="noStrike" cap="none">
+                          <a:latin typeface="Ubuntu" panose="020B0504030602030204" pitchFamily="34" charset="0"/>
                           <a:ea typeface="Consolas"/>
                           <a:cs typeface="Consolas"/>
                           <a:sym typeface="Consolas"/>
                         </a:rPr>
-                        <a:t>  [$◌#◌…</a:t>
+                        <a:t>  {…}</a:t>
                       </a:r>
                       <a:endParaRPr sz="800" u="none" strike="noStrike" cap="none">
-                        <a:latin typeface="Ubuntu" pitchFamily="34" charset="0"/>
+                        <a:latin typeface="Ubuntu" panose="020B0504030602030204" pitchFamily="34" charset="0"/>
                         <a:ea typeface="Consolas"/>
                         <a:cs typeface="Consolas"/>
                         <a:sym typeface="Consolas"/>
@@ -7601,16 +7371,120 @@
                         <a:buNone/>
                       </a:pPr>
                       <a:r>
-                        <a:rPr lang="en" sz="800" u="none" strike="noStrike" cap="none">
-                          <a:latin typeface="Ubuntu" pitchFamily="34" charset="0"/>
+                        <a:rPr lang="en-GB" sz="800" u="none" strike="noStrike" cap="none">
+                          <a:latin typeface="Ubuntu" panose="020B0504030602030204" pitchFamily="34" charset="0"/>
+                        </a:rPr>
+                        <a:t>no</a:t>
+                      </a:r>
+                      <a:endParaRPr sz="800" u="none" strike="noStrike" cap="none">
+                        <a:latin typeface="Ubuntu" panose="020B0504030602030204" pitchFamily="34" charset="0"/>
+                      </a:endParaRPr>
+                    </a:p>
+                  </a:txBody>
+                  <a:tcPr marL="91450" marR="91450" marT="45725" marB="45725">
+                    <a:solidFill>
+                      <a:srgbClr val="92D050"/>
+                    </a:solidFill>
+                  </a:tcPr>
+                </a:tc>
+                <a:tc>
+                  <a:txBody>
+                    <a:bodyPr/>
+                    <a:lstStyle/>
+                    <a:p>
+                      <a:pPr marL="0" marR="0" lvl="0" indent="0" algn="l" rtl="0">
+                        <a:lnSpc>
+                          <a:spcPct val="100000"/>
+                        </a:lnSpc>
+                        <a:spcBef>
+                          <a:spcPts val="0"/>
+                        </a:spcBef>
+                        <a:spcAft>
+                          <a:spcPts val="0"/>
+                        </a:spcAft>
+                        <a:buNone/>
+                      </a:pPr>
+                      <a:r>
+                        <a:rPr lang="en-GB" sz="800" u="none" strike="noStrike" cap="none">
+                          <a:latin typeface="Ubuntu" panose="020B0504030602030204" pitchFamily="34" charset="0"/>
+                        </a:rPr>
+                        <a:t>optional</a:t>
+                      </a:r>
+                      <a:endParaRPr sz="800" u="none" strike="noStrike" cap="none">
+                        <a:latin typeface="Ubuntu" panose="020B0504030602030204" pitchFamily="34" charset="0"/>
+                      </a:endParaRPr>
+                    </a:p>
+                  </a:txBody>
+                  <a:tcPr marL="91450" marR="91450" marT="45725" marB="45725">
+                    <a:solidFill>
+                      <a:srgbClr val="92D050"/>
+                    </a:solidFill>
+                  </a:tcPr>
+                </a:tc>
+                <a:tc>
+                  <a:txBody>
+                    <a:bodyPr/>
+                    <a:lstStyle/>
+                    <a:p>
+                      <a:pPr marL="0" marR="0" lvl="0" indent="0" algn="l" rtl="0">
+                        <a:lnSpc>
+                          <a:spcPct val="100000"/>
+                        </a:lnSpc>
+                        <a:spcBef>
+                          <a:spcPts val="0"/>
+                        </a:spcBef>
+                        <a:spcAft>
+                          <a:spcPts val="0"/>
+                        </a:spcAft>
+                        <a:buNone/>
+                      </a:pPr>
+                      <a:r>
+                        <a:rPr lang="en-GB" sz="800" u="none" strike="noStrike" cap="none" dirty="0">
+                          <a:latin typeface="Ubuntu" panose="020B0504030602030204" pitchFamily="34" charset="0"/>
+                        </a:rPr>
+                        <a:t>regular object: name/value pairs</a:t>
+                      </a:r>
+                      <a:endParaRPr sz="800" u="none" strike="noStrike" cap="none" dirty="0">
+                        <a:latin typeface="Ubuntu" panose="020B0504030602030204" pitchFamily="34" charset="0"/>
+                      </a:endParaRPr>
+                    </a:p>
+                  </a:txBody>
+                  <a:tcPr marL="91450" marR="91450" marT="45725" marB="45725">
+                    <a:solidFill>
+                      <a:srgbClr val="92D050"/>
+                    </a:solidFill>
+                  </a:tcPr>
+                </a:tc>
+              </a:tr>
+              <a:tr h="120875">
+                <a:tc>
+                  <a:txBody>
+                    <a:bodyPr/>
+                    <a:lstStyle/>
+                    <a:p>
+                      <a:pPr marL="0" marR="0" lvl="0" indent="0" algn="l" rtl="0">
+                        <a:lnSpc>
+                          <a:spcPct val="100000"/>
+                        </a:lnSpc>
+                        <a:spcBef>
+                          <a:spcPts val="0"/>
+                        </a:spcBef>
+                        <a:spcAft>
+                          <a:spcPts val="0"/>
+                        </a:spcAft>
+                        <a:buNone/>
+                      </a:pPr>
+                      <a:r>
+                        <a:rPr lang="en-GB" sz="800" u="none" strike="noStrike" cap="none">
+                          <a:latin typeface="Ubuntu" panose="020B0504030602030204" pitchFamily="34" charset="0"/>
                           <a:ea typeface="Consolas"/>
                           <a:cs typeface="Consolas"/>
                           <a:sym typeface="Consolas"/>
                         </a:rPr>
-                        <a:t>#length</a:t>
+                        <a:t>  [$◌#◌…</a:t>
                       </a:r>
                       <a:endParaRPr sz="800" u="none" strike="noStrike" cap="none">
-                        <a:latin typeface="Ubuntu" pitchFamily="34" charset="0"/>
+                        <a:latin typeface="Ubuntu" panose="020B0504030602030204" pitchFamily="34" charset="0"/>
                         <a:ea typeface="Consolas"/>
                         <a:cs typeface="Consolas"/>
                         <a:sym typeface="Consolas"/>
@@ -7641,91 +7515,126 @@
                         <a:buNone/>
                       </a:pPr>
                       <a:r>
-                        <a:rPr lang="en" sz="800" u="none" strike="noStrike" cap="none" dirty="0">
-                          <a:latin typeface="Ubuntu" pitchFamily="34" charset="0"/>
-                        </a:rPr>
-                        <a:t>#*sizeof($type)</a:t>
-                      </a:r>
-                      <a:endParaRPr sz="800" u="none" strike="noStrike" cap="none" dirty="0">
-                        <a:latin typeface="Ubuntu" pitchFamily="34" charset="0"/>
-                      </a:endParaRPr>
-                    </a:p>
-                  </a:txBody>
-                  <a:tcPr marL="91450" marR="91450" marT="45725" marB="45725">
-                    <a:solidFill>
-                      <a:srgbClr val="92D050"/>
-                    </a:solidFill>
-                  </a:tcPr>
-                </a:tc>
-                <a:tc>
-                  <a:txBody>
-                    <a:bodyPr/>
-                    <a:lstStyle/>
-                    <a:p>
-                      <a:pPr marL="0" marR="0" lvl="0" indent="0" algn="l" rtl="0">
-                        <a:lnSpc>
-                          <a:spcPct val="100000"/>
-                        </a:lnSpc>
-                        <a:spcBef>
-                          <a:spcPts val="0"/>
-                        </a:spcBef>
-                        <a:spcAft>
-                          <a:spcPts val="0"/>
-                        </a:spcAft>
-                        <a:buNone/>
-                      </a:pPr>
-                      <a:r>
-                        <a:rPr lang="en" sz="800" u="none" strike="noStrike" cap="none" dirty="0">
-                          <a:latin typeface="Ubuntu" pitchFamily="34" charset="0"/>
-                        </a:rPr>
-                        <a:t>strongly-typed array</a:t>
-                      </a:r>
-                      <a:endParaRPr dirty="0">
-                        <a:latin typeface="Ubuntu" pitchFamily="34" charset="0"/>
-                      </a:endParaRPr>
-                    </a:p>
-                  </a:txBody>
-                  <a:tcPr marL="91450" marR="91450" marT="45725" marB="45725">
-                    <a:solidFill>
-                      <a:srgbClr val="92D050"/>
-                    </a:solidFill>
-                  </a:tcPr>
-                </a:tc>
-                <a:extLst>
-                  <a:ext uri="{0D108BD9-81ED-4DB2-BD59-A6C34878D82A}">
-                    <a16:rowId xmlns:a16="http://schemas.microsoft.com/office/drawing/2014/main" val="10011"/>
-                  </a:ext>
-                </a:extLst>
-              </a:tr>
-              <a:tr h="121940">
-                <a:tc>
-                  <a:txBody>
-                    <a:bodyPr/>
-                    <a:lstStyle/>
-                    <a:p>
-                      <a:pPr marL="0" marR="0" lvl="0" indent="0" algn="l" rtl="0">
-                        <a:lnSpc>
-                          <a:spcPct val="100000"/>
-                        </a:lnSpc>
-                        <a:spcBef>
-                          <a:spcPts val="0"/>
-                        </a:spcBef>
-                        <a:spcAft>
-                          <a:spcPts val="0"/>
-                        </a:spcAft>
-                        <a:buNone/>
-                      </a:pPr>
-                      <a:r>
-                        <a:rPr lang="en" sz="800" u="none" strike="noStrike" cap="none">
-                          <a:latin typeface="Ubuntu" pitchFamily="34" charset="0"/>
+                        <a:rPr lang="en-GB" sz="800" u="none" strike="noStrike" cap="none">
+                          <a:latin typeface="Ubuntu" panose="020B0504030602030204" pitchFamily="34" charset="0"/>
                           <a:ea typeface="Consolas"/>
                           <a:cs typeface="Consolas"/>
                           <a:sym typeface="Consolas"/>
                         </a:rPr>
+                        <a:t>#length</a:t>
+                      </a:r>
+                      <a:endParaRPr sz="800" u="none" strike="noStrike" cap="none">
+                        <a:latin typeface="Ubuntu" panose="020B0504030602030204" pitchFamily="34" charset="0"/>
+                        <a:ea typeface="Consolas"/>
+                        <a:cs typeface="Consolas"/>
+                        <a:sym typeface="Consolas"/>
+                      </a:endParaRPr>
+                    </a:p>
+                  </a:txBody>
+                  <a:tcPr marL="91450" marR="91450" marT="45725" marB="45725">
+                    <a:solidFill>
+                      <a:srgbClr val="92D050"/>
+                    </a:solidFill>
+                  </a:tcPr>
+                </a:tc>
+                <a:tc>
+                  <a:txBody>
+                    <a:bodyPr/>
+                    <a:lstStyle/>
+                    <a:p>
+                      <a:pPr marL="0" marR="0" lvl="0" indent="0" algn="l" rtl="0">
+                        <a:lnSpc>
+                          <a:spcPct val="100000"/>
+                        </a:lnSpc>
+                        <a:spcBef>
+                          <a:spcPts val="0"/>
+                        </a:spcBef>
+                        <a:spcAft>
+                          <a:spcPts val="0"/>
+                        </a:spcAft>
+                        <a:buNone/>
+                      </a:pPr>
+                      <a:r>
+                        <a:rPr lang="en-GB" sz="800" u="none" strike="noStrike" cap="none" dirty="0">
+                          <a:latin typeface="Ubuntu" panose="020B0504030602030204" pitchFamily="34" charset="0"/>
+                        </a:rPr>
+                        <a:t>#*sizeof($type)</a:t>
+                      </a:r>
+                      <a:endParaRPr sz="800" u="none" strike="noStrike" cap="none" dirty="0">
+                        <a:latin typeface="Ubuntu" panose="020B0504030602030204" pitchFamily="34" charset="0"/>
+                      </a:endParaRPr>
+                    </a:p>
+                  </a:txBody>
+                  <a:tcPr marL="91450" marR="91450" marT="45725" marB="45725">
+                    <a:solidFill>
+                      <a:srgbClr val="92D050"/>
+                    </a:solidFill>
+                  </a:tcPr>
+                </a:tc>
+                <a:tc>
+                  <a:txBody>
+                    <a:bodyPr/>
+                    <a:lstStyle/>
+                    <a:p>
+                      <a:pPr marL="0" marR="0" lvl="0" indent="0" algn="l" rtl="0">
+                        <a:lnSpc>
+                          <a:spcPct val="100000"/>
+                        </a:lnSpc>
+                        <a:spcBef>
+                          <a:spcPts val="0"/>
+                        </a:spcBef>
+                        <a:spcAft>
+                          <a:spcPts val="0"/>
+                        </a:spcAft>
+                        <a:buNone/>
+                      </a:pPr>
+                      <a:r>
+                        <a:rPr lang="en-GB" sz="800" u="none" strike="noStrike" cap="none" dirty="0">
+                          <a:latin typeface="Ubuntu" panose="020B0504030602030204" pitchFamily="34" charset="0"/>
+                        </a:rPr>
+                        <a:t>strongly-typed array</a:t>
+                      </a:r>
+                      <a:endParaRPr dirty="0">
+                        <a:latin typeface="Ubuntu" panose="020B0504030602030204" pitchFamily="34" charset="0"/>
+                      </a:endParaRPr>
+                    </a:p>
+                  </a:txBody>
+                  <a:tcPr marL="91450" marR="91450" marT="45725" marB="45725">
+                    <a:solidFill>
+                      <a:srgbClr val="92D050"/>
+                    </a:solidFill>
+                  </a:tcPr>
+                </a:tc>
+              </a:tr>
+              <a:tr h="121940">
+                <a:tc>
+                  <a:txBody>
+                    <a:bodyPr/>
+                    <a:lstStyle/>
+                    <a:p>
+                      <a:pPr marL="0" marR="0" lvl="0" indent="0" algn="l" rtl="0">
+                        <a:lnSpc>
+                          <a:spcPct val="100000"/>
+                        </a:lnSpc>
+                        <a:spcBef>
+                          <a:spcPts val="0"/>
+                        </a:spcBef>
+                        <a:spcAft>
+                          <a:spcPts val="0"/>
+                        </a:spcAft>
+                        <a:buNone/>
+                      </a:pPr>
+                      <a:r>
+                        <a:rPr lang="en-GB" sz="800" u="none" strike="noStrike" cap="none">
+                          <a:latin typeface="Ubuntu" panose="020B0504030602030204" pitchFamily="34" charset="0"/>
+                          <a:ea typeface="Consolas"/>
+                          <a:cs typeface="Consolas"/>
+                          <a:sym typeface="Consolas"/>
+                        </a:rPr>
                         <a:t>  {$◌#◌…</a:t>
                       </a:r>
                       <a:endParaRPr sz="800" u="none" strike="noStrike" cap="none">
-                        <a:latin typeface="Ubuntu" pitchFamily="34" charset="0"/>
+                        <a:latin typeface="Ubuntu" panose="020B0504030602030204" pitchFamily="34" charset="0"/>
                         <a:ea typeface="Consolas"/>
                         <a:cs typeface="Consolas"/>
                         <a:sym typeface="Consolas"/>
@@ -7757,12 +7666,12 @@
                           <a:srgbClr val="000000"/>
                         </a:buClr>
                         <a:buSzPts val="800"/>
-                        <a:buFont typeface="Arial"/>
-                        <a:buNone/>
-                      </a:pPr>
-                      <a:r>
-                        <a:rPr lang="en" sz="800" u="none" strike="noStrike" cap="none">
-                          <a:latin typeface="Ubuntu" pitchFamily="34" charset="0"/>
+                        <a:buFont typeface="Arial" panose="020B0604020202020204"/>
+                        <a:buNone/>
+                      </a:pPr>
+                      <a:r>
+                        <a:rPr lang="en-GB" sz="800" u="none" strike="noStrike" cap="none">
+                          <a:latin typeface="Ubuntu" panose="020B0504030602030204" pitchFamily="34" charset="0"/>
                           <a:ea typeface="Consolas"/>
                           <a:cs typeface="Consolas"/>
                           <a:sym typeface="Consolas"/>
@@ -7770,7 +7679,7 @@
                         <a:t>#length</a:t>
                       </a:r>
                       <a:endParaRPr>
-                        <a:latin typeface="Ubuntu" pitchFamily="34" charset="0"/>
+                        <a:latin typeface="Ubuntu" panose="020B0504030602030204" pitchFamily="34" charset="0"/>
                       </a:endParaRPr>
                     </a:p>
                   </a:txBody>
@@ -7798,7 +7707,7 @@
                         <a:buNone/>
                       </a:pPr>
                       <a:endParaRPr sz="800" u="none" strike="noStrike" cap="none">
-                        <a:latin typeface="Ubuntu" pitchFamily="34" charset="0"/>
+                        <a:latin typeface="Ubuntu" panose="020B0504030602030204" pitchFamily="34" charset="0"/>
                       </a:endParaRPr>
                     </a:p>
                   </a:txBody>
@@ -7826,13 +7735,13 @@
                         <a:buNone/>
                       </a:pPr>
                       <a:r>
-                        <a:rPr lang="en" sz="800" u="none" strike="noStrike" cap="none">
-                          <a:latin typeface="Ubuntu" pitchFamily="34" charset="0"/>
+                        <a:rPr lang="en-GB" sz="800" u="none" strike="noStrike" cap="none">
+                          <a:latin typeface="Ubuntu" panose="020B0504030602030204" pitchFamily="34" charset="0"/>
                         </a:rPr>
                         <a:t>strongly-typed object</a:t>
                       </a:r>
                       <a:endParaRPr>
-                        <a:latin typeface="Ubuntu" pitchFamily="34" charset="0"/>
+                        <a:latin typeface="Ubuntu" panose="020B0504030602030204" pitchFamily="34" charset="0"/>
                       </a:endParaRPr>
                     </a:p>
                   </a:txBody>
@@ -7842,11 +7751,6 @@
                     </a:solidFill>
                   </a:tcPr>
                 </a:tc>
-                <a:extLst>
-                  <a:ext uri="{0D108BD9-81ED-4DB2-BD59-A6C34878D82A}">
-                    <a16:rowId xmlns:a16="http://schemas.microsoft.com/office/drawing/2014/main" val="10012"/>
-                  </a:ext>
-                </a:extLst>
               </a:tr>
               <a:tr h="365770">
                 <a:tc>
@@ -7867,17 +7771,26 @@
                         <a:buNone/>
                       </a:pPr>
                       <a:r>
-                        <a:rPr lang="en" sz="800" u="none" strike="noStrike" cap="none" dirty="0">
+                        <a:rPr lang="en-GB" sz="800" u="none" strike="noStrike" cap="none" dirty="0">
                           <a:solidFill>
                             <a:srgbClr val="FF0000"/>
                           </a:solidFill>
-                          <a:latin typeface="Ubuntu" pitchFamily="34" charset="0"/>
+                          <a:latin typeface="Ubuntu" panose="020B0504030602030204" pitchFamily="34" charset="0"/>
                           <a:ea typeface="Consolas"/>
                           <a:cs typeface="Consolas"/>
                           <a:sym typeface="Consolas"/>
                         </a:rPr>
                         <a:t>[$◌#[n1,n2,…]…</a:t>
                       </a:r>
+                      <a:endParaRPr lang="en-GB" sz="800" u="none" strike="noStrike" cap="none" dirty="0">
+                        <a:solidFill>
+                          <a:srgbClr val="FF0000"/>
+                        </a:solidFill>
+                        <a:latin typeface="Ubuntu" panose="020B0504030602030204" pitchFamily="34" charset="0"/>
+                        <a:ea typeface="Consolas"/>
+                        <a:cs typeface="Consolas"/>
+                        <a:sym typeface="Consolas"/>
+                      </a:endParaRPr>
                     </a:p>
                     <a:p>
                       <a:pPr marL="0" marR="0" lvl="0" indent="0" algn="l" defTabSz="914400" rtl="0" eaLnBrk="1" fontAlgn="auto" latinLnBrk="0" hangingPunct="1">
@@ -7894,7 +7807,6 @@
                         <a:buSzTx/>
                         <a:buFontTx/>
                         <a:buNone/>
-                        <a:tabLst/>
                         <a:defRPr/>
                       </a:pPr>
                       <a:r>
@@ -7902,7 +7814,7 @@
                           <a:solidFill>
                             <a:srgbClr val="FF0000"/>
                           </a:solidFill>
-                          <a:latin typeface="Ubuntu" pitchFamily="34" charset="0"/>
+                          <a:latin typeface="Ubuntu" panose="020B0504030602030204" pitchFamily="34" charset="0"/>
                           <a:ea typeface="Consolas"/>
                           <a:cs typeface="Consolas"/>
                           <a:sym typeface="Consolas"/>
@@ -7914,24 +7826,33 @@
                           <a:solidFill>
                             <a:srgbClr val="FF0000"/>
                           </a:solidFill>
-                          <a:latin typeface="Ubuntu" pitchFamily="34" charset="0"/>
+                          <a:latin typeface="Ubuntu" panose="020B0504030602030204" pitchFamily="34" charset="0"/>
                           <a:ea typeface="Consolas"/>
                           <a:cs typeface="Consolas"/>
                           <a:sym typeface="Consolas"/>
                         </a:rPr>
                       </a:br>
                       <a:r>
-                        <a:rPr lang="en" sz="800" u="none" strike="noStrike" cap="none" dirty="0">
+                        <a:rPr lang="en-GB" sz="800" u="none" strike="noStrike" cap="none" dirty="0">
                           <a:solidFill>
                             <a:srgbClr val="FF0000"/>
                           </a:solidFill>
-                          <a:latin typeface="Ubuntu" pitchFamily="34" charset="0"/>
+                          <a:latin typeface="Ubuntu" panose="020B0504030602030204" pitchFamily="34" charset="0"/>
                           <a:ea typeface="Consolas"/>
                           <a:cs typeface="Consolas"/>
                           <a:sym typeface="Consolas"/>
                         </a:rPr>
                         <a:t>[$◌#[[n1,n2,…]]…</a:t>
                       </a:r>
+                      <a:endParaRPr lang="en-GB" sz="800" u="none" strike="noStrike" cap="none" dirty="0">
+                        <a:solidFill>
+                          <a:srgbClr val="FF0000"/>
+                        </a:solidFill>
+                        <a:latin typeface="Ubuntu" panose="020B0504030602030204" pitchFamily="34" charset="0"/>
+                        <a:ea typeface="Consolas"/>
+                        <a:cs typeface="Consolas"/>
+                        <a:sym typeface="Consolas"/>
+                      </a:endParaRPr>
                     </a:p>
                   </a:txBody>
                   <a:tcPr marL="27432" marR="27432" marT="45725" marB="45725">
@@ -7959,10 +7880,13 @@
                       </a:pPr>
                       <a:r>
                         <a:rPr lang="en-US" sz="800" u="none" strike="noStrike" cap="none" baseline="0" dirty="0">
-                          <a:latin typeface="Ubuntu" pitchFamily="34" charset="0"/>
+                          <a:latin typeface="Ubuntu" panose="020B0504030602030204" pitchFamily="34" charset="0"/>
                         </a:rPr>
                         <a:t>#[…] 1d vector or</a:t>
                       </a:r>
+                      <a:endParaRPr lang="en-US" sz="800" u="none" strike="noStrike" cap="none" baseline="0" dirty="0">
+                        <a:latin typeface="Ubuntu" panose="020B0504030602030204" pitchFamily="34" charset="0"/>
+                      </a:endParaRPr>
                     </a:p>
                     <a:p>
                       <a:pPr marL="0" marR="0" lvl="0" indent="0" algn="l" defTabSz="914400" rtl="0" eaLnBrk="1" fontAlgn="auto" latinLnBrk="0" hangingPunct="1">
@@ -7979,17 +7903,16 @@
                         <a:buSzTx/>
                         <a:buFontTx/>
                         <a:buNone/>
-                        <a:tabLst/>
                         <a:defRPr/>
                       </a:pPr>
                       <a:r>
                         <a:rPr lang="en-US" sz="800" u="none" strike="noStrike" cap="none" baseline="0" dirty="0">
-                          <a:latin typeface="Ubuntu" pitchFamily="34" charset="0"/>
+                          <a:latin typeface="Ubuntu" panose="020B0504030602030204" pitchFamily="34" charset="0"/>
                         </a:rPr>
                         <a:t>#[[…]]</a:t>
                       </a:r>
                       <a:endParaRPr lang="en-US" sz="800" u="none" strike="noStrike" cap="none" dirty="0">
-                        <a:latin typeface="Ubuntu" pitchFamily="34" charset="0"/>
+                        <a:latin typeface="Ubuntu" panose="020B0504030602030204" pitchFamily="34" charset="0"/>
                       </a:endParaRPr>
                     </a:p>
                   </a:txBody>
@@ -8017,19 +7940,19 @@
                         <a:buNone/>
                       </a:pPr>
                       <a:r>
-                        <a:rPr lang="en" sz="700" u="none" strike="noStrike" cap="none" dirty="0">
-                          <a:latin typeface="Ubuntu" pitchFamily="34" charset="0"/>
+                        <a:rPr lang="en-GB" sz="700" u="none" strike="noStrike" cap="none" dirty="0">
+                          <a:latin typeface="Ubuntu" panose="020B0504030602030204" pitchFamily="34" charset="0"/>
                         </a:rPr>
                         <a:t>n1*n2*..*sizeof($) bytes of</a:t>
                       </a:r>
                       <a:r>
-                        <a:rPr lang="en" sz="700" u="none" strike="noStrike" cap="none" baseline="0" dirty="0">
-                          <a:latin typeface="Ubuntu" pitchFamily="34" charset="0"/>
+                        <a:rPr lang="en-GB" sz="700" u="none" strike="noStrike" cap="none" baseline="0" dirty="0">
+                          <a:latin typeface="Ubuntu" panose="020B0504030602030204" pitchFamily="34" charset="0"/>
                         </a:rPr>
                         <a:t> binary data, #[[…]] column-major</a:t>
                       </a:r>
                       <a:endParaRPr sz="700" u="none" strike="noStrike" cap="none" dirty="0">
-                        <a:latin typeface="Ubuntu" pitchFamily="34" charset="0"/>
+                        <a:latin typeface="Ubuntu" panose="020B0504030602030204" pitchFamily="34" charset="0"/>
                       </a:endParaRPr>
                     </a:p>
                   </a:txBody>
@@ -8057,13 +7980,13 @@
                         <a:buNone/>
                       </a:pPr>
                       <a:r>
-                        <a:rPr lang="en" sz="800" u="none" strike="noStrike" cap="none" dirty="0">
-                          <a:latin typeface="Ubuntu" pitchFamily="34" charset="0"/>
+                        <a:rPr lang="en-GB" sz="800" u="none" strike="noStrike" cap="none" dirty="0">
+                          <a:latin typeface="Ubuntu" panose="020B0504030602030204" pitchFamily="34" charset="0"/>
                         </a:rPr>
                         <a:t>strongly-typed ND-array (when length # followed by a 1D vector)</a:t>
                       </a:r>
                       <a:endParaRPr sz="800" u="none" strike="noStrike" cap="none" dirty="0">
-                        <a:latin typeface="Ubuntu" pitchFamily="34" charset="0"/>
+                        <a:latin typeface="Ubuntu" panose="020B0504030602030204" pitchFamily="34" charset="0"/>
                       </a:endParaRPr>
                     </a:p>
                   </a:txBody>
@@ -8073,11 +7996,6 @@
                     </a:solidFill>
                   </a:tcPr>
                 </a:tc>
-                <a:extLst>
-                  <a:ext uri="{0D108BD9-81ED-4DB2-BD59-A6C34878D82A}">
-                    <a16:rowId xmlns:a16="http://schemas.microsoft.com/office/drawing/2014/main" val="10013"/>
-                  </a:ext>
-                </a:extLst>
               </a:tr>
             </a:tbl>
           </a:graphicData>
@@ -8091,7 +8009,7 @@
         </p:nvGrpSpPr>
         <p:grpSpPr>
           <a:xfrm>
-            <a:off x="4642417" y="870718"/>
+            <a:off x="4642417" y="642118"/>
             <a:ext cx="4196783" cy="1003026"/>
             <a:chOff x="4490017" y="811826"/>
             <a:chExt cx="4196783" cy="1003026"/>
@@ -8123,7 +8041,7 @@
                   <a:solidFill>
                     <a:srgbClr val="00B050"/>
                   </a:solidFill>
-                  <a:latin typeface="Ubuntu Mono" pitchFamily="49" charset="0"/>
+                  <a:latin typeface="Ubuntu Mono" panose="020B0509030602030204" pitchFamily="49" charset="0"/>
                 </a:rPr>
                 <a:t>Z,T,F</a:t>
               </a:r>
@@ -8237,6 +8155,9 @@
                     </a:rPr>
                     <a:t>Type</a:t>
                   </a:r>
+                  <a:endParaRPr lang="en-US" sz="1200" dirty="0">
+                    <a:latin typeface="Raleway ExtraBold" pitchFamily="2" charset="0"/>
+                  </a:endParaRPr>
                 </a:p>
               </p:txBody>
             </p:sp>
@@ -8318,6 +8239,9 @@
                     </a:rPr>
                     <a:t>Length</a:t>
                   </a:r>
+                  <a:endParaRPr lang="en-US" sz="1200" dirty="0">
+                    <a:latin typeface="Raleway ExtraBold" pitchFamily="2" charset="0"/>
+                  </a:endParaRPr>
                 </a:p>
               </p:txBody>
             </p:sp>
@@ -8329,7 +8253,7 @@
               </p:nvSpPr>
               <p:spPr>
                 <a:xfrm>
-                  <a:off x="7315200" y="1174750"/>
+                  <a:off x="7391400" y="1174750"/>
                   <a:ext cx="853109" cy="304800"/>
                 </a:xfrm>
                 <a:prstGeom prst="rect">
@@ -8363,6 +8287,9 @@
                     </a:rPr>
                     <a:t>Payload</a:t>
                   </a:r>
+                  <a:endParaRPr lang="en-US" sz="1200" dirty="0">
+                    <a:latin typeface="Raleway ExtraBold" pitchFamily="2" charset="0"/>
+                  </a:endParaRPr>
                 </a:p>
               </p:txBody>
             </p:sp>
@@ -8374,8 +8301,8 @@
               </p:nvSpPr>
               <p:spPr>
                 <a:xfrm>
-                  <a:off x="5797834" y="1066800"/>
-                  <a:ext cx="1517366" cy="257175"/>
+                  <a:off x="5798117" y="1066800"/>
+                  <a:ext cx="1593850" cy="257175"/>
                 </a:xfrm>
                 <a:custGeom>
                   <a:avLst/>
@@ -8629,12 +8556,12 @@
               </p:nvCxnSpPr>
               <p:spPr>
                 <a:xfrm flipV="1">
-                  <a:off x="6538733" y="1327150"/>
-                  <a:ext cx="776467" cy="335302"/>
+                  <a:off x="6538595" y="1327313"/>
+                  <a:ext cx="852805" cy="335280"/>
                 </a:xfrm>
                 <a:prstGeom prst="bentConnector3">
                   <a:avLst>
-                    <a:gd name="adj1" fmla="val 50000"/>
+                    <a:gd name="adj1" fmla="val 50045"/>
                   </a:avLst>
                 </a:prstGeom>
                 <a:ln>
@@ -8684,7 +8611,7 @@
                     <a:solidFill>
                       <a:srgbClr val="00B050"/>
                     </a:solidFill>
-                    <a:latin typeface="Ubuntu Mono" pitchFamily="49" charset="0"/>
+                    <a:latin typeface="Ubuntu Mono" panose="020B0509030602030204" pitchFamily="49" charset="0"/>
                   </a:rPr>
                   <a:t>S,H</a:t>
                 </a:r>
@@ -8700,8 +8627,8 @@
             </p:nvSpPr>
             <p:spPr>
               <a:xfrm>
-                <a:off x="5737440" y="1135446"/>
-                <a:ext cx="1712334" cy="230832"/>
+                <a:off x="5721917" y="1097280"/>
+                <a:ext cx="1746885" cy="229870"/>
               </a:xfrm>
               <a:prstGeom prst="rect">
                 <a:avLst/>
@@ -8718,9 +8645,9 @@
                     <a:solidFill>
                       <a:srgbClr val="00B050"/>
                     </a:solidFill>
-                    <a:latin typeface="Ubuntu Mono" pitchFamily="49" charset="0"/>
+                    <a:latin typeface="Ubuntu Mono" panose="020B0509030602030204" pitchFamily="49" charset="0"/>
                   </a:rPr>
-                  <a:t>U,i,u,I,m,l,M,L,h,d,D,C,B</a:t>
+                  <a:t>U,i,u,I,m,l,M,L,h,d,D,C,B,E</a:t>
                 </a:r>
                 <a:endParaRPr lang="en-US" sz="1200" dirty="0"/>
               </a:p>
@@ -8736,7 +8663,7 @@
         </p:nvSpPr>
         <p:spPr>
           <a:xfrm>
-            <a:off x="389624" y="757129"/>
+            <a:off x="389624" y="528529"/>
             <a:ext cx="2090637" cy="261610"/>
           </a:xfrm>
           <a:prstGeom prst="rect">
@@ -8783,7 +8710,7 @@
         </p:nvSpPr>
         <p:spPr>
           <a:xfrm>
-            <a:off x="4440474" y="757129"/>
+            <a:off x="4440474" y="528529"/>
             <a:ext cx="2012089" cy="261610"/>
           </a:xfrm>
           <a:prstGeom prst="rect">
@@ -8821,7 +8748,7 @@
         </p:nvSpPr>
         <p:spPr>
           <a:xfrm>
-            <a:off x="389624" y="1684047"/>
+            <a:off x="389624" y="1455447"/>
             <a:ext cx="1689886" cy="261610"/>
           </a:xfrm>
           <a:prstGeom prst="rect">
@@ -8859,7 +8786,7 @@
         </p:nvSpPr>
         <p:spPr>
           <a:xfrm>
-            <a:off x="3752850" y="2184400"/>
+            <a:off x="3752850" y="1955800"/>
             <a:ext cx="1854200" cy="114300"/>
           </a:xfrm>
           <a:custGeom>
@@ -8970,7 +8897,7 @@
         </p:nvCxnSpPr>
         <p:spPr>
           <a:xfrm>
-            <a:off x="4006850" y="2184400"/>
+            <a:off x="4006850" y="1955800"/>
             <a:ext cx="965200" cy="0"/>
           </a:xfrm>
           <a:prstGeom prst="line">
@@ -9000,7 +8927,7 @@
         </p:nvGrpSpPr>
         <p:grpSpPr>
           <a:xfrm>
-            <a:off x="514272" y="1917021"/>
+            <a:off x="514272" y="1688421"/>
             <a:ext cx="5093292" cy="826179"/>
             <a:chOff x="514272" y="1764621"/>
             <a:chExt cx="5093292" cy="826179"/>
@@ -9098,6 +9025,9 @@
                   </a:rPr>
                   <a:t>[, {</a:t>
                 </a:r>
+                <a:endParaRPr lang="en-US" sz="1200" dirty="0">
+                  <a:latin typeface="Raleway ExtraBold" pitchFamily="2" charset="0"/>
+                </a:endParaRPr>
               </a:p>
             </p:txBody>
           </p:sp>
@@ -9386,6 +9316,9 @@
                   </a:rPr>
                   <a:t>Payload</a:t>
                 </a:r>
+                <a:endParaRPr lang="en-US" sz="1200" dirty="0">
+                  <a:latin typeface="Raleway ExtraBold" pitchFamily="2" charset="0"/>
+                </a:endParaRPr>
               </a:p>
             </p:txBody>
           </p:sp>
@@ -9431,6 +9364,9 @@
                   </a:rPr>
                   <a:t>$</a:t>
                 </a:r>
+                <a:endParaRPr lang="en-US" sz="1200" dirty="0">
+                  <a:latin typeface="Raleway ExtraBold" pitchFamily="2" charset="0"/>
+                </a:endParaRPr>
               </a:p>
             </p:txBody>
           </p:sp>
@@ -9476,6 +9412,9 @@
                   </a:rPr>
                   <a:t>#</a:t>
                 </a:r>
+                <a:endParaRPr lang="en-US" sz="1200" dirty="0">
+                  <a:latin typeface="Raleway ExtraBold" pitchFamily="2" charset="0"/>
+                </a:endParaRPr>
               </a:p>
             </p:txBody>
           </p:sp>
@@ -9521,6 +9460,9 @@
                   </a:rPr>
                   <a:t>Length</a:t>
                 </a:r>
+                <a:endParaRPr lang="en-US" sz="1200" dirty="0">
+                  <a:latin typeface="Raleway ExtraBold" pitchFamily="2" charset="0"/>
+                </a:endParaRPr>
               </a:p>
             </p:txBody>
           </p:sp>
@@ -9566,6 +9508,9 @@
                   </a:rPr>
                   <a:t>Type</a:t>
                 </a:r>
+                <a:endParaRPr lang="en-US" sz="1200" dirty="0">
+                  <a:latin typeface="Raleway ExtraBold" pitchFamily="2" charset="0"/>
+                </a:endParaRPr>
               </a:p>
             </p:txBody>
           </p:sp>
@@ -9681,6 +9626,9 @@
                   </a:rPr>
                   <a:t>], }</a:t>
                 </a:r>
+                <a:endParaRPr lang="en-US" sz="1200" dirty="0">
+                  <a:latin typeface="Raleway ExtraBold" pitchFamily="2" charset="0"/>
+                </a:endParaRPr>
               </a:p>
             </p:txBody>
           </p:sp>
@@ -9730,7 +9678,7 @@
         </p:nvSpPr>
         <p:spPr>
           <a:xfrm>
-            <a:off x="2389449" y="2806700"/>
+            <a:off x="2389449" y="2578100"/>
             <a:ext cx="3820501" cy="689550"/>
           </a:xfrm>
           <a:prstGeom prst="roundRect">
@@ -9775,9 +9723,9 @@
                   <a:schemeClr val="dk2"/>
                 </a:solidFill>
                 <a:latin typeface="Raleway ExtraBold" pitchFamily="2" charset="0"/>
-                <a:ea typeface="Arial"/>
-                <a:cs typeface="Arial"/>
-                <a:sym typeface="Arial"/>
+                <a:ea typeface="Arial" panose="020B0604020202020204"/>
+                <a:cs typeface="Arial" panose="020B0604020202020204"/>
+                <a:sym typeface="Arial" panose="020B0604020202020204"/>
               </a:rPr>
               <a:t>Type-Marker</a:t>
             </a:r>
@@ -9787,9 +9735,9 @@
                   <a:schemeClr val="dk2"/>
                 </a:solidFill>
                 <a:latin typeface="Raleway ExtraBold" pitchFamily="2" charset="0"/>
-                <a:ea typeface="Arial"/>
-                <a:cs typeface="Arial"/>
-                <a:sym typeface="Arial"/>
+                <a:ea typeface="Arial" panose="020B0604020202020204"/>
+                <a:cs typeface="Arial" panose="020B0604020202020204"/>
+                <a:sym typeface="Arial" panose="020B0604020202020204"/>
               </a:rPr>
               <a:t>   </a:t>
             </a:r>
@@ -9799,9 +9747,9 @@
                   <a:srgbClr val="A6A6A6"/>
                 </a:solidFill>
                 <a:latin typeface="Raleway ExtraBold" pitchFamily="2" charset="0"/>
-                <a:ea typeface="Arial"/>
-                <a:cs typeface="Arial"/>
-                <a:sym typeface="Arial"/>
+                <a:ea typeface="Arial" panose="020B0604020202020204"/>
+                <a:cs typeface="Arial" panose="020B0604020202020204"/>
+                <a:sym typeface="Arial" panose="020B0604020202020204"/>
               </a:rPr>
               <a:t>&lt;</a:t>
             </a:r>
@@ -9811,9 +9759,9 @@
                   <a:srgbClr val="A6A6A6"/>
                 </a:solidFill>
                 <a:latin typeface="Raleway ExtraBold" pitchFamily="2" charset="0"/>
-                <a:ea typeface="Arial"/>
-                <a:cs typeface="Arial"/>
-                <a:sym typeface="Arial"/>
+                <a:ea typeface="Arial" panose="020B0604020202020204"/>
+                <a:cs typeface="Arial" panose="020B0604020202020204"/>
+                <a:sym typeface="Arial" panose="020B0604020202020204"/>
               </a:rPr>
               <a:t>Length</a:t>
             </a:r>
@@ -9823,9 +9771,9 @@
                   <a:srgbClr val="A6A6A6"/>
                 </a:solidFill>
                 <a:latin typeface="Raleway ExtraBold" pitchFamily="2" charset="0"/>
-                <a:ea typeface="Arial"/>
-                <a:cs typeface="Arial"/>
-                <a:sym typeface="Arial"/>
+                <a:ea typeface="Arial" panose="020B0604020202020204"/>
+                <a:cs typeface="Arial" panose="020B0604020202020204"/>
+                <a:sym typeface="Arial" panose="020B0604020202020204"/>
               </a:rPr>
               <a:t>&gt;   &lt;</a:t>
             </a:r>
@@ -9835,9 +9783,9 @@
                   <a:srgbClr val="A6A6A6"/>
                 </a:solidFill>
                 <a:latin typeface="Raleway ExtraBold" pitchFamily="2" charset="0"/>
-                <a:ea typeface="Arial"/>
-                <a:cs typeface="Arial"/>
-                <a:sym typeface="Arial"/>
+                <a:ea typeface="Arial" panose="020B0604020202020204"/>
+                <a:cs typeface="Arial" panose="020B0604020202020204"/>
+                <a:sym typeface="Arial" panose="020B0604020202020204"/>
               </a:rPr>
               <a:t>Payload</a:t>
             </a:r>
@@ -9847,12 +9795,21 @@
                   <a:srgbClr val="A6A6A6"/>
                 </a:solidFill>
                 <a:latin typeface="Raleway ExtraBold" pitchFamily="2" charset="0"/>
-                <a:ea typeface="Arial"/>
-                <a:cs typeface="Arial"/>
-                <a:sym typeface="Arial"/>
+                <a:ea typeface="Arial" panose="020B0604020202020204"/>
+                <a:cs typeface="Arial" panose="020B0604020202020204"/>
+                <a:sym typeface="Arial" panose="020B0604020202020204"/>
               </a:rPr>
               <a:t>&gt;</a:t>
             </a:r>
+            <a:endParaRPr lang="en-US" sz="1600" dirty="0">
+              <a:solidFill>
+                <a:srgbClr val="A6A6A6"/>
+              </a:solidFill>
+              <a:latin typeface="Raleway ExtraBold" pitchFamily="2" charset="0"/>
+              <a:ea typeface="Arial" panose="020B0604020202020204"/>
+              <a:cs typeface="Arial" panose="020B0604020202020204"/>
+              <a:sym typeface="Arial" panose="020B0604020202020204"/>
+            </a:endParaRPr>
           </a:p>
           <a:p>
             <a:pPr marL="114300" lvl="0">
@@ -9870,12 +9827,21 @@
                   <a:schemeClr val="dk2"/>
                 </a:solidFill>
                 <a:latin typeface="Raleway" pitchFamily="2" charset="0"/>
-                <a:ea typeface="Arial"/>
-                <a:cs typeface="Arial"/>
-                <a:sym typeface="Arial"/>
+                <a:ea typeface="Arial" panose="020B0604020202020204"/>
+                <a:cs typeface="Arial" panose="020B0604020202020204"/>
+                <a:sym typeface="Arial" panose="020B0604020202020204"/>
               </a:rPr>
               <a:t>1-byte-char         an integer     binary data</a:t>
             </a:r>
+            <a:endParaRPr lang="en-US" sz="1400" dirty="0">
+              <a:solidFill>
+                <a:schemeClr val="dk2"/>
+              </a:solidFill>
+              <a:latin typeface="Raleway" pitchFamily="2" charset="0"/>
+              <a:ea typeface="Arial" panose="020B0604020202020204"/>
+              <a:cs typeface="Arial" panose="020B0604020202020204"/>
+              <a:sym typeface="Arial" panose="020B0604020202020204"/>
+            </a:endParaRPr>
           </a:p>
         </p:txBody>
       </p:sp>
@@ -9887,7 +9853,7 @@
         </p:nvSpPr>
         <p:spPr>
           <a:xfrm>
-            <a:off x="2544859" y="2459995"/>
+            <a:off x="2544859" y="2231395"/>
             <a:ext cx="1970411" cy="261610"/>
           </a:xfrm>
           <a:prstGeom prst="rect">
@@ -9925,7 +9891,7 @@
         </p:nvSpPr>
         <p:spPr>
           <a:xfrm>
-            <a:off x="6224643" y="2144373"/>
+            <a:off x="6224643" y="1915773"/>
             <a:ext cx="1146468" cy="861774"/>
           </a:xfrm>
           <a:prstGeom prst="rect">
@@ -9954,57 +9920,63 @@
           <a:p>
             <a:r>
               <a:rPr lang="en-US" sz="1000" dirty="0">
-                <a:latin typeface="Ubuntu Mono" pitchFamily="49" charset="0"/>
+                <a:latin typeface="Ubuntu Mono" panose="020B0509030602030204" pitchFamily="49" charset="0"/>
               </a:rPr>
               <a:t>{</a:t>
             </a:r>
             <a:br>
               <a:rPr lang="en-US" sz="1000" dirty="0">
-                <a:latin typeface="Ubuntu Mono" pitchFamily="49" charset="0"/>
+                <a:latin typeface="Ubuntu Mono" panose="020B0509030602030204" pitchFamily="49" charset="0"/>
               </a:rPr>
             </a:br>
             <a:r>
               <a:rPr lang="en-US" sz="1000" dirty="0">
-                <a:latin typeface="Ubuntu Mono" pitchFamily="49" charset="0"/>
+                <a:latin typeface="Ubuntu Mono" panose="020B0509030602030204" pitchFamily="49" charset="0"/>
               </a:rPr>
               <a:t>  “a”: [1,2,3],</a:t>
             </a:r>
             <a:br>
               <a:rPr lang="en-US" sz="1000" dirty="0">
-                <a:latin typeface="Ubuntu Mono" pitchFamily="49" charset="0"/>
+                <a:latin typeface="Ubuntu Mono" panose="020B0509030602030204" pitchFamily="49" charset="0"/>
               </a:rPr>
             </a:br>
             <a:r>
               <a:rPr lang="en-US" sz="1000" dirty="0">
-                <a:latin typeface="Ubuntu Mono" pitchFamily="49" charset="0"/>
+                <a:latin typeface="Ubuntu Mono" panose="020B0509030602030204" pitchFamily="49" charset="0"/>
               </a:rPr>
               <a:t>  “b”: true,</a:t>
             </a:r>
+            <a:endParaRPr lang="en-US" sz="1000" dirty="0">
+              <a:latin typeface="Ubuntu Mono" panose="020B0509030602030204" pitchFamily="49" charset="0"/>
+            </a:endParaRPr>
           </a:p>
           <a:p>
             <a:r>
               <a:rPr lang="en-US" sz="1000" dirty="0">
-                <a:latin typeface="Ubuntu Mono" pitchFamily="49" charset="0"/>
+                <a:latin typeface="Ubuntu Mono" panose="020B0509030602030204" pitchFamily="49" charset="0"/>
               </a:rPr>
               <a:t>  “c</a:t>
             </a:r>
             <a:r>
               <a:rPr lang="en-US" sz="1000">
-                <a:latin typeface="Ubuntu Mono" pitchFamily="49" charset="0"/>
+                <a:latin typeface="Ubuntu Mono" panose="020B0509030602030204" pitchFamily="49" charset="0"/>
               </a:rPr>
               <a:t>”: “string”</a:t>
             </a:r>
             <a:endParaRPr lang="en-US" sz="1000" dirty="0">
-              <a:latin typeface="Ubuntu Mono" pitchFamily="49" charset="0"/>
+              <a:latin typeface="Ubuntu Mono" panose="020B0509030602030204" pitchFamily="49" charset="0"/>
             </a:endParaRPr>
           </a:p>
           <a:p>
             <a:r>
               <a:rPr lang="en-US" sz="1000" dirty="0">
-                <a:latin typeface="Ubuntu Mono" pitchFamily="49" charset="0"/>
+                <a:latin typeface="Ubuntu Mono" panose="020B0509030602030204" pitchFamily="49" charset="0"/>
               </a:rPr>
               <a:t>}</a:t>
             </a:r>
+            <a:endParaRPr lang="en-US" sz="1000" dirty="0">
+              <a:latin typeface="Ubuntu Mono" panose="020B0509030602030204" pitchFamily="49" charset="0"/>
+            </a:endParaRPr>
           </a:p>
         </p:txBody>
       </p:sp>
@@ -10045,45 +10017,57 @@
           <a:p>
             <a:r>
               <a:rPr lang="en-US" sz="1000" dirty="0">
-                <a:latin typeface="Ubuntu Mono" pitchFamily="49" charset="0"/>
+                <a:latin typeface="Ubuntu Mono" panose="020B0509030602030204" pitchFamily="49" charset="0"/>
               </a:rPr>
               <a:t>{</a:t>
             </a:r>
+            <a:endParaRPr lang="en-US" sz="1000" dirty="0">
+              <a:latin typeface="Ubuntu Mono" panose="020B0509030602030204" pitchFamily="49" charset="0"/>
+            </a:endParaRPr>
           </a:p>
           <a:p>
             <a:r>
               <a:rPr lang="en-US" sz="1000" dirty="0">
-                <a:latin typeface="Ubuntu Mono" pitchFamily="49" charset="0"/>
+                <a:latin typeface="Ubuntu Mono" panose="020B0509030602030204" pitchFamily="49" charset="0"/>
               </a:rPr>
               <a:t> U1a [$U#U3\0x1\0x2\0x3</a:t>
             </a:r>
             <a:br>
               <a:rPr lang="en-US" sz="1000" dirty="0">
-                <a:latin typeface="Ubuntu Mono" pitchFamily="49" charset="0"/>
+                <a:latin typeface="Ubuntu Mono" panose="020B0509030602030204" pitchFamily="49" charset="0"/>
               </a:rPr>
             </a:br>
             <a:r>
               <a:rPr lang="en-US" sz="1000" dirty="0">
-                <a:latin typeface="Ubuntu Mono" pitchFamily="49" charset="0"/>
+                <a:latin typeface="Ubuntu Mono" panose="020B0509030602030204" pitchFamily="49" charset="0"/>
               </a:rPr>
               <a:t> U1b T</a:t>
             </a:r>
+            <a:endParaRPr lang="en-US" sz="1000" dirty="0">
+              <a:latin typeface="Ubuntu Mono" panose="020B0509030602030204" pitchFamily="49" charset="0"/>
+            </a:endParaRPr>
           </a:p>
           <a:p>
             <a:r>
               <a:rPr lang="en-US" sz="1000" dirty="0">
-                <a:latin typeface="Ubuntu Mono" pitchFamily="49" charset="0"/>
+                <a:latin typeface="Ubuntu Mono" panose="020B0509030602030204" pitchFamily="49" charset="0"/>
               </a:rPr>
               <a:t> U1c SU6string</a:t>
             </a:r>
+            <a:endParaRPr lang="en-US" sz="1000" dirty="0">
+              <a:latin typeface="Ubuntu Mono" panose="020B0509030602030204" pitchFamily="49" charset="0"/>
+            </a:endParaRPr>
           </a:p>
           <a:p>
             <a:r>
               <a:rPr lang="en-US" sz="1000" dirty="0">
-                <a:latin typeface="Ubuntu Mono" pitchFamily="49" charset="0"/>
+                <a:latin typeface="Ubuntu Mono" panose="020B0509030602030204" pitchFamily="49" charset="0"/>
               </a:rPr>
               <a:t>}</a:t>
             </a:r>
+            <a:endParaRPr lang="en-US" sz="1000" dirty="0">
+              <a:latin typeface="Ubuntu Mono" panose="020B0509030602030204" pitchFamily="49" charset="0"/>
+            </a:endParaRPr>
           </a:p>
         </p:txBody>
       </p:sp>
@@ -10095,7 +10079,7 @@
         </p:nvSpPr>
         <p:spPr>
           <a:xfrm>
-            <a:off x="7226352" y="2487388"/>
+            <a:off x="7226352" y="2258788"/>
             <a:ext cx="287875" cy="228370"/>
           </a:xfrm>
           <a:prstGeom prst="rightArrow">
@@ -10128,11 +10112,6 @@
         </p:txBody>
       </p:sp>
     </p:spTree>
-    <p:extLst>
-      <p:ext uri="{BB962C8B-B14F-4D97-AF65-F5344CB8AC3E}">
-        <p14:creationId xmlns:p14="http://schemas.microsoft.com/office/powerpoint/2010/main" val="1340430692"/>
-      </p:ext>
-    </p:extLst>
   </p:cSld>
   <p:clrMapOvr>
     <a:masterClrMapping/>
@@ -10420,7 +10399,10 @@
       </a:bgFillStyleLst>
     </a:fmtScheme>
   </a:themeElements>
-  <a:objectDefaults/>
-  <a:extraClrSchemeLst/>
+  <a:extLst>
+    <a:ext uri="{05A4C25C-085E-4340-85A3-A5531E510DB2}">
+      <thm15:themeFamily xmlns:thm15="http://schemas.microsoft.com/office/thememl/2012/main" name="Office Theme" id="{62F939B6-93AF-4DB8-9C6B-D6C7DFDC589F}" vid="{4A3C46E8-61CC-4603-A589-7422A47A8E4A}"/>
+    </a:ext>
+  </a:extLst>
 </a:theme>
 </file>
</xml_diff>